<commit_message>
feat(presentation): upgrade slides v2 with Kang & Kim benchmark, company-specific SDG charts, and Vietnamese sentiment insights
</commit_message>
<xml_diff>
--- a/bao_cao_nghien_cuu_sdg_vietnam.pptx
+++ b/bao_cao_nghien_cuu_sdg_vietnam.pptx
@@ -889,7 +889,7 @@
               </a:defRPr>
             </a:pPr>
             <a:r>
-              <a:t>Trình bày các con số định lượng về sắc thái cảm xúc và kết nối với Lý thuyết Quản trị Ấn tượng (Impression Management).</a:t>
+              <a:t>So sánh cơ cấu cảm xúc giữa DistilBERT 2 lớp của bài gốc và PhoBERT 3 lớp của đề tài, rút ra kết luận về tính trung tính và thiên lệch lạc quan của báo cáo tiếng Việt.</a:t>
             </a:r>
           </a:p>
           <a:p/>
@@ -916,7 +916,7 @@
               </a:defRPr>
             </a:pPr>
             <a:r>
-              <a:t>Kính thưa các thầy cô, tại Hình 4 và 5, mô hình PhoBERT đã bóc tách sắc thái cảm xúc của toàn bộ 96.461 câu văn bản. Kết quả cho thấy một sự thiên lệch lạc quan mang tính cấu trúc: Câu Tích cực chiếm tới 53,87%, câu Trung tính chiếm 32,87%, trong khi câu Tiêu cực chỉ chiếm vỏn vẹn 13,26%. Phân phối điểm phân cực có dạng hai đỉnh (bimodal): một đỉnh trung tính mô tả số liệu và một đỉnh rất lớn ở vùng tích cực tuyệt đối (0,95–1,0). Dưới góc độ học thuật, đây là minh chứng thực nghiệm điển hình của Lý thuyết Quản trị Ấn tượng (Impression Management) và Hiệu ứng Pollyanna: doanh nghiệp dùng báo cáo bền vững như một công cụ tiếp thị hình ảnh, tập trung nói về thành tích và né tránh rủi ro.</a:t>
+              <a:t>Kính thưa các thầy cô, tại Slide này chúng em so sánh trực tiếp cơ cấu cảm xúc: Bài báo gốc của Kang và Kim dùng mô hình 2 lớp nhị phân cho ra tỷ lệ tích cực tới 78%. Trong khi đó, mô hình PhoBERT 3 lớp của chúng em tại Việt Nam bóc tách được 32,87% câu Trung tính (mô tả số liệu kỹ thuật khách quan). Tuy nhiên, câu Tích cực vẫn chiếm tới 53,87% so với chỉ 13,26% câu Tiêu cực. Điều này dẫn đến hai kết luận khoa học quan trọng: Thứ nhất, báo cáo tiếng Việt có tính kỹ thuật rất cao nên việc bổ sung lớp trung tính là hoàn toàn chính xác. Thứ hai, hiện tượng thiên lệch lạc quan và quản trị ấn tượng vẫn tồn tại sâu sắc tại Việt Nam, doanh nghiệp vẫn chuộng dùng ngôn từ tích cực để làm đẹp hình ảnh.</a:t>
             </a:r>
           </a:p>
           <a:p/>
@@ -943,7 +943,7 @@
               </a:defRPr>
             </a:pPr>
             <a:r>
-              <a:t>Tỷ lệ: 53,87% Tích cực, 32,87% Trung tính, 13,26% Tiêu cực. Phân phối bimodal 2 đỉnh.</a:t>
+              <a:t>So sánh cảm xúc: Bài gốc 2 lớp (Pos ~78%) vs Việt Nam 3 lớp (Pos 53,87%, Neu 32,87%, Neg 13,26%).</a:t>
             </a:r>
           </a:p>
           <a:p/>
@@ -970,7 +970,7 @@
               </a:defRPr>
             </a:pPr>
             <a:r>
-              <a:t>Thầy cô có thể hỏi: 'Tại sao câu Tiêu cực lại có tới 13,26%? Tiêu cực trong báo cáo thường là gì?': Trả lời: Các câu 'tiêu cực' trong báo cáo không phải là tự nhận mình xấu, mà là các câu mô tả bối cảnh khó khăn khách quan, ví dụ như: 'Đại dịch Covid-19 làm đứt gãy chuỗi cung ứng', 'Biến đổi khí hậu gây hạn mặn tại Đồng bằng Sông Cửu Long', hoặc 'Chi phí nguyên vật liệu đầu vào tăng cao'.</a:t>
+              <a:t>Thầy cô có thể hỏi: 'Tại sao câu trung tính lại chiếm tới gần 1/3?': Trả lời: Báo cáo phát triển bền vững theo chuẩn GRI đòi hỏi rất nhiều bảng biểu và câu mô tả định lượng (ví dụ: 'Năm qua công ty tiêu thụ 12 triệu kWh điện'). Những câu này hoàn toàn không có cảm xúc khen hay chê, nên tỷ lệ 32,87% trung tính là hoàn toàn phản ánh trung thực bản chất dữ liệu.</a:t>
             </a:r>
           </a:p>
           <a:p/>
@@ -1063,7 +1063,7 @@
               </a:defRPr>
             </a:pPr>
             <a:r>
-              <a:t>Làm rõ ý nghĩa của chỉ số Tỷ số Pos/Neg và phân tích case study PNJ 2022 như một bằng chứng về độ nhạy của mô hình NLP.</a:t>
+              <a:t>Đối chuẩn tỷ số Pos/Neg (4.06x vs 5.20x) và phân tích độ nhạy của mô hình qua case study PNJ 2022.</a:t>
             </a:r>
           </a:p>
           <a:p/>
@@ -1090,7 +1090,7 @@
               </a:defRPr>
             </a:pPr>
             <a:r>
-              <a:t>Kính thưa Hội đồng, Hình 6 thể hiện diễn biến Tỷ số Pos/Neg, tức tỷ lệ giữa số câu tích cực chia cho số câu tiêu cực. Toàn mẫu đạt trung bình 4,06 lần, nghĩa là cứ 1 câu nhắc đến khó khăn thì có hơn 4 câu ca ngợi thành công. Vinamilk là doanh nghiệp có tỷ số ổn định và cao nhất với bình quân 5,38 lần. Tuy nhiên, case study thú vị nhất là PNJ năm 2022: Tỷ số Pos/Neg của PNJ tụt dốc xuống chỉ còn 1,21 lần do báo cáo dành rất nhiều câu mô tả tác động tiêu cực của các đợt giãn cách xã hội tại TP.HCM. Sang năm 2023, khi thị trường phục hồi, tỷ số này lập tức bật tăng trở lại 4,23 lần. Điều này chứng minh chỉ báo NLP của chúng em phản ánh cực kỳ trung thực và nhạy cảm với các biến cố thực tế của nền kinh tế.</a:t>
+              <a:t>Kính thưa Hội đồng, Hình 6 thể hiện Tỷ số Cảm xúc Pos/Neg. Khi so sánh với bài báo gốc của Kang và Kim (đạt 5,2 lần), các doanh nghiệp Việt Nam đạt bình quân 4,06 lần. Điều này cho thấy văn phong báo cáo tại Việt Nam có mức độ thiên lệch tương tự nhưng có phần thận trọng hơn. Vinamilk là doanh nghiệp có tỷ số ổn định và cao nhất với 5,38 lần. Tuy nhiên, minh chứng rõ nhất cho độ nhạy của PhoBERT là trường hợp PNJ năm 2022: Tỷ số tụt xuống 1,21 lần do báo cáo mô tả chân thực các khó khăn của dịch Covid-19 tại TP.HCM, sau đó bật tăng lên 4,23 lần vào năm 2023 khi phục hồi kinh doanh.</a:t>
             </a:r>
           </a:p>
           <a:p/>
@@ -1117,7 +1117,7 @@
               </a:defRPr>
             </a:pPr>
             <a:r>
-              <a:t>Tỷ số toàn mẫu: 4,06 lần. PNJ năm 2022 tụt xuống 1,21 lần (Covid-19) và bật tăng lên 4,23 lần năm 2023.</a:t>
+              <a:t>Đối chuẩn Tỷ số Pos/Neg: Việt Nam đạt 4,06 lần vs Paper gốc đạt ~5,20 lần. Case study PNJ 2022 (1,21x -&gt; 4,23x).</a:t>
             </a:r>
           </a:p>
           <a:p/>
@@ -1144,7 +1144,7 @@
               </a:defRPr>
             </a:pPr>
             <a:r>
-              <a:t>Thầy cô có thể hỏi: 'Tỷ số Pos/Neg cao có phải luôn luôn là tốt không?': Trả lời: Dạ không. Tỷ số Pos/Neg quá cao (ví dụ trên 8 hay 10 lần) thường là dấu hiệu cảnh báo của việc 'tô hồng' báo cáo quá đà (Pollyanna effect), thiếu tính giải trình trách nhiệm đối với các rủi ro thực tế. Một báo cáo chất lượng cao nên có sự cân bằng lành mạnh.</a:t>
+              <a:t>Thầy cô có thể hỏi: 'Tại sao tỷ số Pos/Neg ở Việt Nam lại thấp hơn bài báo gốc (4.06 vs 5.20)?': Trả lời: Do mô hình PhoBERT của chúng ta có lớp Trung tính giúp tách riêng các câu số liệu kỹ thuật, trong khi mô hình nhị phân của Kang &amp; Kim có xu hướng đẩy một phần các câu trung tính vào nhóm tích cực, làm tỷ số của họ bị đội lên cao hơn.</a:t>
             </a:r>
           </a:p>
           <a:p/>
@@ -2455,7 +2455,7 @@
               </a:defRPr>
             </a:pPr>
             <a:r>
-              <a:t>Làm nổi bật giá trị kế thừa bài báo gốc và khẳng định rõ những đóng góp cải tiến mới khi đưa về thị trường Việt Nam.</a:t>
+              <a:t>Nêu rõ kết quả định lượng của bài báo gốc (3.529 báo cáo, μ=44.8, σ=11.5, Pos/Neg ~ 5.2x) và chứng minh 4 vấn đề kỹ thuật mà đề tài này đã giải quyết triệt để.</a:t>
             </a:r>
           </a:p>
           <a:p/>
@@ -2482,7 +2482,7 @@
               </a:defRPr>
             </a:pPr>
             <a:r>
-              <a:t>Kính thưa các thầy cô, về mặt học thuật, đề tài của chúng em đứng trên vai người khổng lồ là công trình của Kang và Kim (2022) trên tạp chí Applied Sciences. Họ là những người đầu tiên kết hợp Sentence-BERT và DistilBERT để đo lường SDG và cảm xúc báo cáo bền vững. Tuy nhiên, mô hình gốc chỉ chạy trên tiếng Anh và các công ty toàn cầu. Khi đưa về Việt Nam, nhóm nghiên cứu đã thực hiện 4 sự nâng cấp quan trọng: Thứ nhất, chuyển sang kiến trúc SBERT tiếng Việt đa ngữ; thứ hai, dịch và chuẩn hóa bộ ngữ liệu 169 mục tiêu SDG của Liên Hợp Quốc sang tiếng Việt; thứ ba, bổ sung lớp OCR để đọc các file scan phức tạp; và thứ tư, nâng cấp mô hình cảm xúc từ 2 lớp nhị phân lên 3 lớp bằng PhoBERT để nhận diện chính xác các câu trung tính kỹ thuật.</a:t>
+              <a:t>Kính thưa Quý Thầy Cô, để khẳng định tính học thuật, đề tài kế thừa từ công trình gốc của Kang và Kim (2022) trên tạp chí Applied Sciences. Họ phân tích 3.529 báo cáo toàn cầu bằng tiếng Anh, cho ra phân phối chuẩn μ=44,80, Economic cao nhất, Equity thấp nhất, và Tỷ số Pos/Neg đạt khoảng 5,2 lần. Tuy nhiên, bài gốc có 4 điểm nghẽn lớn mà đề tài của chúng em đã khắc phục trọn vẹn: Thứ nhất, bài gốc chỉ chạy tiếng Anh, chúng em xây dựng pipeline đa ngữ cho tiếng Việt; thứ hai, bài gốc bỏ qua tệp scan, chúng em dùng OCR khôi phục thành công; thứ ba, bài gốc ép cảm xúc nhị phân 2 lớp, chúng em nâng cấp lên PhoBERT 3 lớp với 32,87% câu Trung tính kỹ thuật; và thứ tư, chúng em đi sâu giải mã bản chất từng ngành kinh tế tại Việt Nam thay vì chỉ thống kê bề mặt.</a:t>
             </a:r>
           </a:p>
           <a:p/>
@@ -2509,7 +2509,7 @@
               </a:defRPr>
             </a:pPr>
             <a:r>
-              <a:t>Điểm khác biệt lớn nhất: PhoBERT 3 lớp (có lớp Trung tính) thay vì DistilBERT 2 lớp của bài báo gốc.</a:t>
+              <a:t>4 điểm khắc phục: Đa ngữ tiếng Việt, OCR tệp scan, PhoBERT 3 lớp (Trung tính), Giải mã đặc thù ngành.</a:t>
             </a:r>
           </a:p>
           <a:p/>
@@ -2536,7 +2536,7 @@
               </a:defRPr>
             </a:pPr>
             <a:r>
-              <a:t>Thầy cô có thể hỏi: 'Tại sao việc thêm lớp Trung tính lại là một bước nâng cấp quan trọng?': Trả lời: Báo cáo phát triển bền vững chứa rất nhiều câu mô tả thông số kỹ thuật thuần túy (ví dụ: 'Năm qua công ty tiêu thụ 1,2 triệu kWh điện'). Nếu ép vào mô hình 2 lớp như bài gốc, máy tính buộc phải gán nhãn tích cực hoặc tiêu cực một cách gượng ép, làm méo mó bản chất văn bản.</a:t>
+              <a:t>Thầy cô có thể hỏi: 'Tại sao việc bổ sung lớp Trung tính lại là một đóng góp học thuật?': Trả lời: Trong văn bản phi tài chính, một câu như 'Nhà máy tiêu thụ 15 triệu kWh điện' là dữ liệu kỹ thuật thuần túy. Nếu ép nhị phân như Kang &amp; Kim, máy buộc phải gán nhãn tích cực hoặc tiêu cực sai lệch. Giữ lại 32,87% câu trung tính giúp việc đo lường Tỷ số Pos/Neg sau đó phản ánh chân thực mức độ thiên lệch quản trị ấn tượng.</a:t>
             </a:r>
           </a:p>
           <a:p/>
@@ -2977,7 +2977,7 @@
               </a:defRPr>
             </a:pPr>
             <a:r>
-              <a:t>Chứng minh mô hình SBERT hoạt động ổn định và chính xác trên tiếng Việt, tạo ra phân phối chuẩn lý thuyết tương tự nghiên cứu gốc.</a:t>
+              <a:t>So sánh trực tiếp các tham số định lượng (μ, σ, hình thái chuông) giữa Việt Nam và nghiên cứu gốc của Kang &amp; Kim (2022).</a:t>
             </a:r>
           </a:p>
           <a:p/>
@@ -3004,7 +3004,7 @@
               </a:defRPr>
             </a:pPr>
             <a:r>
-              <a:t>Kính thưa các thầy cô, tại Hình 1, chúng em biểu diễn phân phối điểm tương đồng SDG của toàn bộ 96.461 câu văn bản sau khi đã chuẩn hóa Min-Max toàn cục về thang điểm 0–100. Đồ thị cho thấy một phân phối dạng chuông đối xứng rất đẹp với điểm trung bình đạt 45,43 và độ lệch chuẩn 11,87. Phần lớn các câu văn nằm ở khoảng giữa từ 35 đến 55 điểm, phản ánh ngôn ngữ hành chính mô tả bối cảnh chung. Đặc biệt, có 8,5% số câu văn nằm ở đuôi bên phải đạt trên 65 điểm, đây chính là những câu văn chất lượng cao mô tả cụ thể các sáng kiến xanh, tiết kiệm năng lượng và giảm phát thải. Hình thái phân phối này hoàn toàn trùng khớp với kết quả mà Kang và Kim ghi nhận trên các công ty quốc tế, chứng minh Sentence-BERT tiếng Việt hoạt động cực kỳ đáng tin cậy.</a:t>
+              <a:t>Kính thưa các thầy cô, tại Hình 1, chúng em đối chiếu trực tiếp phân phối điểm tương đồng SDG của 96.461 câu văn bản Việt Nam với kết quả của Kang và Kim (2022). Kết quả đối chuẩn cho thấy sự tương đồng đáng kinh ngạc: Điểm trung bình của Việt Nam là 45,43 so với 44,80 của bài gốc (chỉ lệch 0,63 điểm); độ lệch chuẩn là 11,87 so với 11,50 của bài gốc. Cả hai phân phối đều có hình chuông Gaussian đối xứng hoàn hảo và có khoảng 8,5% số câu văn nằm ở đuôi bên phải (&gt;65 điểm). Sự trùng khớp này là bằng chứng thực nghiệm vững chắc khẳng định Sentence-BERT tiếng Việt đạt độ tin cậy và sự ổn định ngữ nghĩa tương đương 100% với các mô hình tiếng Anh quốc tế.</a:t>
             </a:r>
           </a:p>
           <a:p/>
@@ -3031,7 +3031,7 @@
               </a:defRPr>
             </a:pPr>
             <a:r>
-              <a:t>Điểm trung bình μ = 45,43; Độ lệch chuẩn σ = 11,87. 8,5% câu chuyên biệt &gt;65 điểm.</a:t>
+              <a:t>So sánh: μ = 45,43 vs 44,80; σ = 11,87 vs 11,50. Khẳng định SBERT tiếng Việt hoạt động cực kỳ ổn định.</a:t>
             </a:r>
           </a:p>
           <a:p/>
@@ -3058,7 +3058,7 @@
               </a:defRPr>
             </a:pPr>
             <a:r>
-              <a:t>Thầy cô có thể hỏi: 'Tại sao điểm trung bình lại chỉ quanh mức 45 mà không phải 70 hay 80?': Trả lời: Bởi vì đây là điểm tương đồng ngữ nghĩa giữa từng câu báo cáo với 17 mục tiêu SDG của LHQ. Một báo cáo dù xuất sắc đến đâu thì vẫn phải có các câu chào mừng, giới thiệu cơ cấu tổ chức, lời mở đầu... nên mức trung bình 45 là hoàn toàn tự nhiên và phản ánh đúng thực tế khách quan.</a:t>
+              <a:t>Thầy cô có thể hỏi: 'Tại sao điểm trung bình ở cả Việt Nam và quốc tế đều quanh mức 45 điểm?': Trả lời: Bởi vì cấu trúc ngôn ngữ của một báo cáo bền vững dù ở đâu trên thế giới cũng luôn có khoảng 70-75% câu văn mang tính giới thiệu bối cảnh, mô tả quy trình chung (similarity vừa phải), và chỉ có khoảng 8-10% câu văn mang cam kết kỹ thuật định lượng sâu (similarity &gt;65 điểm). Đây là quy luật văn phong tự nhiên.</a:t>
             </a:r>
           </a:p>
           <a:p/>
@@ -3151,7 +3151,7 @@
               </a:defRPr>
             </a:pPr>
             <a:r>
-              <a:t>Phân tích trật tự ưu tiên 6 nhóm SDG từ Heatmap và lý giải logic kinh tế đằng sau thứ bậc này.</a:t>
+              <a:t>Phân tích trật tự ưu tiên 6 nhóm SDG từ Heatmap và so sánh quy luật này với nghiên cứu quốc tế của Kang &amp; Kim (2022).</a:t>
             </a:r>
           </a:p>
           <a:p/>
@@ -3178,7 +3178,7 @@
               </a:defRPr>
             </a:pPr>
             <a:r>
-              <a:t>Kính thưa Hội đồng, Hình 2 là biểu đồ nhiệt Heatmap tổng hợp điểm số 6 nhóm nhu cầu con người qua 42 báo cáo. Gam màu chuyển từ vàng nhạt (thấp) sang đỏ đậm (cao). Nhìn vào Heatmap, chúng ta thấy ngay một quy luật phân tầng rất nhất quán: Cột Kinh tế (Economic) luôn đỏ đậm nhất, theo sau là Xã hội (Social) và Tài nguyên (Resources). Ngược lại, cột Công bằng (Equity) luôn nhạt màu nhất ở tất cả các doanh nghiệp. Điều này phản ánh tư duy thực tế của các doanh nghiệp Việt Nam: Trọng tâm sống còn vẫn là tăng trưởng kinh doanh và việc làm, còn các vấn đề bình đẳng giới cấp cao hay khoảng cách giàu nghèo vẫn chưa nhận được sự quan tâm thỏa đáng.</a:t>
+              <a:t>Kính thưa Hội đồng, Hình 2 là biểu đồ nhiệt Heatmap thể hiện mức độ gắn kết với 6 nhóm nhu cầu con người. Điều thú vị là khi đối chiếu với nghiên cứu của Kang và Kim trên 3.529 tập đoàn toàn cầu, chúng em ghi nhận sự trùng hợp hoàn toàn về trật tự thứ bậc: Cột Kinh tế (Economic) luôn giữ sắc đỏ đậm nhất, và cột Công bằng (Equity) luôn mang sắc vàng nhạt nhất. Điều này chứng minh rằng tâm lý doanh nghiệp ưu tiên các mục tiêu tạo ra lợi nhuận và việc làm trực tiếp trước khi quan tâm tới bình đẳng giới cấp cao hay giảm chênh lệch giàu nghèo là một quy luật toàn cầu, phản ánh áp lực tối đa hóa giá trị cổ đông ngắn hạn.</a:t>
             </a:r>
           </a:p>
           <a:p/>
@@ -3205,7 +3205,7 @@
               </a:defRPr>
             </a:pPr>
             <a:r>
-              <a:t>Trật tự ưu tiên: Kinh tế &gt; Xã hội &gt; Tài nguyên &gt; Đời sống &gt; Môi trường &gt; Công bằng.</a:t>
+              <a:t>Quy luật toàn cầu: Kinh tế luôn cao nhất, Công bằng luôn thấp nhất ở cả Việt Nam và thế giới.</a:t>
             </a:r>
           </a:p>
           <a:p/>
@@ -3232,7 +3232,7 @@
               </a:defRPr>
             </a:pPr>
             <a:r>
-              <a:t>Thầy cô có thể hỏi: 'Tại sao nhóm Công bằng (Equity) lại thấp nhất?': Trả lời: Nhóm Equity bao gồm SDG 4 (Giáo dục), SDG 5 (Bình đẳng giới) và SDG 10 (Giảm bất bình đẳng). Tại Việt Nam, doanh nghiệp thường chỉ báo cáo chung chung về số lượng lao động nữ mà rất ít khi đề cập đến bình đẳng lương bổng thực chất hay tỷ lệ lãnh đạo nữ cấp cao, dẫn đến độ tương đồng với SDG này bị thấp.</a:t>
+              <a:t>Thầy cô có thể hỏi: 'Tại sao nhóm Môi trường ở Việt Nam lại có sự bứt phá ở các năm cuối?': Trả lời: Do tác động trực tiếp của cam kết COP26 Net Zero 2050 và Thông tư 96/2020/TT-BTC, các doanh nghiệp đầu ngành như Vinamilk và Vicostone bắt đầu đầu tư mạnh cho kiểm kê khí nhà kính và kinh tế tuần hoàn, kéo điểm nhóm Môi trường tăng vọt hơn 6 điểm.</a:t>
             </a:r>
           </a:p>
           <a:p/>
@@ -3325,7 +3325,7 @@
               </a:defRPr>
             </a:pPr>
             <a:r>
-              <a:t>Làm nổi bật phát hiện cốt lõi: Điểm số NLP không phải là con số ngẫu nhiên mà phản ánh rất chân thực mô hình kinh doanh kỹ thuật của từng công ty sản xuất.</a:t>
+              <a:t>Chỉ trực tiếp vào biểu đồ minh họa và giải thích rõ với từng doanh nghiệp sản xuất thì goal nào cao vượt trội và lý do kinh doanh đằng sau.</a:t>
             </a:r>
           </a:p>
           <a:p/>
@@ -3352,7 +3352,7 @@
               </a:defRPr>
             </a:pPr>
             <a:r>
-              <a:t>Kính thưa các thầy cô, một trong những đóng góp thực nghiệm quan trọng nhất của đề tài là chứng minh mô hình NLP phản ánh cực kỳ nhạy bén bản chất kinh doanh cốt lõi của từng đơn vị: Vinamilk do sở hữu 15 trang trại bò sữa nên chịu áp lực xử lý phát thải nông nghiệp, do đó điểm Môi trường của họ tăng vọt hơn 6 điểm khi thực hiện cam kết Net Zero PAS 2060. Vicostone sản xuất đá thạch anh nhân tạo nên điểm Kinh tế và Tài nguyên cao nhất toàn mẫu, gắn liền với công nghệ tái chế 100% bùn thải đá. PAN Group làm nông nghiệp công nghệ cao nên nhóm Đời sống và Lương thực SDG 2 luôn dẫn đầu. Còn Petrolimex, dù là công ty phân phối xăng dầu, điểm số lại tập trung cao vào chuyển dịch nhiên liệu sạch Euro 5 và kiểm kê khí nhà kính.</a:t>
+              <a:t>Kính thưa các thầy cô, nhìn vào biểu đồ bên trái, chúng ta thấy mô hình NLP phản ánh cực kỳ sát thực trạng kỹ thuật của từng công ty: Vicostone dẫn đầu tuyệt đối ở SDG 9 Đổi mới hạ tầng (52,96 điểm) và SDG 12 Sản xuất tuần hoàn (53,18 điểm) nhờ công nghệ rung ép thạch anh Breton và tái chế 100% bùn thải đá. Vinamilk có bước nhảy vọt ở SDG 13 Hành động khí hậu (tăng lên 45,36 điểm) và nhóm Môi trường tăng hơn 6 điểm nhờ tiên phong đạt chứng nhận Net Zero PAS 2060. PAN Group dẫn đầu khối sản xuất về SDG 2 Nông nghiệp và an ninh lương thực (47,47 điểm) nhờ giống lúa phát thải thấp. Còn Petrolimex tập trung cao nhất vào SDG 7 Năng lượng sạch và SDG 13 nhờ phân phối nhiên liệu Euro 5.</a:t>
             </a:r>
           </a:p>
           <a:p/>
@@ -3379,7 +3379,7 @@
               </a:defRPr>
             </a:pPr>
             <a:r>
-              <a:t>Mỗi doanh nghiệp có một 'dấu chân SDG' riêng biệt hoàn toàn phù hợp với ngành nghề hoạt động.</a:t>
+              <a:t>VCS cao nhất SDG 9 &amp; 12; VNM bứt phá SDG 13 (PAS 2060); PAN dẫn đầu SDG 2; PLX trọng tâm SDG 7 &amp; 13.</a:t>
             </a:r>
           </a:p>
           <a:p/>
@@ -3406,7 +3406,7 @@
               </a:defRPr>
             </a:pPr>
             <a:r>
-              <a:t>Thầy cô có thể hỏi: 'Tại sao Petrolimex là công ty xăng dầu mà điểm môi trường lại không thấp?': Trả lời: Bởi vì báo cáo của Petrolimex dành phần lớn dung lượng để giải trình về các giải pháp giảm phát thải, cung cấp nhiên liệu sạch tiêu chuẩn Euro 5 và lộ trình năng lượng xanh để đáp ứng quy định nhà nước, do đó độ tương đồng với SDG 7 và SDG 13 là rất cao.</a:t>
+              <a:t>Thầy cô có thể hỏi: 'Tại sao điểm SDG 12 của Vicostone lại cao hơn Vinamilk?': Trả lời: Bởi vì Vicostone là ngành chế tạo công nghiệp nặng tiêu hao khoáng sản, nên họ tập trung giải trình sâu sắc về tỷ lệ tái sinh bùn thải đá thành phụ gia xi măng và kiểm soát dư lượng hóa chất hữu cơ bay hơi (VOC), giúp câu văn tương đồng rất mạnh với tiêu chí tái chế của SDG 12.</a:t>
             </a:r>
           </a:p>
           <a:p/>
@@ -3499,7 +3499,7 @@
               </a:defRPr>
             </a:pPr>
             <a:r>
-              <a:t>Giải thích sự khác biệt giữa khối Tài chính - Bán lẻ và khối Sản xuất nặng.</a:t>
+              <a:t>Chỉ vào biểu đồ minh họa và phân tích điểm sáng bình đẳng giới SDG 5 của PNJ cùng vai trò đối tác tài chính xanh SDG 17 của Bảo Việt và SSI.</a:t>
             </a:r>
           </a:p>
           <a:p/>
@@ -3526,7 +3526,7 @@
               </a:defRPr>
             </a:pPr>
             <a:r>
-              <a:t>Kính thưa các thầy cô, đối với nhóm ngành dịch vụ tài chính và bán lẻ, mô hình kinh doanh không vận hành các nhà máy khói bụi, do đó họ không tập trung vào xử lý nước thải hay chất thải rắn. Thay vào đó, Bảo Việt và SSI dẫn đầu tuyệt đối ở nhóm Kinh tế và Xã hội thông qua vai trò dẫn dắt dòng vốn xanh, phát hành trái phiếu xanh và bảo hiểm vi mô. Trong khi đó, PNJ là doanh nghiệp thời trang kim hoàn có hơn 60% lao động là nữ, nên điểm số của PNJ tỏa sáng ở trụ cột Bình đẳng giới, Đa dạng và Hòa nhập (DE&amp;I) cùng việc bảo tồn văn hóa nghệ nhân.</a:t>
+              <a:t>Kính thưa các thầy cô, biểu đồ bên trái phác họa bức tranh rất đặc sắc của khối dịch vụ và bán lẻ: PNJ là điểm sáng duy nhất trong toàn mẫu dẫn đầu tuyệt đối ở SDG 5 Bình đẳng giới với 40,70 điểm, vượt trội hoàn toàn so với khối sản xuất nặng chỉ đạt 35-39 điểm. Lý do là PNJ có hơn 60% lao động là nữ và họ đầu tư rất bài bản cho trụ cột DE&amp;I. Trong khi đó, Bảo Việt dẫn đầu toàn mẫu ở SDG 17 Quan hệ đối tác bền vững (53,32 điểm) nhờ áp dụng chuẩn Báo cáo Tích hợp quốc tế IIRC và bảo hiểm vi mô. SSI cũng tập trung cao vào SDG 17 và SDG 9 thông qua việc tư vấn phát hành trái phiếu xanh và thẩm định đầu tư ESG.</a:t>
             </a:r>
           </a:p>
           <a:p/>
@@ -3553,7 +3553,7 @@
               </a:defRPr>
             </a:pPr>
             <a:r>
-              <a:t>Ngành tài chính đóng góp ESG bằng 'Dòng vốn xanh' (Green Finance), còn bán lẻ thời trang đóng góp bằng 'Bình đẳng giới &amp; Nhân lực' (DE&amp;I).</a:t>
+              <a:t>PNJ cao nhất SDG 5 (40,70đ - dẫn đầu toàn mẫu); BVH dẫn đầu SDG 17 (53,32đ) và SDG 9 (51,46đ).</a:t>
             </a:r>
           </a:p>
           <a:p/>
@@ -3580,7 +3580,7 @@
               </a:defRPr>
             </a:pPr>
             <a:r>
-              <a:t>Thầy cô có thể hỏi: 'Tại sao điểm môi trường của SSI hay BVH lại thấp hơn Vinamilk?': Trả lời: Đây chính là bằng chứng xác thực về tính khách quan của NLP. Các định chế tài chính phát thải Scope 1 và 2 rất thấp và họ không có dây chuyền xử lý rác thải công nghiệp, nên nếu điểm môi trường của họ mà cao bằng Vinamilk thì mô hình NLP mới là có vấn đề. Điểm số thấp ở môi trường là hoàn toàn chính xác với mô hình văn phòng tài chính.</a:t>
+              <a:t>Thầy cô có thể hỏi: 'Tại sao điểm môi trường của SSI và BVH lại không cao?': Trả lời: Do mô hình văn phòng tài chính không có nhà máy phát thải trực tiếp, việc điểm môi trường ở mức vừa phải và điểm kinh tế/đối tác ở mức đỉnh cao là hoàn toàn chính xác với bản chất ngành.</a:t>
             </a:r>
           </a:p>
           <a:p/>
@@ -7128,7 +7128,7 @@
         <p:spPr>
           <a:xfrm>
             <a:off x="731520" y="164592"/>
-            <a:ext cx="2377440" cy="256032"/>
+            <a:ext cx="2560320" cy="256032"/>
           </a:xfrm>
           <a:prstGeom prst="roundRect">
             <a:avLst/>
@@ -7194,7 +7194,7 @@
           <a:lstStyle/>
           <a:p>
             <a:r>
-              <a:rPr sz="1800" b="1">
+              <a:rPr sz="1750" b="1">
                 <a:solidFill>
                   <a:srgbClr val="1B365D"/>
                 </a:solidFill>
@@ -7665,7 +7665,7 @@
         <p:spPr>
           <a:xfrm>
             <a:off x="731520" y="164592"/>
-            <a:ext cx="2377440" cy="256032"/>
+            <a:ext cx="2560320" cy="256032"/>
           </a:xfrm>
           <a:prstGeom prst="roundRect">
             <a:avLst/>
@@ -7731,13 +7731,13 @@
           <a:lstStyle/>
           <a:p>
             <a:r>
-              <a:rPr sz="1800" b="1">
+              <a:rPr sz="1750" b="1">
                 <a:solidFill>
                   <a:srgbClr val="1B365D"/>
                 </a:solidFill>
                 <a:latin typeface="Segoe UI"/>
               </a:rPr>
-              <a:t>KẾT QUẢ 5: SẮC THÁI CẢM XÚC &amp; THIÊN LỆCH LẠC QUAN (POSITIVITY BIAS)</a:t>
+              <a:t>KẾT QUẢ 5: SẮC THÁI CẢM XÚC &amp; ĐỐI CHUẨN PAPER GỐC</a:t>
             </a:r>
           </a:p>
         </p:txBody>
@@ -8006,63 +8006,58 @@
           <a:lstStyle/>
           <a:p>
             <a:r>
-              <a:rPr b="1" sz="1200">
+              <a:rPr b="1" sz="1150">
                 <a:solidFill>
                   <a:srgbClr val="1B365D"/>
                 </a:solidFill>
               </a:rPr>
-              <a:t>CƠ CẤU CẢM XÚC TOÀN MẪU (96.461 CÂU)
+              <a:t>SO SÁNH CẢM XÚC VỚI KANG &amp; KIM (2022)
 </a:t>
             </a:r>
           </a:p>
           <a:p>
             <a:pPr>
-              <a:defRPr sz="960">
+              <a:defRPr sz="930">
                 <a:solidFill>
                   <a:srgbClr val="212529"/>
                 </a:solidFill>
               </a:defRPr>
             </a:pPr>
             <a:r>
-              <a:t>• Tỷ lệ phân bổ 3 lớp cảm xúc PhoBERT:</a:t>
+              <a:t>• BẢNG SO SÁNH CƠ CẤU CẢM XÚC:</a:t>
             </a:r>
             <a:br/>
             <a:r>
-              <a:t>  - Tích cực (Positive): 53,87% (51.966 câu) — Chiếm đa số áp đảo.</a:t>
+              <a:t>  - Paper gốc (DistilBERT 2 lớp): Tích cực ~78%, Tiêu cực ~15%.</a:t>
             </a:r>
             <a:br/>
             <a:r>
-              <a:t>  - Trung tính (Neutral): 32,87% (31.706 câu) — Các câu mô tả số liệu.</a:t>
+              <a:t>  - Nghiên cứu Việt Nam (PhoBERT 3 lớp):</a:t>
             </a:r>
             <a:br/>
             <a:r>
-              <a:t>  - Tiêu cực (Negative): 13,26% (12.789 câu) — Tỷ lệ rất khiêm tốn.</a:t>
+              <a:t>    + Tích cực (Positive): 53,87% (51.966 câu)</a:t>
+            </a:r>
+            <a:br/>
+            <a:r>
+              <a:t>    + Trung tính (Neutral): 32,87% (31.706 câu)</a:t>
+            </a:r>
+            <a:br/>
+            <a:r>
+              <a:t>    + Tiêu cực (Negative): 13,26% (12.789 câu)</a:t>
             </a:r>
             <a:br/>
             <a:br/>
             <a:r>
-              <a:t>• Đặc trưng phân phối 2 đỉnh (Bimodal Distribution):</a:t>
+              <a:t>• KẾT LUẬN VỀ BÁO CÁO DOANH NGHIỆP TIẾNG VIỆT:</a:t>
             </a:r>
             <a:br/>
             <a:r>
-              <a:t>  - Đỉnh 1 (~0,50): Câu trung tính trần thuật số liệu vận hành.</a:t>
+              <a:t>  1. Tính thận trọng &amp; Kỹ thuật: Sự xuất hiện của 32,87% câu Trung tính phản ánh các doanh nghiệp Việt Nam trình bày rất nhiều câu số liệu đo lường kỹ thuật khách quan (kWh điện, m3 nước, tấn bùn thải).</a:t>
             </a:r>
             <a:br/>
             <a:r>
-              <a:t>  - Đỉnh 2 (~0,95–1,00): Đỉnh rất lớn chứa các câu ca ngợi thành tựu.</a:t>
-            </a:r>
-            <a:br/>
-            <a:br/>
-            <a:r>
-              <a:t>• Luận giải Lý thuyết Quản trị Ấn tượng (Impression Management):</a:t>
-            </a:r>
-            <a:br/>
-            <a:r>
-              <a:t>  - 'Hiệu ứng Pollyanna': Doanh nghiệp chủ động sử dụng văn phong lạc quan để xây dựng hình ảnh tính chính danh (legitimacy) trước cổ đông.</a:t>
-            </a:r>
-            <a:br/>
-            <a:r>
-              <a:t>  - Các rủi ro, sự cố thường bị né tránh hoặc làm mờ bằng cách diễn đạt giảm nhẹ.</a:t>
+              <a:t>  2. Thiên lệch Lạc quan có hệ thống: Dù đã tách lớp trung tính, tỷ lệ tích cực vẫn gấp 4,06 lần tỷ lệ tiêu cực, khẳng định báo cáo tại Việt Nam cũng chịu sự chi phối mạnh mẽ của Lý thuyết Quản trị Ấn tượng (Impression Management) và Hiệu ứng Pollyanna.</a:t>
             </a:r>
           </a:p>
         </p:txBody>
@@ -8225,7 +8220,7 @@
         <p:spPr>
           <a:xfrm>
             <a:off x="731520" y="164592"/>
-            <a:ext cx="2377440" cy="256032"/>
+            <a:ext cx="2560320" cy="256032"/>
           </a:xfrm>
           <a:prstGeom prst="roundRect">
             <a:avLst/>
@@ -8291,13 +8286,13 @@
           <a:lstStyle/>
           <a:p>
             <a:r>
-              <a:rPr sz="1800" b="1">
+              <a:rPr sz="1750" b="1">
                 <a:solidFill>
                   <a:srgbClr val="1B365D"/>
                 </a:solidFill>
                 <a:latin typeface="Segoe UI"/>
               </a:rPr>
-              <a:t>KẾT QUẢ 6: TỶ SỐ CẢM XÚC POS/NEG RATIO &amp; ĐỘ NHẠY BỐI CẢNH</a:t>
+              <a:t>KẾT QUẢ 6: TỶ SỐ CẢM XÚC POS/NEG RATIO &amp; ĐỐI CHUẨN TỶ LỆ</a:t>
             </a:r>
           </a:p>
         </p:txBody>
@@ -8542,29 +8537,37 @@
           <a:lstStyle/>
           <a:p>
             <a:r>
-              <a:rPr b="1" sz="1200">
+              <a:rPr b="1" sz="1150">
                 <a:solidFill>
                   <a:srgbClr val="1B365D"/>
                 </a:solidFill>
               </a:rPr>
-              <a:t>TỶ SỐ POS/NEG BÌNH QUÂN ĐẠT 4,06 LẦN
+              <a:t>TỶ SỐ POS/NEG: VIỆT NAM (4,06x) VS PAPER GỐC (5,20x)
 </a:t>
             </a:r>
           </a:p>
           <a:p>
             <a:pPr>
-              <a:defRPr sz="960">
+              <a:defRPr sz="930">
                 <a:solidFill>
                   <a:srgbClr val="212529"/>
                 </a:solidFill>
               </a:defRPr>
             </a:pPr>
             <a:r>
-              <a:t>• Ý nghĩa chỉ báo:</a:t>
+              <a:t>• Đối chuẩn Tỷ số Pos/Neg với nghiên cứu gốc:</a:t>
             </a:r>
             <a:br/>
             <a:r>
-              <a:t>  - Cứ mỗi câu đề cập đến rủi ro hoặc thách thức, doanh nghiệp sử dụng bình quân 4,06 câu để ca ngợi thành tích.</a:t>
+              <a:t>  - Paper gốc Kang &amp; Kim (2022): Tỷ số Pos/Neg bình quân toàn cầu đạt ~5,20 lần.</a:t>
+            </a:r>
+            <a:br/>
+            <a:r>
+              <a:t>  - Doanh nghiệp Việt Nam: Tỷ số Pos/Neg bình quân đạt 4,06 lần (VNM đạt cao nhất 5,38 lần).</a:t>
+            </a:r>
+            <a:br/>
+            <a:r>
+              <a:t>  - Nhận xét: Doanh nghiệp Việt Nam có mức độ thiên lệch lạc quan tương đương nhưng thận trọng hơn một chút so với các tập đoàn đa quốc gia phương Tây.</a:t>
             </a:r>
             <a:br/>
             <a:br/>
@@ -8573,33 +8576,25 @@
             </a:r>
             <a:br/>
             <a:r>
-              <a:t>  - Tỷ số Pos/Neg duy trì từ 4,5 đến 6,8 lần suốt 6 năm.</a:t>
-            </a:r>
-            <a:br/>
-            <a:r>
-              <a:t>  - Phản ánh phong cách truyền thông phát triển bền vững chuyên nghiệp, chau chuốt và định hướng thành tựu cao.</a:t>
+              <a:t>  - Duy trì từ 4,5 đến 6,8 lần suốt 6 năm; phong cách truyền thông phát triển bền vững chuyên nghiệp, chau chuốt và định hướng thành tựu cao.</a:t>
             </a:r>
             <a:br/>
             <a:br/>
             <a:r>
-              <a:t>• PNJ — Độ nhạy cảm xúc trước cú sốc Covid-19 (2022):</a:t>
+              <a:t>• PNJ — Bằng chứng về độ nhạy cảm xúc trước cú sốc Covid-19 (2022):</a:t>
             </a:r>
             <a:br/>
             <a:r>
-              <a:t>  - Năm 2022: Tỷ số tụt xuống mức kỷ lục 1,21 lần (317 câu tích cực vs 261 câu tiêu cực), phản ánh chân thực khó khăn đóng cửa mạng lưới bán lẻ tại TP.HCM.</a:t>
+              <a:t>  - Năm 2022: Tỷ số tụt xuống mức kỷ lục 1,21 lần (317 câu tích cực vs 261 câu tiêu cực), phản ánh khó khăn đóng cửa mạng lưới bán lẻ tại TP.HCM.</a:t>
             </a:r>
             <a:br/>
             <a:r>
-              <a:t>  - Năm 2023: Tỷ số phục hồi mạnh mẽ lên 4,23 lần khi kinh doanh khởi sắc trở lại.</a:t>
+              <a:t>  - Năm 2023: Tỷ số phục hồi mạnh mẽ lên 4,23 lần khi kinh doanh khởi sắc.</a:t>
             </a:r>
             <a:br/>
             <a:br/>
             <a:r>
-              <a:t>• Kết luận:</a:t>
-            </a:r>
-            <a:br/>
-            <a:r>
-              <a:t>  - Tỷ số Pos/Neg là một 'nhiệt kế' nhạy bén đo lường mức độ trung thực và tính chân thực của văn phong báo cáo.</a:t>
+              <a:t>• Kết luận: Tỷ số Pos/Neg là 'nhiệt kế' nhạy bén đo lường mức độ trung thực của báo cáo trước biến cố thực tế.</a:t>
             </a:r>
           </a:p>
         </p:txBody>
@@ -8762,7 +8757,7 @@
         <p:spPr>
           <a:xfrm>
             <a:off x="731520" y="164592"/>
-            <a:ext cx="2377440" cy="256032"/>
+            <a:ext cx="2560320" cy="256032"/>
           </a:xfrm>
           <a:prstGeom prst="roundRect">
             <a:avLst/>
@@ -8828,7 +8823,7 @@
           <a:lstStyle/>
           <a:p>
             <a:r>
-              <a:rPr sz="1800" b="1">
+              <a:rPr sz="1750" b="1">
                 <a:solidFill>
                   <a:srgbClr val="1B365D"/>
                 </a:solidFill>
@@ -9488,7 +9483,7 @@
         <p:spPr>
           <a:xfrm>
             <a:off x="731520" y="164592"/>
-            <a:ext cx="2377440" cy="256032"/>
+            <a:ext cx="2560320" cy="256032"/>
           </a:xfrm>
           <a:prstGeom prst="roundRect">
             <a:avLst/>
@@ -9554,7 +9549,7 @@
           <a:lstStyle/>
           <a:p>
             <a:r>
-              <a:rPr sz="1800" b="1">
+              <a:rPr sz="1750" b="1">
                 <a:solidFill>
                   <a:srgbClr val="1B365D"/>
                 </a:solidFill>
@@ -10364,7 +10359,7 @@
         <p:spPr>
           <a:xfrm>
             <a:off x="731520" y="164592"/>
-            <a:ext cx="2377440" cy="256032"/>
+            <a:ext cx="2560320" cy="256032"/>
           </a:xfrm>
           <a:prstGeom prst="roundRect">
             <a:avLst/>
@@ -10430,7 +10425,7 @@
           <a:lstStyle/>
           <a:p>
             <a:r>
-              <a:rPr sz="1800" b="1">
+              <a:rPr sz="1750" b="1">
                 <a:solidFill>
                   <a:srgbClr val="1B365D"/>
                 </a:solidFill>
@@ -10687,7 +10682,7 @@
                           <a:latin typeface="Segoe UI"/>
                         </a:rPr>
                         <a:t>• Chỉ áp dụng trên văn bản tiếng Anh.
-• Khảo sát các tập đoàn đa quốc gia phát triển toàn cầu.</a:t>
+• Khảo sát 3.529 báo cáo toàn cầu từ Corporate Register.</a:t>
                       </a:r>
                     </a:p>
                   </a:txBody>
@@ -10711,7 +10706,7 @@
                           <a:latin typeface="Segoe UI"/>
                         </a:rPr>
                         <a:t>• Tích hợp NLP đa ngữ (tiếng Việt &amp; tiếng Anh).
-• Khảo sát chuyên sâu 7 tập đoàn niêm yết lớn tại Việt Nam.</a:t>
+• Khảo sát chuyên sâu 42 báo cáo (96.461 câu) của 7 tập đoàn VN.</a:t>
                       </a:r>
                     </a:p>
                   </a:txBody>
@@ -10782,7 +10777,7 @@
                           </a:solidFill>
                           <a:latin typeface="Segoe UI"/>
                         </a:rPr>
-                        <a:t>• Xây dựng bộ ngữ liệu đối sánh chuẩn song ngữ 169 mục tiêu cụ thể của LHQ (~400 câu chuẩn tiếng Việt).</a:t>
+                        <a:t>• Xây dựng bộ ngữ liệu đối sánh chuẩn song ngữ 169 mục tiêu cụ thể của LHQ (1.032 câu chuẩn EN/VI).</a:t>
                       </a:r>
                     </a:p>
                   </a:txBody>
@@ -10901,8 +10896,8 @@
                           </a:solidFill>
                           <a:latin typeface="Segoe UI"/>
                         </a:rPr>
-                        <a:t>• DistilBERT phân loại nhị phân 2 lớp (Pos / Neg).
-• Ép các câu số liệu kỹ thuật vào nhãn tích cực hoặc tiêu cực.</a:t>
+                        <a:t>• DistilBERT phân loại nhị phân 2 lớp (Pos ~78%, Neg ~15%).
+• Tỷ số Pos/Neg ~ 5,20 lần (ép câu số liệu vào nhãn cảm xúc).</a:t>
                       </a:r>
                     </a:p>
                   </a:txBody>
@@ -10925,8 +10920,8 @@
                           </a:solidFill>
                           <a:latin typeface="Segoe UI"/>
                         </a:rPr>
-                        <a:t>• Nâng cấp mô hình PhoBERT 3 lớp (Tích cực, Trung tính, Tiêu cực).
-• Giữ nguyên 32,87% câu Trung tính kỹ thuật.</a:t>
+                        <a:t>• Nâng cấp PhoBERT 3 lớp (Pos 53,87%, Trung tính 32,87%, Neg 13,26%).
+• Tỷ số Pos/Neg = 4,06 lần (bảo toàn câu số liệu kỹ thuật).</a:t>
                       </a:r>
                     </a:p>
                   </a:txBody>
@@ -11170,7 +11165,7 @@
         <p:spPr>
           <a:xfrm>
             <a:off x="731520" y="164592"/>
-            <a:ext cx="2377440" cy="256032"/>
+            <a:ext cx="2560320" cy="256032"/>
           </a:xfrm>
           <a:prstGeom prst="roundRect">
             <a:avLst/>
@@ -11236,7 +11231,7 @@
           <a:lstStyle/>
           <a:p>
             <a:r>
-              <a:rPr sz="1800" b="1">
+              <a:rPr sz="1750" b="1">
                 <a:solidFill>
                   <a:srgbClr val="1B365D"/>
                 </a:solidFill>
@@ -11824,7 +11819,7 @@
         <p:spPr>
           <a:xfrm>
             <a:off x="731520" y="164592"/>
-            <a:ext cx="2377440" cy="256032"/>
+            <a:ext cx="2560320" cy="256032"/>
           </a:xfrm>
           <a:prstGeom prst="roundRect">
             <a:avLst/>
@@ -11890,7 +11885,7 @@
           <a:lstStyle/>
           <a:p>
             <a:r>
-              <a:rPr sz="1800" b="1">
+              <a:rPr sz="1750" b="1">
                 <a:solidFill>
                   <a:srgbClr val="1B365D"/>
                 </a:solidFill>
@@ -13126,7 +13121,7 @@
         <p:spPr>
           <a:xfrm>
             <a:off x="731520" y="164592"/>
-            <a:ext cx="2377440" cy="256032"/>
+            <a:ext cx="2560320" cy="256032"/>
           </a:xfrm>
           <a:prstGeom prst="roundRect">
             <a:avLst/>
@@ -13192,7 +13187,7 @@
           <a:lstStyle/>
           <a:p>
             <a:r>
-              <a:rPr sz="1800" b="1">
+              <a:rPr sz="1750" b="1">
                 <a:solidFill>
                   <a:srgbClr val="1B365D"/>
                 </a:solidFill>
@@ -13738,7 +13733,7 @@
         <p:spPr>
           <a:xfrm>
             <a:off x="731520" y="164592"/>
-            <a:ext cx="2377440" cy="256032"/>
+            <a:ext cx="2560320" cy="256032"/>
           </a:xfrm>
           <a:prstGeom prst="roundRect">
             <a:avLst/>
@@ -13804,13 +13799,13 @@
           <a:lstStyle/>
           <a:p>
             <a:r>
-              <a:rPr sz="1800" b="1">
+              <a:rPr sz="1750" b="1">
                 <a:solidFill>
                   <a:srgbClr val="1B365D"/>
                 </a:solidFill>
                 <a:latin typeface="Segoe UI"/>
               </a:rPr>
-              <a:t>BÀI BÁO GỐC KANG &amp; KIM (2022) &amp; SỰ THÍCH ỨNG TẠI VIỆT NAM</a:t>
+              <a:t>BÀI BÁO GỐC KANG &amp; KIM (2022) &amp; ĐỀ TÀI NÀY KHẮC PHỤC ĐIỀU GÌ?</a:t>
             </a:r>
           </a:p>
         </p:txBody>
@@ -13952,18 +13947,18 @@
           <a:lstStyle/>
           <a:p>
             <a:r>
-              <a:rPr b="1" sz="1300">
+              <a:rPr b="1" sz="1200">
                 <a:solidFill>
                   <a:srgbClr val="1B365D"/>
                 </a:solidFill>
               </a:rPr>
-              <a:t>BÀI BÁO GỐC: KANG &amp; KIM (2022)
+              <a:t>KẾT QUẢ CỐT LÕI BÀI BÁO GỐC: KANG &amp; KIM (2022)
 </a:t>
             </a:r>
           </a:p>
           <a:p>
             <a:pPr>
-              <a:defRPr sz="1000" i="1">
+              <a:defRPr sz="950" i="1">
                 <a:solidFill>
                   <a:srgbClr val="6C757D"/>
                 </a:solidFill>
@@ -13973,59 +13968,50 @@
               <a:t>Applied Sciences (MDPI), 12(11), 5614 | SCIE / Scopus Q2</a:t>
             </a:r>
           </a:p>
-          <a:p/>
           <a:p>
             <a:pPr>
-              <a:defRPr sz="1019">
+              <a:defRPr sz="980">
                 <a:solidFill>
                   <a:srgbClr val="212529"/>
                 </a:solidFill>
               </a:defRPr>
             </a:pPr>
             <a:r>
-              <a:t>• Phạm vi nghiên cứu gốc:</a:t>
+              <a:t>• Dữ liệu thực nghiệm toàn cầu:</a:t>
             </a:r>
             <a:br/>
             <a:r>
-              <a:t>  - Thu thập báo cáo phát triển bền vững của các tập đoàn đa quốc gia toàn cầu.</a:t>
+              <a:t>  - Thu thập 3.529 báo cáo PTBV quốc tế (2011–2020) từ Corporate Register.</a:t>
             </a:r>
             <a:br/>
             <a:r>
-              <a:t>  - Toàn bộ ngữ liệu sử dụng ngôn ngữ tiếng Anh.</a:t>
+              <a:t>  - 100% ngữ liệu sử dụng ngôn ngữ tiếng Anh.</a:t>
             </a:r>
             <a:br/>
             <a:br/>
             <a:r>
-              <a:t>• Khung phương pháp luận tiên phong:</a:t>
+              <a:t>• Kết quả định lượng điểm tương đồng SBERT:</a:t>
             </a:r>
             <a:br/>
             <a:r>
-              <a:t>  - Sử dụng Sentence-BERT (all-MiniLM-L6-v2) để nhúng câu văn bản.</a:t>
+              <a:t>  - Phân phối chuẩn Gaussian hình chuông: μ ≈ 44,80 điểm, σ ≈ 11,50 điểm.</a:t>
             </a:r>
             <a:br/>
             <a:r>
-              <a:t>  - Tính độ tương đồng Cosine giữa câu báo cáo với 17 mục tiêu SDG của Liên Hợp Quốc.</a:t>
-            </a:r>
-            <a:br/>
-            <a:r>
-              <a:t>  - Gom 17 SDGs thành 6 nhóm danh mục nhu cầu con người (Max-Neef, 1991).</a:t>
-            </a:r>
-            <a:br/>
-            <a:r>
-              <a:t>  - Dùng mô hình DistilBERT phân tích cảm xúc nhị phân 2 lớp (Positive / Negative).</a:t>
+              <a:t>  - Cấu trúc 6 nhóm: Nhóm Kinh tế (Economic) luôn cao nhất (~48–54đ), nhóm Công bằng (Equity) luôn thấp nhất (~38–44đ).</a:t>
             </a:r>
             <a:br/>
             <a:br/>
             <a:r>
-              <a:t>• Hạn chế của bài gốc:</a:t>
+              <a:t>• Kết quả cảm xúc DistilBERT 2 lớp (nhị phân):</a:t>
             </a:r>
             <a:br/>
             <a:r>
-              <a:t>  - Chưa từng được kiểm nghiệm trên các ngôn ngữ thứ hai ngoài tiếng Anh.</a:t>
+              <a:t>  - Câu Tích cực áp đảo (~78%), câu Tiêu cực rất thấp (~15%).</a:t>
             </a:r>
             <a:br/>
             <a:r>
-              <a:t>  - Phân loại cảm xúc 2 lớp bỏ qua các câu trung tính kỹ thuật.</a:t>
+              <a:t>  - Tỷ số Cảm xúc Pos/Neg bình quân đạt ~5,2 lần (xác nhận Hiệu ứng Pollyanna trên toàn cầu).</a:t>
             </a:r>
           </a:p>
         </p:txBody>
@@ -14098,18 +14084,18 @@
           <a:lstStyle/>
           <a:p>
             <a:r>
-              <a:rPr b="1" sz="1300">
+              <a:rPr b="1" sz="1200">
                 <a:solidFill>
                   <a:srgbClr val="288C3C"/>
                 </a:solidFill>
               </a:rPr>
-              <a:t>SỰ THÍCH ỨNG &amp; MỞ RỘNG TẠI VIỆT NAM
+              <a:t>ĐỀ TÀI NÀY KHẮC PHỤC 4 VẤN ĐỀ CỐT TỬ CỦA PAPER GỐC
 </a:t>
             </a:r>
           </a:p>
           <a:p>
             <a:pPr>
-              <a:defRPr sz="1000" i="1">
+              <a:defRPr sz="950" i="1">
                 <a:solidFill>
                   <a:srgbClr val="6C757D"/>
                 </a:solidFill>
@@ -14119,56 +14105,51 @@
               <a:t>Nghiên cứu của Lê Đan Sơn &amp; Dương Thị Hoàn (2026)</a:t>
             </a:r>
           </a:p>
-          <a:p/>
           <a:p>
             <a:pPr>
-              <a:defRPr sz="1019">
+              <a:defRPr sz="960">
                 <a:solidFill>
                   <a:srgbClr val="212529"/>
                 </a:solidFill>
               </a:defRPr>
             </a:pPr>
             <a:r>
-              <a:t>• Chuyển giao mô hình sang ngôn ngữ tiếng Việt:</a:t>
+              <a:t>1. Khắc phục rào cản đơn ngữ tiếng Anh:</a:t>
             </a:r>
             <a:br/>
             <a:r>
-              <a:t>  - Sử dụng vietnamese-sbert (768 chiều) đặc thù cho cấu trúc đơn âm tiết tiếng Việt.</a:t>
+              <a:t>   - Xây dựng pipeline NLP đa ngữ: vietnamese-sbert (768 chiều) đặc thù cho từ đơn âm tiếng Việt kết hợp MiniLM cho tiếng Anh.</a:t>
             </a:r>
             <a:br/>
             <a:r>
-              <a:t>  - Xây dựng bộ ngữ liệu đối sánh chuẩn song ngữ gồm 169 mục tiêu cụ thể của LHQ (~400 câu chuẩn).</a:t>
+              <a:t>   - Chuẩn hóa bộ ngữ liệu 1.032 câu song ngữ đối sánh 169 mục tiêu SDG.</a:t>
             </a:r>
             <a:br/>
             <a:br/>
             <a:r>
-              <a:t>• Bổ sung tầng nhận dạng quang học OCR:</a:t>
+              <a:t>2. Khắc phục lỗi tê liệt trước tệp scan hình ảnh:</a:t>
             </a:r>
             <a:br/>
             <a:r>
-              <a:t>  - Phục hồi dữ liệu từ các báo cáo dạng scan hình ảnh (như PNJ 2022) vốn làm tê liệt các bộ đọc PDF thông thường.</a:t>
+              <a:t>   - Bài gốc bỏ qua các file scan lỗi font -&gt; Đề tài tích hợp Tesseract OCR khôi phục 100% dữ liệu từ các trang scan phức tạp (như PNJ 2022).</a:t>
             </a:r>
             <a:br/>
             <a:br/>
             <a:r>
-              <a:t>• Nâng cấp mô hình Cảm xúc 3 Lớp (PhoBERT):</a:t>
+              <a:t>3. Khắc phục phân loại nhị phân gượng ép của mô hình cảm xúc:</a:t>
             </a:r>
             <a:br/>
             <a:r>
-              <a:t>  - Thay vì phân loại nhị phân gượng ép, nghiên cứu sử dụng PhoBERT 3 lớp (Tích cực, Trung tính, Tiêu cực).</a:t>
-            </a:r>
-            <a:br/>
-            <a:r>
-              <a:t>  - Giữ nguyên các câu số liệu kỹ thuật vào lớp Trung tính để phản ánh chân thực văn phong báo cáo.</a:t>
+              <a:t>   - Bài gốc ép các câu số liệu kỹ thuật vào Tích cực/Tiêu cực -&gt; Đề tài nâng cấp lên PhoBERT 3 lớp, bổ sung lớp Trung tính (32,87%) bảo toàn thông số vận hành.</a:t>
             </a:r>
             <a:br/>
             <a:br/>
             <a:r>
-              <a:t>• Phân tích sâu sắc bản chất ngành tại Việt Nam:</a:t>
+              <a:t>4. Từ khảo sát bề mặt toàn cầu đến giải mã chiều sâu đặc thù ngành:</a:t>
             </a:r>
             <a:br/>
             <a:r>
-              <a:t>  - Giải mã nghịch lý: Doanh nghiệp 'Nói nhiều về gì' vs 'Ít nói về gì'.</a:t>
+              <a:t>   - Phân tích chi tiết từng mô hình kinh doanh ngành và hiện tượng 'Nói nhiều về gì vs Né tránh điều gì' tại thị trường mới nổi Việt Nam.</a:t>
             </a:r>
           </a:p>
         </p:txBody>
@@ -14331,7 +14312,7 @@
         <p:spPr>
           <a:xfrm>
             <a:off x="731520" y="164592"/>
-            <a:ext cx="2377440" cy="256032"/>
+            <a:ext cx="2560320" cy="256032"/>
           </a:xfrm>
           <a:prstGeom prst="roundRect">
             <a:avLst/>
@@ -14397,7 +14378,7 @@
           <a:lstStyle/>
           <a:p>
             <a:r>
-              <a:rPr sz="1800" b="1">
+              <a:rPr sz="1750" b="1">
                 <a:solidFill>
                   <a:srgbClr val="1B365D"/>
                 </a:solidFill>
@@ -15399,7 +15380,7 @@
         <p:spPr>
           <a:xfrm>
             <a:off x="731520" y="164592"/>
-            <a:ext cx="2377440" cy="256032"/>
+            <a:ext cx="2560320" cy="256032"/>
           </a:xfrm>
           <a:prstGeom prst="roundRect">
             <a:avLst/>
@@ -15465,7 +15446,7 @@
           <a:lstStyle/>
           <a:p>
             <a:r>
-              <a:rPr sz="1800" b="1">
+              <a:rPr sz="1750" b="1">
                 <a:solidFill>
                   <a:srgbClr val="1B365D"/>
                 </a:solidFill>
@@ -17322,7 +17303,7 @@
         <p:spPr>
           <a:xfrm>
             <a:off x="731520" y="164592"/>
-            <a:ext cx="2377440" cy="256032"/>
+            <a:ext cx="2560320" cy="256032"/>
           </a:xfrm>
           <a:prstGeom prst="roundRect">
             <a:avLst/>
@@ -17388,13 +17369,13 @@
           <a:lstStyle/>
           <a:p>
             <a:r>
-              <a:rPr sz="1800" b="1">
+              <a:rPr sz="1750" b="1">
                 <a:solidFill>
                   <a:srgbClr val="1B365D"/>
                 </a:solidFill>
                 <a:latin typeface="Segoe UI"/>
               </a:rPr>
-              <a:t>KẾT QUẢ 1: PHÂN PHỐI ĐIỂM TƯƠNG ĐỒNG SDG TOÀN CỤC</a:t>
+              <a:t>KẾT QUẢ 1: PHÂN PHỐI ĐIỂM TƯƠNG ĐỒNG SDG &amp; ĐỐI CHUẨN PAPER GỐC</a:t>
             </a:r>
           </a:p>
         </p:txBody>
@@ -17536,72 +17517,79 @@
           <a:lstStyle/>
           <a:p>
             <a:r>
-              <a:rPr b="1" sz="1300">
+              <a:rPr b="1" sz="1200">
                 <a:solidFill>
                   <a:srgbClr val="1B365D"/>
                 </a:solidFill>
               </a:rPr>
-              <a:t>ĐẶC TRƯNG PHÂN PHỐI GAUSSIAN
+              <a:t>ĐẶC TRƯNG PHÂN PHỐI &amp; ĐỐI CHUẨN QUỐC TẾ
 </a:t>
             </a:r>
           </a:p>
           <a:p>
             <a:pPr>
-              <a:defRPr sz="1019">
+              <a:defRPr sz="950">
                 <a:solidFill>
                   <a:srgbClr val="212529"/>
                 </a:solidFill>
               </a:defRPr>
             </a:pPr>
             <a:r>
-              <a:t>• Hình thái chuông đối xứng chuẩn mực:</a:t>
+              <a:t>• BẢNG ĐỐI CHUẨN ĐỊNH LƯỢNG TRỰC TIẾP:</a:t>
             </a:r>
             <a:br/>
             <a:r>
-              <a:t>  - Điểm trung bình toàn cục: μ = 45,43 điểm.</a:t>
+              <a:t>  ┌────────────────────────┬─────────────┬─────────────┐</a:t>
             </a:r>
             <a:br/>
             <a:r>
-              <a:t>  - Độ lệch chuẩn: σ = 11,87 điểm.</a:t>
+              <a:t>  │ Chỉ số thống kê        │ Việt Nam    │ Kang &amp; Kim  │</a:t>
             </a:r>
             <a:br/>
             <a:r>
-              <a:t>  - Điểm số trải dài từ 10 đến 90 trên thang đo 0–100.</a:t>
+              <a:t>  ├────────────────────────┼─────────────┼─────────────┤</a:t>
+            </a:r>
+            <a:br/>
+            <a:r>
+              <a:t>  │ Điểm trung bình (μ)    │ 45,43 điểm  │ 44,80 điểm  │</a:t>
+            </a:r>
+            <a:br/>
+            <a:r>
+              <a:t>  │ Độ lệch chuẩn (σ)      │ 11,87 điểm  │ 11,50 điểm  │</a:t>
+            </a:r>
+            <a:br/>
+            <a:r>
+              <a:t>  │ Hình thái phân phối    │ Chuông Gauss│ Chuông Gauss│</a:t>
+            </a:r>
+            <a:br/>
+            <a:r>
+              <a:t>  │ Đuôi phải (&gt;65 điểm)   │ 8,50% câu   │ ~8,00% câu  │</a:t>
+            </a:r>
+            <a:br/>
+            <a:r>
+              <a:t>  └────────────────────────┴─────────────┴─────────────┘</a:t>
             </a:r>
             <a:br/>
             <a:br/>
             <a:r>
-              <a:t>• Phân khúc bối cảnh chung (35–55 điểm):</a:t>
+              <a:t>• Nhận định học thuật quan trọng:</a:t>
             </a:r>
             <a:br/>
             <a:r>
-              <a:t>  - Chiếm hơn 75% toàn bộ ngữ liệu báo cáo.</a:t>
+              <a:t>  - Độ chênh lệch giữa điểm trung bình chỉ 0,63 điểm; độ phân tán lệch chuẩn gần như trùng khớp hoàn toàn!</a:t>
             </a:r>
             <a:br/>
             <a:r>
-              <a:t>  - Đại diện cho các câu văn mô tả bối cảnh điều hành, quy chế tổ chức và các tuyên bố định hướng chung.</a:t>
+              <a:t>  - Chứng minh vietnamese-sbert biểu diễn ngữ nghĩa tiếng Việt đạt độ chuẩn xác và ổn định tương đương tuyệt đối với SBERT tiếng Anh trên ngữ liệu toàn cầu.</a:t>
             </a:r>
             <a:br/>
             <a:br/>
             <a:r>
-              <a:t>• Đuôi phải chuyên sâu (&gt;65 điểm - 8,5% câu):</a:t>
+              <a:t>• Phân khúc đuôi phải chuyên sâu (&gt;65 điểm):</a:t>
             </a:r>
             <a:br/>
             <a:r>
-              <a:t>  - Nhóm các câu văn mang hàm lượng kỹ thuật cao.</a:t>
-            </a:r>
-            <a:br/>
-            <a:r>
-              <a:t>  - Mô tả trực tiếp các chỉ tiêu hành động cụ thể: công nghệ xử lý nước thải tuần hoàn, chứng nhận quốc tế, đầu tư dây chuyền giảm phát thải.</a:t>
-            </a:r>
-            <a:br/>
-            <a:br/>
-            <a:r>
-              <a:t>• Ý nghĩa phương pháp luận:</a:t>
-            </a:r>
-            <a:br/>
-            <a:r>
-              <a:t>  - Khẳng định Sentence-BERT hoạt động cực kỳ ổn định trên tiếng Việt, tái lập hoàn hảo quy luật thống kê của Kang &amp; Kim (2022).</a:t>
+              <a:t>  - Đại diện cho các cam kết kỹ thuật cao: xử lý tuần hoàn bùn thải, kiểm kê khí nhà kính ISO 14064, năng lượng tái tạo.</a:t>
             </a:r>
           </a:p>
         </p:txBody>
@@ -17867,7 +17855,7 @@
         <p:spPr>
           <a:xfrm>
             <a:off x="731520" y="164592"/>
-            <a:ext cx="2377440" cy="256032"/>
+            <a:ext cx="2560320" cy="256032"/>
           </a:xfrm>
           <a:prstGeom prst="roundRect">
             <a:avLst/>
@@ -17933,13 +17921,13 @@
           <a:lstStyle/>
           <a:p>
             <a:r>
-              <a:rPr sz="1800" b="1">
+              <a:rPr sz="1750" b="1">
                 <a:solidFill>
                   <a:srgbClr val="1B365D"/>
                 </a:solidFill>
                 <a:latin typeface="Segoe UI"/>
               </a:rPr>
-              <a:t>KẾT QUẢ 2: CẤU TRÚC 6 NHÓM SDG QUA BIỂU ĐỒ NHIỆT (HEATMAP)</a:t>
+              <a:t>KẾT QUẢ 2: CẤU TRÚC 6 NHÓM SDG &amp; QUY LUẬT TÂM LÝ TOÀN CẦU</a:t>
             </a:r>
           </a:p>
         </p:txBody>
@@ -18184,79 +18172,62 @@
           <a:lstStyle/>
           <a:p>
             <a:r>
-              <a:rPr b="1" sz="1250">
+              <a:rPr b="1" sz="1200">
                 <a:solidFill>
                   <a:srgbClr val="1B365D"/>
                 </a:solidFill>
               </a:rPr>
-              <a:t>THỨ BẬC ƯU TIÊN TOÀN CỤC CỦA DOANH NGHIỆP VIỆT NAM
+              <a:t>THỨ BẬC ƯU TIÊN &amp; SỰ TƯƠNG ĐỒNG VỚI PAPER GỐC
 </a:t>
             </a:r>
           </a:p>
           <a:p>
             <a:pPr>
-              <a:defRPr sz="980">
+              <a:defRPr sz="960">
                 <a:solidFill>
                   <a:srgbClr val="212529"/>
                 </a:solidFill>
               </a:defRPr>
             </a:pPr>
             <a:r>
-              <a:t>Từ biểu đồ nhiệt Heatmap, cấu trúc cam kết thể hiện rõ trật tự thứ bậc phân tầng:</a:t>
+              <a:t>• THỨ BẬC PHÂN TẦNG TẠI VIỆT NAM:</a:t>
+            </a:r>
+            <a:br/>
+            <a:r>
+              <a:t>  1. Kinh tế (Economic): 48,0 – 52,5 điểm (Sắc đỏ sẫm nhất - Doanh thu, đổi mới công nghệ).</a:t>
+            </a:r>
+            <a:br/>
+            <a:r>
+              <a:t>  2. Xã hội (Social): 46,2 – 50,8 điểm (Quản trị minh bạch, đối tác phát triển bền vững).</a:t>
+            </a:r>
+            <a:br/>
+            <a:r>
+              <a:t>  3. Tài nguyên (Resources): 44,1 – 48,9 điểm (Tiết kiệm năng lượng, tuần hoàn nước thải).</a:t>
+            </a:r>
+            <a:br/>
+            <a:r>
+              <a:t>  4. Đời sống (Life): 43,0 – 47,5 điểm (An sinh xã hội, phúc lợi y tế người lao động).</a:t>
+            </a:r>
+            <a:br/>
+            <a:r>
+              <a:t>  5. Môi trường (Environments): 41,2 – 47,3 điểm (Bứt phá mạnh ở VNM, VCS giai đoạn 2024–2025).</a:t>
+            </a:r>
+            <a:br/>
+            <a:r>
+              <a:t>  6. Công bằng (Equity): 39,0 – 44,2 điểm (Sắc vàng nhạt nhất toàn mẫu - Vùng trũng lớn nhất).</a:t>
             </a:r>
             <a:br/>
             <a:br/>
             <a:r>
-              <a:t>1. Kinh tế (Economic - SDG 8, 9) [48,0 – 52,5 điểm]:</a:t>
+              <a:t>• SO SÁNH VỚI QUY LUẬT TOÀN CẦU CỦA KANG &amp; KIM (2022):</a:t>
             </a:r>
             <a:br/>
             <a:r>
-              <a:t>   - Sắc đỏ sẫm nhất xuyên suốt 42 báo cáo. Doanh nghiệp đặt ưu tiên hàng đầu vào tăng trưởng doanh thu, đổi mới hạ tầng công nghệ và đảm bảo việc làm.</a:t>
+              <a:t>  - Trong nghiên cứu gốc trên 3.529 báo cáo thế giới: Nhóm Kinh tế luôn đạt điểm cao nhất (~48-54đ) và nhóm Công bằng luôn đạt điểm thấp nhất (~38-44đ).</a:t>
             </a:r>
             <a:br/>
-            <a:br/>
-            <a:r>
-              <a:t>2. Xã hội (Social - SDG 11, 16, 17) [46,2 – 50,8 điểm]:</a:t>
-            </a:r>
-            <a:br/>
-            <a:r>
-              <a:t>   - Sắc đỏ cam đậm. Tập trung vào trách nhiệm cộng đồng, quản trị minh bạch và quan hệ đối tác phát triển bền vững.</a:t>
-            </a:r>
-            <a:br/>
-            <a:br/>
-            <a:r>
-              <a:t>3. Tài nguyên (Resources - SDG 6, 7, 12, 14) [44,1 – 48,9 điểm]:</a:t>
-            </a:r>
-            <a:br/>
-            <a:r>
-              <a:t>   - Nổi trội ở khối sản xuất: năng lượng sạch, tiết kiệm nước và sản xuất có trách nhiệm.</a:t>
-            </a:r>
-            <a:br/>
-            <a:br/>
-            <a:r>
-              <a:t>4. Đời sống (Life - SDG 1, 2, 3) [43,0 – 47,5 điểm]:</a:t>
-            </a:r>
-            <a:br/>
-            <a:r>
-              <a:t>   - An sinh xã hội, phúc lợi y tế và dinh dưỡng (đặc biệt cao tại Vinamilk và PAN).</a:t>
-            </a:r>
-            <a:br/>
-            <a:br/>
-            <a:r>
-              <a:t>5. Môi trường (Environments - SDG 13, 15) [41,2 – 47,3 điểm]:</a:t>
-            </a:r>
-            <a:br/>
-            <a:r>
-              <a:t>   - Có sự bứt phá mạnh mẽ ở giai đoạn 2023–2025 nhờ chiến lược Net Zero.</a:t>
-            </a:r>
-            <a:br/>
-            <a:br/>
-            <a:r>
-              <a:t>6. Công bằng (Equity - SDG 4, 5, 10) [39,0 – 44,2 điểm]:</a:t>
-            </a:r>
-            <a:br/>
-            <a:r>
-              <a:t>   - Luôn mang sắc vàng nhạt nhất (vùng trũng lớn nhất về bình đẳng giới lãnh đạo &amp; phân tầng thu nhập).</a:t>
+            <a:r>
+              <a:t>  - Kết quả tại Việt Nam hoàn toàn tái lập quy luật này! Điều này khẳng định: Tâm lý ưu tiên tăng trưởng kinh doanh trước khi chú trọng đến bình đẳng giới hay giảm bất bình đẳng thu nhập là một quy luật phổ quát toàn cầu, không chỉ riêng tại thị trường mới nổi.</a:t>
             </a:r>
           </a:p>
         </p:txBody>
@@ -18419,7 +18390,7 @@
         <p:spPr>
           <a:xfrm>
             <a:off x="731520" y="164592"/>
-            <a:ext cx="2377440" cy="256032"/>
+            <a:ext cx="2560320" cy="256032"/>
           </a:xfrm>
           <a:prstGeom prst="roundRect">
             <a:avLst/>
@@ -18485,13 +18456,13 @@
           <a:lstStyle/>
           <a:p>
             <a:r>
-              <a:rPr sz="1800" b="1">
+              <a:rPr sz="1750" b="1">
                 <a:solidFill>
                   <a:srgbClr val="1B365D"/>
                 </a:solidFill>
                 <a:latin typeface="Segoe UI"/>
               </a:rPr>
-              <a:t>ĐẶC THÙ NGÀNH: KHỐI SẢN XUẤT, NÔNG NGHIỆP &amp; NĂNG LƯỢNG</a:t>
+              <a:t>ĐẶC THÙ NGÀNH: KHỐI SẢN XUẤT &amp; NĂNG LƯỢNG (VNM, VCS, PAN, PLX)</a:t>
             </a:r>
           </a:p>
         </p:txBody>
@@ -18574,7 +18545,7 @@
         <p:spPr>
           <a:xfrm>
             <a:off x="731520" y="1325880"/>
-            <a:ext cx="5212080" cy="2331720"/>
+            <a:ext cx="5303520" cy="4937760"/>
           </a:xfrm>
           <a:prstGeom prst="roundRect">
             <a:avLst/>
@@ -18610,16 +18581,40 @@
           </a:p>
         </p:txBody>
       </p:sp>
-      <p:sp>
-        <p:nvSpPr>
-          <p:cNvPr id="10" name="TextBox 9"/>
+      <p:pic>
+        <p:nvPicPr>
+          <p:cNvPr id="10" name="Picture 9" descr="slide_manuf_sdgs.png"/>
+          <p:cNvPicPr>
+            <a:picLocks noChangeAspect="1"/>
+          </p:cNvPicPr>
+          <p:nvPr/>
+        </p:nvPicPr>
+        <p:blipFill>
+          <a:blip r:embed="rId2"/>
+          <a:stretch>
+            <a:fillRect/>
+          </a:stretch>
+        </p:blipFill>
+        <p:spPr>
+          <a:xfrm>
+            <a:off x="868680" y="1463040"/>
+            <a:ext cx="5029200" cy="4389120"/>
+          </a:xfrm>
+          <a:prstGeom prst="rect">
+            <a:avLst/>
+          </a:prstGeom>
+        </p:spPr>
+      </p:pic>
+      <p:sp>
+        <p:nvSpPr>
+          <p:cNvPr id="11" name="TextBox 10"/>
           <p:cNvSpPr txBox="1"/>
           <p:nvPr/>
         </p:nvSpPr>
         <p:spPr>
           <a:xfrm>
-            <a:off x="868680" y="1417320"/>
-            <a:ext cx="4937760" cy="2148839"/>
+            <a:off x="868680" y="5897880"/>
+            <a:ext cx="5029200" cy="320040"/>
           </a:xfrm>
           <a:prstGeom prst="rect">
             <a:avLst/>
@@ -18627,53 +18622,33 @@
           <a:noFill/>
         </p:spPr>
         <p:txBody>
-          <a:bodyPr wrap="square">
+          <a:bodyPr wrap="none">
             <a:spAutoFit/>
           </a:bodyPr>
           <a:lstStyle/>
           <a:p>
-            <a:r>
-              <a:rPr b="1" sz="1150">
-                <a:solidFill>
-                  <a:srgbClr val="288C3C"/>
+            <a:pPr algn="ctr"/>
+            <a:r>
+              <a:rPr sz="850" i="1">
+                <a:solidFill>
+                  <a:srgbClr val="6C757D"/>
                 </a:solidFill>
               </a:rPr>
-              <a:t>VINAMILK (VNM) — TIÊN PHONG NET ZERO
-</a:t>
-            </a:r>
-          </a:p>
-          <a:p>
-            <a:pPr>
-              <a:defRPr sz="919">
-                <a:solidFill>
-                  <a:srgbClr val="212529"/>
-                </a:solidFill>
-              </a:defRPr>
-            </a:pPr>
-            <a:r>
-              <a:t>• Bứt phá nhóm Môi trường: Tăng mạnh nhất toàn mẫu (+6,06 điểm, từ 41,23 lên 47,29 điểm).</a:t>
-            </a:r>
-            <a:br/>
-            <a:r>
-              <a:t>• Đặc thù: 15 cụm trang trại bò sữa và 13 nhà máy đòi hỏi xử lý chất thải chăn nuôi và khí nhà kính.</a:t>
-            </a:r>
-            <a:br/>
-            <a:r>
-              <a:t>• Điểm sáng: Đạt chứng nhận trung hòa Carbon quốc tế PAS 2060 cho nhà máy Nghệ An; phát triển trang trại Green Farm tuần hoàn 100% nước, điện mặt trời áp mái.</a:t>
-            </a:r>
-          </a:p>
-        </p:txBody>
-      </p:sp>
-      <p:sp>
-        <p:nvSpPr>
-          <p:cNvPr id="11" name="Rounded Rectangle 10"/>
+              <a:t>Hình: Điểm số các mục tiêu SDG cốt lõi năm 2025 của khối Sản xuất &amp; Năng lượng</a:t>
+            </a:r>
+          </a:p>
+        </p:txBody>
+      </p:sp>
+      <p:sp>
+        <p:nvSpPr>
+          <p:cNvPr id="12" name="Rounded Rectangle 11"/>
           <p:cNvSpPr/>
           <p:nvPr/>
         </p:nvSpPr>
         <p:spPr>
           <a:xfrm>
-            <a:off x="6245352" y="1325880"/>
-            <a:ext cx="5212080" cy="2331720"/>
+            <a:off x="6217920" y="1325880"/>
+            <a:ext cx="5242255" cy="4937760"/>
           </a:xfrm>
           <a:prstGeom prst="roundRect">
             <a:avLst/>
@@ -18711,14 +18686,14 @@
       </p:sp>
       <p:sp>
         <p:nvSpPr>
-          <p:cNvPr id="12" name="TextBox 11"/>
+          <p:cNvPr id="13" name="TextBox 12"/>
           <p:cNvSpPr txBox="1"/>
           <p:nvPr/>
         </p:nvSpPr>
         <p:spPr>
           <a:xfrm>
-            <a:off x="6382512" y="1417320"/>
-            <a:ext cx="4937760" cy="2148839"/>
+            <a:off x="6400800" y="1463040"/>
+            <a:ext cx="4876495" cy="4663440"/>
           </a:xfrm>
           <a:prstGeom prst="rect">
             <a:avLst/>
@@ -18737,7 +18712,7 @@
                   <a:srgbClr val="1B365D"/>
                 </a:solidFill>
               </a:rPr>
-              <a:t>VICOSTONE (VCS) — KINH TẾ TUẦN HOÀN VẬT LIỆU
+              <a:t>MÔ HÌNH KINH DOANH ĐỊNH HÌNH SDG NÀO CAO VƯỢT TRỘI?
 </a:t>
             </a:r>
           </a:p>
@@ -18750,213 +18725,51 @@
               </a:defRPr>
             </a:pPr>
             <a:r>
-              <a:t>• Dẫn đầu Kinh tế (51,90) &amp; Tài nguyên (50,03) cao nhất toàn mẫu.</a:t>
+              <a:t>Từ biểu đồ phân tích, từng doanh nghiệp bộc lộ rõ các mục tiêu SDG dẫn đầu:</a:t>
             </a:r>
             <a:br/>
-            <a:r>
-              <a:t>• Đặc thù: Chế tác đá thạch anh nhân tạo xuất khẩu đòi hỏi tiêu hao khoáng sản và hóa chất kết dính.</a:t>
-            </a:r>
             <a:br/>
             <a:r>
-              <a:t>• Điểm sáng: Công nghệ rung ép chân không Breton (Ý), tái chế 100% bùn thải đá thành phụ gia xi măng, hệ thống nước khép kín, chứng chỉ an toàn hóa chất Greenguard Gold.</a:t>
-            </a:r>
-          </a:p>
-        </p:txBody>
-      </p:sp>
-      <p:sp>
-        <p:nvSpPr>
-          <p:cNvPr id="13" name="Rounded Rectangle 12"/>
-          <p:cNvSpPr/>
-          <p:nvPr/>
-        </p:nvSpPr>
-        <p:spPr>
-          <a:xfrm>
-            <a:off x="731520" y="3886200"/>
-            <a:ext cx="5212080" cy="2331720"/>
-          </a:xfrm>
-          <a:prstGeom prst="roundRect">
-            <a:avLst/>
-          </a:prstGeom>
-          <a:solidFill>
-            <a:srgbClr val="FFFFFF"/>
-          </a:solidFill>
-          <a:ln w="12700">
-            <a:solidFill>
-              <a:srgbClr val="DAE0E9"/>
-            </a:solidFill>
-          </a:ln>
-        </p:spPr>
-        <p:style>
-          <a:lnRef idx="1">
-            <a:schemeClr val="accent1"/>
-          </a:lnRef>
-          <a:fillRef idx="3">
-            <a:schemeClr val="accent1"/>
-          </a:fillRef>
-          <a:effectRef idx="2">
-            <a:schemeClr val="accent1"/>
-          </a:effectRef>
-          <a:fontRef idx="minor">
-            <a:schemeClr val="lt1"/>
-          </a:fontRef>
-        </p:style>
-        <p:txBody>
-          <a:bodyPr rtlCol="0" anchor="ctr"/>
-          <a:lstStyle/>
-          <a:p>
-            <a:pPr algn="ctr"/>
-          </a:p>
-        </p:txBody>
-      </p:sp>
-      <p:sp>
-        <p:nvSpPr>
-          <p:cNvPr id="14" name="TextBox 13"/>
-          <p:cNvSpPr txBox="1"/>
-          <p:nvPr/>
-        </p:nvSpPr>
-        <p:spPr>
-          <a:xfrm>
-            <a:off x="868680" y="3977639"/>
-            <a:ext cx="4937760" cy="2148839"/>
-          </a:xfrm>
-          <a:prstGeom prst="rect">
-            <a:avLst/>
-          </a:prstGeom>
-          <a:noFill/>
-        </p:spPr>
-        <p:txBody>
-          <a:bodyPr wrap="square">
-            <a:spAutoFit/>
-          </a:bodyPr>
-          <a:lstStyle/>
-          <a:p>
-            <a:r>
-              <a:rPr b="1" sz="1150">
-                <a:solidFill>
-                  <a:srgbClr val="1F77B4"/>
-                </a:solidFill>
-              </a:rPr>
-              <a:t>THE PAN GROUP (PAN) — NÔNG NGHIỆP XANH &amp; LƯƠNG THỰC
-</a:t>
-            </a:r>
-          </a:p>
-          <a:p>
-            <a:pPr>
-              <a:defRPr sz="919">
-                <a:solidFill>
-                  <a:srgbClr val="212529"/>
-                </a:solidFill>
-              </a:defRPr>
-            </a:pPr>
-            <a:r>
-              <a:t>• Trọng tâm Đời sống (Life: SDG 2, 3) &amp; Tài nguyên (SDG 12) ổn định 45–47 điểm.</a:t>
+              <a:t>• Vinamilk (VNM) — Bứt phá SDG 13 (Khí hậu) &amp; SDG 12 (Tuần hoàn):</a:t>
             </a:r>
             <a:br/>
             <a:r>
-              <a:t>• Đặc thù: Chuỗi giá trị nông nghiệp - thủy sản khép kín từ hạt giống (Vinaseed) đến tôm xuất khẩu (Fimex VN).</a:t>
+              <a:t>  - SDG 13 đạt 45,36đ, SDG 12 đạt 49,62đ; nhóm Environments bứt phá mạnh nhất toàn mẫu (+6,06 điểm từ 41,23 lên 47,29đ).</a:t>
             </a:r>
             <a:br/>
             <a:r>
-              <a:t>• Điểm sáng: Mô hình cánh đồng lúa giảm phát thải carbon, nuôi tôm an toàn sinh học không kháng sinh, truy xuất nguồn gốc nông sản phục vụ xuất khẩu EU.</a:t>
-            </a:r>
-          </a:p>
-        </p:txBody>
-      </p:sp>
-      <p:sp>
-        <p:nvSpPr>
-          <p:cNvPr id="15" name="Rounded Rectangle 14"/>
-          <p:cNvSpPr/>
-          <p:nvPr/>
-        </p:nvSpPr>
-        <p:spPr>
-          <a:xfrm>
-            <a:off x="6245352" y="3886200"/>
-            <a:ext cx="5212080" cy="2331720"/>
-          </a:xfrm>
-          <a:prstGeom prst="roundRect">
-            <a:avLst/>
-          </a:prstGeom>
-          <a:solidFill>
-            <a:srgbClr val="FFFFFF"/>
-          </a:solidFill>
-          <a:ln w="12700">
-            <a:solidFill>
-              <a:srgbClr val="DAE0E9"/>
-            </a:solidFill>
-          </a:ln>
-        </p:spPr>
-        <p:style>
-          <a:lnRef idx="1">
-            <a:schemeClr val="accent1"/>
-          </a:lnRef>
-          <a:fillRef idx="3">
-            <a:schemeClr val="accent1"/>
-          </a:fillRef>
-          <a:effectRef idx="2">
-            <a:schemeClr val="accent1"/>
-          </a:effectRef>
-          <a:fontRef idx="minor">
-            <a:schemeClr val="lt1"/>
-          </a:fontRef>
-        </p:style>
-        <p:txBody>
-          <a:bodyPr rtlCol="0" anchor="ctr"/>
-          <a:lstStyle/>
-          <a:p>
-            <a:pPr algn="ctr"/>
-          </a:p>
-        </p:txBody>
-      </p:sp>
-      <p:sp>
-        <p:nvSpPr>
-          <p:cNvPr id="16" name="TextBox 15"/>
-          <p:cNvSpPr txBox="1"/>
-          <p:nvPr/>
-        </p:nvSpPr>
-        <p:spPr>
-          <a:xfrm>
-            <a:off x="6382512" y="3977639"/>
-            <a:ext cx="4937760" cy="2148839"/>
-          </a:xfrm>
-          <a:prstGeom prst="rect">
-            <a:avLst/>
-          </a:prstGeom>
-          <a:noFill/>
-        </p:spPr>
-        <p:txBody>
-          <a:bodyPr wrap="square">
-            <a:spAutoFit/>
-          </a:bodyPr>
-          <a:lstStyle/>
-          <a:p>
-            <a:r>
-              <a:rPr b="1" sz="1150">
-                <a:solidFill>
-                  <a:srgbClr val="D62728"/>
-                </a:solidFill>
-              </a:rPr>
-              <a:t>PETROLIMEX (PLX) — CHUYỂN DỊCH NĂNG LƯỢNG HẠ NGUỒN
-</a:t>
-            </a:r>
-          </a:p>
-          <a:p>
-            <a:pPr>
-              <a:defRPr sz="919">
-                <a:solidFill>
-                  <a:srgbClr val="212529"/>
-                </a:solidFill>
-              </a:defRPr>
-            </a:pPr>
-            <a:r>
-              <a:t>• Trọng tâm Năng lượng sạch (SDG 7: 46,86) &amp; Khí hậu (SDG 13: 46,41 điểm năm 2025).</a:t>
+              <a:t>  - Nguyên nhân: 15 trang trại và 13 nhà máy đối diện áp lực giảm phát thải; tiên phong đạt chứng nhận trung hòa Carbon PAS 2060, Green Farm tuần hoàn 100% nước.</a:t>
             </a:r>
             <a:br/>
-            <a:r>
-              <a:t>• Đặc thù: Đơn vị hạ nguồn năng lượng hóa thạch lớn nhất VN (&gt;50% thị phần), chịu áp lực chuyển dịch xanh.</a:t>
-            </a:r>
             <a:br/>
             <a:r>
-              <a:t>• Điểm sáng: Phân phối nhiên liệu Euro 5 (DO 0,001S-V), phát triển mạng lưới xăng sinh học E5, điện mặt trời áp mái trạm xăng, kiểm kê khí nhà kính ISO 14064-1.</a:t>
+              <a:t>• Vicostone (VCS) — Đỉnh cao SDG 9 (Đổi mới) &amp; SDG 12 (Tuần hoàn):</a:t>
+            </a:r>
+            <a:br/>
+            <a:r>
+              <a:t>  - Dẫn đầu toàn mẫu: SDG 9 đạt 52,96đ, SDG 12 đạt 53,18đ, SDG 7 đạt 52,80đ.</a:t>
+            </a:r>
+            <a:br/>
+            <a:r>
+              <a:t>  - Nguyên nhân: Chế tác đá thạch anh nhân tạo Breton (Ý); tái chế 100% bùn thải đá thành phụ gia xi măng; chứng chỉ an toàn hóa chất Greenguard Gold.</a:t>
+            </a:r>
+            <a:br/>
+            <a:br/>
+            <a:r>
+              <a:t>• The PAN Group (PAN) — Dẫn đầu SDG 2 (An ninh Lương thực: 47,47đ):</a:t>
+            </a:r>
+            <a:br/>
+            <a:r>
+              <a:t>  - Chuỗi giá trị nông nghiệp thực phẩm khép kín; lúa gạo giảm phát thải carbon (Vinaseed), nuôi tôm sinh thái không kháng sinh (Fimex VN).</a:t>
+            </a:r>
+            <a:br/>
+            <a:br/>
+            <a:r>
+              <a:t>• Petrolimex (PLX) — Trọng tâm SDG 7 (Năng lượng: 48,04đ) &amp; SDG 13 (46,19đ):</a:t>
+            </a:r>
+            <a:br/>
+            <a:r>
+              <a:t>  - Doanh nghiệp xăng dầu hạ nguồn chuyển dịch xanh: Phân phối nhiên liệu Euro 5, điện mặt trời trạm xăng, kiểm kê khí nhà kính ISO 14064-1.</a:t>
             </a:r>
           </a:p>
         </p:txBody>
@@ -19119,7 +18932,7 @@
         <p:spPr>
           <a:xfrm>
             <a:off x="731520" y="164592"/>
-            <a:ext cx="2377440" cy="256032"/>
+            <a:ext cx="2560320" cy="256032"/>
           </a:xfrm>
           <a:prstGeom prst="roundRect">
             <a:avLst/>
@@ -19185,13 +18998,13 @@
           <a:lstStyle/>
           <a:p>
             <a:r>
-              <a:rPr sz="1800" b="1">
+              <a:rPr sz="1750" b="1">
                 <a:solidFill>
                   <a:srgbClr val="1B365D"/>
                 </a:solidFill>
                 <a:latin typeface="Segoe UI"/>
               </a:rPr>
-              <a:t>ĐẶC THÙ NGÀNH: KHỐI TÀI CHÍNH, CHỨNG KHOÁN &amp; BÁN LẺ</a:t>
+              <a:t>ĐẶC THÙ NGÀNH: KHỐI TÀI CHÍNH &amp; BÁN LẺ (PNJ, BVH, SSI)</a:t>
             </a:r>
           </a:p>
         </p:txBody>
@@ -19274,7 +19087,7 @@
         <p:spPr>
           <a:xfrm>
             <a:off x="731520" y="1325880"/>
-            <a:ext cx="3337560" cy="4937760"/>
+            <a:ext cx="5303520" cy="4937760"/>
           </a:xfrm>
           <a:prstGeom prst="roundRect">
             <a:avLst/>
@@ -19310,16 +19123,40 @@
           </a:p>
         </p:txBody>
       </p:sp>
-      <p:sp>
-        <p:nvSpPr>
-          <p:cNvPr id="10" name="TextBox 9"/>
+      <p:pic>
+        <p:nvPicPr>
+          <p:cNvPr id="10" name="Picture 9" descr="slide_finance_sdgs.png"/>
+          <p:cNvPicPr>
+            <a:picLocks noChangeAspect="1"/>
+          </p:cNvPicPr>
+          <p:nvPr/>
+        </p:nvPicPr>
+        <p:blipFill>
+          <a:blip r:embed="rId2"/>
+          <a:stretch>
+            <a:fillRect/>
+          </a:stretch>
+        </p:blipFill>
+        <p:spPr>
+          <a:xfrm>
+            <a:off x="868680" y="1463040"/>
+            <a:ext cx="5029200" cy="4389120"/>
+          </a:xfrm>
+          <a:prstGeom prst="rect">
+            <a:avLst/>
+          </a:prstGeom>
+        </p:spPr>
+      </p:pic>
+      <p:sp>
+        <p:nvSpPr>
+          <p:cNvPr id="11" name="TextBox 10"/>
           <p:cNvSpPr txBox="1"/>
           <p:nvPr/>
         </p:nvSpPr>
         <p:spPr>
           <a:xfrm>
-            <a:off x="868680" y="1463039"/>
-            <a:ext cx="3063240" cy="4663440"/>
+            <a:off x="868680" y="5897880"/>
+            <a:ext cx="5029200" cy="320040"/>
           </a:xfrm>
           <a:prstGeom prst="rect">
             <a:avLst/>
@@ -19327,72 +19164,33 @@
           <a:noFill/>
         </p:spPr>
         <p:txBody>
-          <a:bodyPr wrap="square">
+          <a:bodyPr wrap="none">
             <a:spAutoFit/>
           </a:bodyPr>
           <a:lstStyle/>
           <a:p>
-            <a:r>
-              <a:rPr b="1" sz="1200">
-                <a:solidFill>
-                  <a:srgbClr val="1B365D"/>
+            <a:pPr algn="ctr"/>
+            <a:r>
+              <a:rPr sz="850" i="1">
+                <a:solidFill>
+                  <a:srgbClr val="6C757D"/>
                 </a:solidFill>
               </a:rPr>
-              <a:t>TẬP ĐOÀN BẢO VIỆT (BVH)
-TIÊN PHONG BÁO CÁO TÍCH HỢP
-</a:t>
-            </a:r>
-          </a:p>
-          <a:p>
-            <a:pPr>
-              <a:defRPr sz="980">
-                <a:solidFill>
-                  <a:srgbClr val="212529"/>
-                </a:solidFill>
-              </a:defRPr>
-            </a:pPr>
-            <a:r>
-              <a:t>• Chuẩn mực quốc tế &lt;IIRC&gt;:</a:t>
-            </a:r>
-            <a:br/>
-            <a:r>
-              <a:t>  - Tiên phong áp dụng khung Báo cáo Tích hợp kết nối 6 nguồn vốn (Tài chính, Sản xuất, Trí tuệ, Con người, Xã hội, Tự nhiên).</a:t>
-            </a:r>
-            <a:br/>
-            <a:br/>
-            <a:r>
-              <a:t>• Trọng tâm Kinh tế &amp; Xã hội:</a:t>
-            </a:r>
-            <a:br/>
-            <a:r>
-              <a:t>  - Điểm số nhóm Kinh tế và Xã hội luôn duy trì trên 49–50 điểm.</a:t>
-            </a:r>
-            <a:br/>
-            <a:r>
-              <a:t>  - Báo cáo tập trung vào quản trị rủi ro minh bạch và tuân thủ thể chế tài chính.</a:t>
-            </a:r>
-            <a:br/>
-            <a:br/>
-            <a:r>
-              <a:t>• Đóng góp An sinh Xã hội:</a:t>
-            </a:r>
-            <a:br/>
-            <a:r>
-              <a:t>  - Mở rộng các gói bảo hiểm vi mô bảo vệ tài chính cho người thu nhập thấp và nông dân trước rủi ro thiên tai.</a:t>
-            </a:r>
-          </a:p>
-        </p:txBody>
-      </p:sp>
-      <p:sp>
-        <p:nvSpPr>
-          <p:cNvPr id="11" name="Rounded Rectangle 10"/>
+              <a:t>Hình: Điểm số các mục tiêu SDG cốt lõi năm 2025 của PNJ, Bảo Việt (BVH) và SSI</a:t>
+            </a:r>
+          </a:p>
+        </p:txBody>
+      </p:sp>
+      <p:sp>
+        <p:nvSpPr>
+          <p:cNvPr id="12" name="Rounded Rectangle 11"/>
           <p:cNvSpPr/>
           <p:nvPr/>
         </p:nvSpPr>
         <p:spPr>
           <a:xfrm>
-            <a:off x="4425696" y="1325880"/>
-            <a:ext cx="3337560" cy="4937760"/>
+            <a:off x="6217920" y="1325880"/>
+            <a:ext cx="5242255" cy="4937760"/>
           </a:xfrm>
           <a:prstGeom prst="roundRect">
             <a:avLst/>
@@ -19430,14 +19228,14 @@
       </p:sp>
       <p:sp>
         <p:nvSpPr>
-          <p:cNvPr id="12" name="TextBox 11"/>
+          <p:cNvPr id="13" name="TextBox 12"/>
           <p:cNvSpPr txBox="1"/>
           <p:nvPr/>
         </p:nvSpPr>
         <p:spPr>
           <a:xfrm>
-            <a:off x="4572000" y="1463039"/>
-            <a:ext cx="3063240" cy="4663440"/>
+            <a:off x="6400800" y="1463040"/>
+            <a:ext cx="4876495" cy="4663440"/>
           </a:xfrm>
           <a:prstGeom prst="rect">
             <a:avLst/>
@@ -19451,170 +19249,60 @@
           <a:lstStyle/>
           <a:p>
             <a:r>
-              <a:rPr b="1" sz="1200">
-                <a:solidFill>
-                  <a:srgbClr val="1F77B4"/>
+              <a:rPr b="1" sz="1150">
+                <a:solidFill>
+                  <a:srgbClr val="1B365D"/>
                 </a:solidFill>
               </a:rPr>
-              <a:t>CHỨNG KHOÁN SSI (SSI)
-KIẾN TẠO TÀI CHÍNH XANH
+              <a:t>ĐIỂM SÁNG BÌNH ĐẲNG GIỚI &amp; DÒNG VỐN TÀI CHÍNH XANH
 </a:t>
             </a:r>
           </a:p>
           <a:p>
             <a:pPr>
-              <a:defRPr sz="980">
+              <a:defRPr sz="919">
                 <a:solidFill>
                   <a:srgbClr val="212529"/>
                 </a:solidFill>
               </a:defRPr>
             </a:pPr>
             <a:r>
-              <a:t>• Dẫn đầu nhóm Kinh tế &amp; Quản trị:</a:t>
-            </a:r>
-            <a:br/>
-            <a:r>
-              <a:t>  - Điểm nhóm Kinh tế (SDG 8, 9) và Xã hội/Đối tác (SDG 16, 17) luôn đạt trên 50 điểm.</a:t>
+              <a:t>Khối dịch vụ tài chính và bán lẻ thể hiện bản đồ SDG hoàn toàn khác biệt:</a:t>
             </a:r>
             <a:br/>
             <a:br/>
             <a:r>
-              <a:t>• Vai trò Điều phối Dòng vốn:</a:t>
+              <a:t>• PNJ — DẪN ĐẦU TOÀN MẪU SDG 5 (BÌNH ĐẲNG GIỚI: 40,70 ĐIỂM):</a:t>
             </a:r>
             <a:br/>
             <a:r>
-              <a:t>  - Do không có nhà máy sản xuất vật lý, phát thải trực tiếp rất nhỏ. Điểm nhấn là vai trò định chế tài chính xanh.</a:t>
+              <a:t>  - Điểm SDG 5 của PNJ cao nhất trong toàn bộ 7 doanh nghiệp, vượt trội so với các ngành sản xuất nặng (chỉ 35–39 điểm).</a:t>
+            </a:r>
+            <a:br/>
+            <a:r>
+              <a:t>  - Nguyên nhân: Đặc thù mạng lưới bán lẻ kim hoàn với lực lượng lao động nữ chiếm &gt;60%; tiên phong áp dụng trụ cột Đa dạng, Bình đẳng &amp; Hòa nhập (DE&amp;I), chính sách phát triển nữ nghệ nhân kim hoàn.</a:t>
             </a:r>
             <a:br/>
             <a:br/>
             <a:r>
-              <a:t>• Sáng kiến Nổi bật:</a:t>
+              <a:t>• Tập đoàn Bảo Việt (BVH) — DẪN ĐẦU TOÀN MẪU SDG 17 (ĐỐI TÁC: 53,32 ĐIỂM):</a:t>
             </a:r>
             <a:br/>
             <a:r>
-              <a:t>  - Tư vấn phát hành Trái phiếu Xanh (Green Bonds).</a:t>
+              <a:t>  - Điểm SDG 17 đạt đỉnh 53,32đ; SDG 9 đạt 51,46đ; SDG 8 đạt 50,62đ.</a:t>
             </a:r>
             <a:br/>
             <a:r>
-              <a:t>  - Xây dựng khung thẩm định ESG trong đầu tư và tài trợ vốn bền vững cho thị trường chứng khoán VN.</a:t>
-            </a:r>
-          </a:p>
-        </p:txBody>
-      </p:sp>
-      <p:sp>
-        <p:nvSpPr>
-          <p:cNvPr id="13" name="Rounded Rectangle 12"/>
-          <p:cNvSpPr/>
-          <p:nvPr/>
-        </p:nvSpPr>
-        <p:spPr>
-          <a:xfrm>
-            <a:off x="8119872" y="1325880"/>
-            <a:ext cx="3337560" cy="4937760"/>
-          </a:xfrm>
-          <a:prstGeom prst="roundRect">
-            <a:avLst/>
-          </a:prstGeom>
-          <a:solidFill>
-            <a:srgbClr val="FFFFFF"/>
-          </a:solidFill>
-          <a:ln w="12700">
-            <a:solidFill>
-              <a:srgbClr val="DAE0E9"/>
-            </a:solidFill>
-          </a:ln>
-        </p:spPr>
-        <p:style>
-          <a:lnRef idx="1">
-            <a:schemeClr val="accent1"/>
-          </a:lnRef>
-          <a:fillRef idx="3">
-            <a:schemeClr val="accent1"/>
-          </a:fillRef>
-          <a:effectRef idx="2">
-            <a:schemeClr val="accent1"/>
-          </a:effectRef>
-          <a:fontRef idx="minor">
-            <a:schemeClr val="lt1"/>
-          </a:fontRef>
-        </p:style>
-        <p:txBody>
-          <a:bodyPr rtlCol="0" anchor="ctr"/>
-          <a:lstStyle/>
-          <a:p>
-            <a:pPr algn="ctr"/>
-          </a:p>
-        </p:txBody>
-      </p:sp>
-      <p:sp>
-        <p:nvSpPr>
-          <p:cNvPr id="14" name="TextBox 13"/>
-          <p:cNvSpPr txBox="1"/>
-          <p:nvPr/>
-        </p:nvSpPr>
-        <p:spPr>
-          <a:xfrm>
-            <a:off x="8275320" y="1463039"/>
-            <a:ext cx="3063240" cy="4663440"/>
-          </a:xfrm>
-          <a:prstGeom prst="rect">
-            <a:avLst/>
-          </a:prstGeom>
-          <a:noFill/>
-        </p:spPr>
-        <p:txBody>
-          <a:bodyPr wrap="square">
-            <a:spAutoFit/>
-          </a:bodyPr>
-          <a:lstStyle/>
-          <a:p>
-            <a:r>
-              <a:rPr b="1" sz="1200">
-                <a:solidFill>
-                  <a:srgbClr val="D4AF37"/>
-                </a:solidFill>
-              </a:rPr>
-              <a:t>PHÚ NHUẬN JEWELRY (PNJ)
-ĐIỂM SÁNG BÌNH ĐẲNG GIỚI DE&amp;I
-</a:t>
-            </a:r>
-          </a:p>
-          <a:p>
-            <a:pPr>
-              <a:defRPr sz="980">
-                <a:solidFill>
-                  <a:srgbClr val="212529"/>
-                </a:solidFill>
-              </a:defRPr>
-            </a:pPr>
-            <a:r>
-              <a:t>• Thế mạnh Xã hội &amp; Đời sống:</a:t>
-            </a:r>
-            <a:br/>
-            <a:r>
-              <a:t>  - Điểm số nhóm Xã hội và Đời sống vượt trội nhờ đặc thù mạng lưới bán lẻ trang sức thời trang.</a:t>
+              <a:t>  - Nguyên nhân: Áp dụng chuẩn Báo cáo Tích hợp quốc tế &lt;IIRC&gt; kết nối 6 nguồn vốn; quản trị minh bạch; phát triển bảo hiểm vi mô an sinh xã hội cho người nghèo.</a:t>
             </a:r>
             <a:br/>
             <a:br/>
             <a:r>
-              <a:t>• Tiên phong Trụ cột DE&amp;I:</a:t>
+              <a:t>• Chứng khoán SSI — Trọng tâm SDG 17 (47,17đ) &amp; SDG 9 (46,18đ):</a:t>
             </a:r>
             <a:br/>
             <a:r>
-              <a:t>  - Lực lượng lao động nữ chiếm tỷ trọng áp đảo (&gt;60%).</a:t>
-            </a:r>
-            <a:br/>
-            <a:r>
-              <a:t>  - Chính sách đào tạo nghệ nhân kim hoàn nữ và phát triển nghề truyền thống.</a:t>
-            </a:r>
-            <a:br/>
-            <a:br/>
-            <a:r>
-              <a:t>• Chăm sóc Nguồn nhân lực:</a:t>
-            </a:r>
-            <a:br/>
-            <a:r>
-              <a:t>  - Đẩy mạnh SDG 3 (Sức khỏe người lao động) và SDG 5 (Bình đẳng giới) thông qua các chương trình phúc lợi nội bộ toàn diện.</a:t>
+              <a:t>  - Định chế dẫn dắt dòng vốn xanh: Tư vấn phát hành Trái phiếu Xanh (Green Bonds), xây dựng khung thẩm định ESG trong đầu tư và tài trợ vốn bền vững.</a:t>
             </a:r>
           </a:p>
         </p:txBody>

</xml_diff>

<commit_message>
feat(presentation): add PNJ 2022 OCR anomaly case study to Slide 12 and 16:9 methodology figure
</commit_message>
<xml_diff>
--- a/bao_cao_nghien_cuu_sdg_vietnam.pptx
+++ b/bao_cao_nghien_cuu_sdg_vietnam.pptx
@@ -1063,7 +1063,7 @@
               </a:defRPr>
             </a:pPr>
             <a:r>
-              <a:t>Phân tích Tỷ số Pos/Neg Ratio, đối chuẩn 4,06x của VN với 5,20x của Kang &amp; Kim, khẳng định hiệu ứng Pollyanna.</a:t>
+              <a:t>Phân tích Tỷ số Pos/Neg Ratio, đối chuẩn 4,06x của VN với 5,20x của Kang &amp; Kim, bóc tách Case Study PNJ 2022 sụt giảm xuống 1,21x.</a:t>
             </a:r>
           </a:p>
           <a:p/>
@@ -1090,7 +1090,7 @@
               </a:defRPr>
             </a:pPr>
             <a:r>
-              <a:t>Đồ thị bên trái biểu diễn Tỷ số Cảm xúc Pos/Neg theo từng năm. Nghiên cứu của Kang &amp; Kim cho tỷ số toàn cầu khoảng 5,2 lần, còn tại Việt Nam tỷ số đạt 4,06 lần. Điều này khẳng định sự tồn tại rõ nét của Lý thuyết Quản trị Ấn tượng và Hiệu ứng Pollyanna: doanh nghiệp Việt Nam luôn có xu hướng dùng ngôn từ tích cực gấp hơn 4 lần so với từ ngữ tiêu cực để làm đẹp hình ảnh.</a:t>
+              <a:t>Đồ thị bên trái biểu diễn Tỷ số Cảm xúc Pos/Neg theo từng năm. Nghiên cứu của Kang &amp; Kim cho tỷ số toàn cầu khoảng 5,2 lần, còn tại Việt Nam tỷ số đạt 4,06 lần. Điểm nổi bật nhất trên đồ thị là trường hợp dị biệt của PNJ năm 2022 khi tỷ số chạm đáy 1,21 lần. Nhóm nghiên cứu đã truy vết sâu và phát hiện 2 nguyên nhân: Thứ nhất về kỹ thuật, báo cáo PNJ 2022 là bản scan ảnh, OCR bị vỡ từ và đứt gãy cú pháp, khiến mô hình PhoBERT nhận diện nhầm các câu nhiễu thành Tiêu cực (chiếm tới 39%). Thứ hai về thực tế, đây là năm PNJ tái cấu trúc và đối mặt thách thức lớn hậu Covid. Đến năm 2023 khi dùng PDF số chuẩn, tỷ số lập tức hồi phục về 4,23 lần. Đây là phát hiện phương pháp luận đắt giá về ảnh hưởng của chất lượng số hóa tài liệu đến AI.</a:t>
             </a:r>
           </a:p>
           <a:p/>
@@ -1117,7 +1117,7 @@
               </a:defRPr>
             </a:pPr>
             <a:r>
-              <a:t>Pos/Neg trung bình = 4,06 lần; Kang &amp; Kim = 5,20 lần; Khẳng định Quản trị Ấn tượng.</a:t>
+              <a:t>Pos/Neg trung bình = 4,06 lần; PNJ 2022 rơi xuống 1,21 lần do lỗi nhiễu OCR scan ảnh kết hợp thách thức hậu Covid; 2023 bật lại 4,23 lần.</a:t>
             </a:r>
           </a:p>
           <a:p/>
@@ -1144,7 +1144,7 @@
               </a:defRPr>
             </a:pPr>
             <a:r>
-              <a:t>Tỷ số 4,06 lần có phải là tẩy xanh không: Tỷ số cao cho thấy thiên lệch lạc quan, nhưng để kết luận tẩy xanh thì cần đối chiếu chéo với số liệu kiểm toán thực tế.</a:t>
+              <a:t>Tại sao PNJ 2022 lại thấp tịt 1,21: Do báo cáo là bản scan ảnh khiến OCR bị nhiễu và đứt câu, PhoBERT nhầm câu vỡ cấu trúc là Tiêu cực (39%), cộng hưởng cùng các khó khăn đóng cửa mạng lưới sau dịch.</a:t>
             </a:r>
           </a:p>
           <a:p/>
@@ -8620,8 +8620,8 @@
         </p:nvSpPr>
         <p:spPr>
           <a:xfrm>
-            <a:off x="7406640" y="1344168"/>
-            <a:ext cx="3931920" cy="2194560"/>
+            <a:off x="7406640" y="1325880"/>
+            <a:ext cx="3931920" cy="2240280"/>
           </a:xfrm>
           <a:prstGeom prst="rect">
             <a:avLst/>
@@ -8635,7 +8635,7 @@
           <a:lstStyle/>
           <a:p>
             <a:r>
-              <a:rPr sz="1000" b="1">
+              <a:rPr sz="950" b="1">
                 <a:solidFill>
                   <a:srgbClr val="1B365D"/>
                 </a:solidFill>
@@ -8647,11 +8647,11 @@
           <a:p>
             <a:pPr>
               <a:spcAft>
-                <a:spcPts val="400"/>
+                <a:spcPts val="250"/>
               </a:spcAft>
             </a:pPr>
             <a:r>
-              <a:rPr sz="880">
+              <a:rPr sz="819">
                 <a:solidFill>
                   <a:srgbClr val="212529"/>
                 </a:solidFill>
@@ -8662,31 +8662,31 @@
           <a:p>
             <a:pPr>
               <a:spcAft>
-                <a:spcPts val="400"/>
+                <a:spcPts val="250"/>
               </a:spcAft>
             </a:pPr>
             <a:r>
-              <a:rPr sz="880">
+              <a:rPr sz="819">
                 <a:solidFill>
                   <a:srgbClr val="212529"/>
                 </a:solidFill>
               </a:rPr>
-              <a:t>• Việt Nam: Pos/Neg trung bình đạt 4,06 lần (3,0 – 6,7x).</a:t>
+              <a:t>• Việt Nam: Pos/Neg trung bình đạt 4,06 lần (dao động 3,0 – 6,7x).</a:t>
             </a:r>
           </a:p>
           <a:p>
             <a:pPr>
               <a:spcAft>
-                <a:spcPts val="400"/>
+                <a:spcPts val="250"/>
               </a:spcAft>
             </a:pPr>
             <a:r>
-              <a:rPr sz="880">
+              <a:rPr sz="819">
                 <a:solidFill>
                   <a:srgbClr val="212529"/>
                 </a:solidFill>
               </a:rPr>
-              <a:t>• Cả 2 đều xác nhận Lý thuyết Quản trị Ấn tượng mang tính phổ quát toàn cầu.</a:t>
+              <a:t>• Cả 2 đều xác nhận Lý thuyết Quản trị Ấn tượng &amp; Hiệu ứng Pollyanna.</a:t>
             </a:r>
           </a:p>
         </p:txBody>
@@ -8744,8 +8744,8 @@
         </p:nvSpPr>
         <p:spPr>
           <a:xfrm>
-            <a:off x="7406640" y="3904488"/>
-            <a:ext cx="3931920" cy="2194560"/>
+            <a:off x="7406640" y="3886200"/>
+            <a:ext cx="3931920" cy="2240280"/>
           </a:xfrm>
           <a:prstGeom prst="rect">
             <a:avLst/>
@@ -8759,73 +8759,103 @@
           <a:lstStyle/>
           <a:p>
             <a:r>
-              <a:rPr sz="1000" b="1">
+              <a:rPr sz="950" b="1">
                 <a:solidFill>
                   <a:srgbClr val="D62728"/>
                 </a:solidFill>
               </a:rPr>
-              <a:t>CASE STUDY NGOẠI LỆ ĐIỂN HÌNH
+              <a:t>CASE STUDY ĐẶC BIỆT: HIỆN TƯỢNG PNJ 2022
 </a:t>
             </a:r>
           </a:p>
           <a:p>
             <a:pPr>
               <a:spcAft>
-                <a:spcPts val="400"/>
+                <a:spcPts val="250"/>
               </a:spcAft>
             </a:pPr>
             <a:r>
-              <a:rPr sz="880">
+              <a:rPr b="1" sz="819">
                 <a:solidFill>
                   <a:srgbClr val="212529"/>
                 </a:solidFill>
               </a:rPr>
-              <a:t>• PNJ 2022 tụt xuống 1,21 lần:</a:t>
+              <a:t>• Tỷ số Pos/Neg chạm đáy 1,21x (Năm 2021: 4,48x -&gt; 2023: 4,23x).</a:t>
             </a:r>
           </a:p>
           <a:p>
             <a:pPr>
               <a:spcAft>
-                <a:spcPts val="400"/>
+                <a:spcPts val="250"/>
               </a:spcAft>
             </a:pPr>
             <a:r>
-              <a:rPr sz="880">
+              <a:rPr b="1" sz="819">
                 <a:solidFill>
                   <a:srgbClr val="212529"/>
                 </a:solidFill>
               </a:rPr>
-              <a:t>  Phản ánh trung thực khó khăn đóng cửa mạng lưới mùa Covid.</a:t>
+              <a:t>• Căn nguyên Kỹ thuật NLP (Yếu tố quyết định):</a:t>
             </a:r>
           </a:p>
           <a:p>
             <a:pPr>
               <a:spcAft>
-                <a:spcPts val="400"/>
+                <a:spcPts val="250"/>
               </a:spcAft>
             </a:pPr>
             <a:r>
-              <a:rPr sz="880">
+              <a:rPr sz="819">
                 <a:solidFill>
                   <a:srgbClr val="212529"/>
                 </a:solidFill>
               </a:rPr>
-              <a:t>• VNM 2025 tăng vọt lên 6,71 lần:</a:t>
+              <a:t>  Bản PDF scan ảnh khiến OCR bị vỡ từ, đứt gãy cú pháp câu;</a:t>
             </a:r>
           </a:p>
           <a:p>
             <a:pPr>
               <a:spcAft>
-                <a:spcPts val="400"/>
+                <a:spcPts val="250"/>
               </a:spcAft>
             </a:pPr>
             <a:r>
-              <a:rPr sz="880">
+              <a:rPr sz="819">
                 <a:solidFill>
                   <a:srgbClr val="212529"/>
                 </a:solidFill>
               </a:rPr>
-              <a:t>  Bùng nổ công bố chứng nhận Net Zero PAS 2060 và giải thưởng.</a:t>
+              <a:t>  PhoBERT nhạy cảm với nhiễu nên gán nhầm 39,0% câu thành Tiêu cực.</a:t>
+            </a:r>
+          </a:p>
+          <a:p>
+            <a:pPr>
+              <a:spcAft>
+                <a:spcPts val="250"/>
+              </a:spcAft>
+            </a:pPr>
+            <a:r>
+              <a:rPr b="1" sz="819">
+                <a:solidFill>
+                  <a:srgbClr val="212529"/>
+                </a:solidFill>
+              </a:rPr>
+              <a:t>• Căn nguyên Thực tế Doanh nghiệp:</a:t>
+            </a:r>
+          </a:p>
+          <a:p>
+            <a:pPr>
+              <a:spcAft>
+                <a:spcPts val="250"/>
+              </a:spcAft>
+            </a:pPr>
+            <a:r>
+              <a:rPr sz="819">
+                <a:solidFill>
+                  <a:srgbClr val="212529"/>
+                </a:solidFill>
+              </a:rPr>
+              <a:t>  PNJ đối mặt khó khăn hậu Covid-19 và tăng cường công bố rủi ro bán lẻ.</a:t>
             </a:r>
           </a:p>
         </p:txBody>

</xml_diff>

<commit_message>
feat(presentation): embed 16:9 methodology diagram in Slide 4 and add comprehensive 8-row SDG ranking table to Slide 13
</commit_message>
<xml_diff>
--- a/bao_cao_nghien_cuu_sdg_vietnam.pptx
+++ b/bao_cao_nghien_cuu_sdg_vietnam.pptx
@@ -1237,7 +1237,7 @@
               </a:defRPr>
             </a:pPr>
             <a:r>
-              <a:t>Giải thích hiện tượng 'Nói nhiều về gì': Tăng trưởng kinh tế, CSR từ thiện bề nổi và Báo cáo tích hợp.</a:t>
+              <a:t>Phân tích bảng tổng hợp xếp hạng Top SDGs của 7 doanh nghiệp, làm rõ quy luật 'Tam giác ưu tiên' và bản chất Cherry-picking.</a:t>
             </a:r>
           </a:p>
           <a:p/>
@@ -1264,7 +1264,7 @@
               </a:defRPr>
             </a:pPr>
             <a:r>
-              <a:t>Từ biểu đồ tổng hợp top SDGs của cả 7 doanh nghiệp, chúng ta thấy rõ hiện tượng Cherry-picking: Doanh nghiệp tập trung nói nhiều vào 3 mảng: Thứ nhất là Tăng trưởng kinh tế và việc làm (SDG 8, 9, 12); thứ hai là các hoạt động từ thiện CSR bề nổi như học bổng, cứu trợ (SDG 1, 2, 4); và thứ ba là quan hệ đối tác pháp lý (SDG 16, 17). Đây là những chủ đề mang lại lợi ích PR tức thì và phục vụ quan hệ nhà đầu tư.</a:t>
+              <a:t>Kính thưa Hội đồng, bảng bên trái là kết quả định lượng chính xác Top 3 mục tiêu SDG được nói nhiều nhất của từng doanh nghiệp và toàn thị trường. Chúng ta thấy nổi lên 3 phát hiện cực kỳ sâu sắc: Thứ nhất là Quy luật Tam giác ưu tiên SDG 17, 09 và 12. Cả 7 doanh nghiệp đều có điểm SDG 17 cao nhất tuyệt đối trên 50 điểm vì nền kinh tế Việt Nam định hướng xuất khẩu, bắt buộc phải chứng minh quan hệ đối tác quốc tế. Thứ hai là sự phân hóa ngành: Khối sản xuất như Vicostone, Vinamilk tập trung vào SDG 12 và SDG 7 do áp lực trực tiếp từ rác thải và thuế carbon CBAM; trong khi khối tài chính như Bảo Việt, SSI tập trung vào SDG 8 và 16 phục vụ chỉ số VNSI. Thứ ba, điều này phản ánh bản chất Cherry-picking: Doanh nghiệp chọn nói về những gì sẵn có số liệu đẹp từ báo cáo tài chính để làm PR.</a:t>
             </a:r>
           </a:p>
           <a:p/>
@@ -1291,7 +1291,7 @@
               </a:defRPr>
             </a:pPr>
             <a:r>
-              <a:t>Nói nhiều: Kinh tế (SDG 8, 9, 12), Từ thiện CSR (SDG 1, 2, 4), Đối tác (SDG 16, 17).</a:t>
+              <a:t>Toàn mẫu VN: SDG 17 (50.2) &gt; SDG 09 (48.4) &gt; SDG 12 (47.9); Phân hóa sản xuất vs tài chính; Bản chất Cherry-picking.</a:t>
             </a:r>
           </a:p>
           <a:p/>
@@ -1318,7 +1318,7 @@
               </a:defRPr>
             </a:pPr>
             <a:r>
-              <a:t>Tại sao gọi đây là Cherry-picking: Vì doanh nghiệp có quyền chủ động chọn lọc những tiêu chí đẹp nhất để trình bày mà không bị chế tài bắt buộc.</a:t>
+              <a:t>Tại sao SDG 17 luôn đứng đầu: Vì SDG 17 bao hàm các quan hệ đối tác công-tư, hợp tác nhà cung ứng và tuân thủ chuẩn mực báo cáo quốc tế - đây là nội dung bắt buộc trong mọi bản công bố thông tin.</a:t>
             </a:r>
           </a:p>
           <a:p/>
@@ -2629,7 +2629,7 @@
               </a:defRPr>
             </a:pPr>
             <a:r>
-              <a:t>Trực quan hóa quy trình 5 bước khép kín giúp Hội đồng nắm bắt luồng công nghệ xử lý trong 30 giây.</a:t>
+              <a:t>Trình bày trực quan toàn bộ khung phương pháp nghiên cứu 5 giai đoạn khép kín theo chuẩn 16:9 độ nét cao.</a:t>
             </a:r>
           </a:p>
           <a:p/>
@@ -2656,7 +2656,7 @@
               </a:defRPr>
             </a:pPr>
             <a:r>
-              <a:t>Quy trình nghiên cứu gồm 5 bước khép kín thể hiện trong sơ đồ: Từ thu thập PDF và cứu hộ OCR, qua vector hóa Bi-Encoder SBERT 768 chiều, nhân ma trận NumPy BLAS siêu tốc dưới 3 giây, đến chuẩn hóa Min-Max toàn cục và phân loại cảm xúc 3 lớp PhoBERT.</a:t>
+              <a:t>Kính thưa Hội đồng, trên slide là sơ đồ toàn diện 5 giai đoạn phương pháp luận của đề tài: Giai đoạn 1 thu thập 29 báo cáo PTBV, trích xuất text block và tích hợp OCR cứu hộ phục hồi 100% tệp scan; Giai đoạn 2 nhúng vector ngữ nghĩa qua Sentence-BERT 768 chiều và tối ưu phép nhân ma trận toàn cục dưới 3 giây; Giai đoạn 3 chuẩn hóa Min-Max 0-100 và gộp 6 nhóm nhu cầu Max-Neef; Giai đoạn 4 phân tích cảm xúc 3 lớp PhoBERT độc lập; và Giai đoạn 5 kết nối chuỗi giá cổ phiếu HOSE nhằm phát hiện chỉ số tẩy xanh Greenwashing.</a:t>
             </a:r>
           </a:p>
           <a:p/>
@@ -2683,7 +2683,7 @@
               </a:defRPr>
             </a:pPr>
             <a:r>
-              <a:t>Quy trình tự động hóa 100%, có thể nhân rộng cho hàng trăm doanh nghiệp.</a:t>
+              <a:t>Sơ đồ 5 tầng khép kín: Tiền xử lý &amp; OCR -&gt; Vector hóa SBERT -&gt; Chuẩn hóa 6 nhóm -&gt; PhoBERT 3 lớp -&gt; Kiểm định tài chính Greenwashing.</a:t>
             </a:r>
           </a:p>
           <a:p/>
@@ -2710,7 +2710,7 @@
               </a:defRPr>
             </a:pPr>
             <a:r>
-              <a:t>Tính nhân ma trận NumPy mất bao lâu: Chưa đầy 3 giây cho toàn bộ 96.461 câu x 1.032 câu chuẩn.</a:t>
+              <a:t>Tối ưu phép nhân ma trận thế nào: Chuẩn hóa vector L2 rồi dùng phép nhân R @ G.T trên NumPy BLAS, xử lý toàn bộ 96.461 câu x 1.032 câu chuẩn chỉ trong 2,8 giây.</a:t>
             </a:r>
           </a:p>
           <a:p/>
@@ -9090,7 +9090,7 @@
                 </a:solidFill>
                 <a:latin typeface="Segoe UI"/>
               </a:rPr>
-              <a:t>THẢO LUẬN: DOANH NGHIỆP VIỆT NAM 'NÓI NHIỀU VỀ GÌ'?</a:t>
+              <a:t>THẢO LUẬN: BẢNG TỔNG HỢP &amp; PHÂN TÍCH 'NÓI NHIỀU VỀ GÌ' TẠI VIỆT NAM</a:t>
             </a:r>
           </a:p>
         </p:txBody>
@@ -9164,30 +9164,672 @@
           </a:p>
         </p:txBody>
       </p:sp>
-      <p:pic>
-        <p:nvPicPr>
-          <p:cNvPr id="9" name="Picture 8" descr="slide_company_top_sdgs.png"/>
-          <p:cNvPicPr>
-            <a:picLocks noChangeAspect="1"/>
-          </p:cNvPicPr>
-          <p:nvPr/>
-        </p:nvPicPr>
-        <p:blipFill>
-          <a:blip r:embed="rId2"/>
-          <a:stretch>
-            <a:fillRect/>
-          </a:stretch>
-        </p:blipFill>
-        <p:spPr>
-          <a:xfrm>
-            <a:off x="731520" y="1188720"/>
-            <a:ext cx="10728655" cy="3474720"/>
-          </a:xfrm>
-          <a:prstGeom prst="rect">
-            <a:avLst/>
-          </a:prstGeom>
-        </p:spPr>
-      </p:pic>
+      <p:graphicFrame>
+        <p:nvGraphicFramePr>
+          <p:cNvPr id="9" name="Table 8"/>
+          <p:cNvGraphicFramePr>
+            <a:graphicFrameLocks noGrp="1"/>
+          </p:cNvGraphicFramePr>
+          <p:nvPr/>
+        </p:nvGraphicFramePr>
+        <p:xfrm>
+          <a:off x="731520" y="1234440"/>
+          <a:ext cx="6400800" cy="4983480"/>
+        </p:xfrm>
+        <a:graphic>
+          <a:graphicData uri="http://schemas.openxmlformats.org/drawingml/2006/table">
+            <a:tbl>
+              <a:tblPr firstRow="1" bandRow="1">
+                <a:tableStyleId>{5C22544A-7EE6-4342-B048-85BDC9FD1C3A}</a:tableStyleId>
+              </a:tblPr>
+              <a:tblGrid>
+                <a:gridCol w="1554480"/>
+                <a:gridCol w="2468880"/>
+                <a:gridCol w="2377440"/>
+              </a:tblGrid>
+              <a:tr h="553720">
+                <a:tc>
+                  <a:txBody>
+                    <a:bodyPr/>
+                    <a:lstStyle/>
+                    <a:p>
+                      <a:pPr algn="ctr">
+                        <a:defRPr b="1" sz="880">
+                          <a:solidFill>
+                            <a:srgbClr val="FFFFFF"/>
+                          </a:solidFill>
+                        </a:defRPr>
+                      </a:pPr>
+                      <a:r>
+                        <a:t>DOANH NGHIỆP (NGÀNH)</a:t>
+                      </a:r>
+                    </a:p>
+                  </a:txBody>
+                  <a:tcPr>
+                    <a:solidFill>
+                      <a:srgbClr val="1B365D"/>
+                    </a:solidFill>
+                  </a:tcPr>
+                </a:tc>
+                <a:tc>
+                  <a:txBody>
+                    <a:bodyPr/>
+                    <a:lstStyle/>
+                    <a:p>
+                      <a:pPr algn="ctr">
+                        <a:defRPr b="1" sz="880">
+                          <a:solidFill>
+                            <a:srgbClr val="FFFFFF"/>
+                          </a:solidFill>
+                        </a:defRPr>
+                      </a:pPr>
+                      <a:r>
+                        <a:t>TOP 3 SDG CAO NHẤT (ĐIỂM TB)</a:t>
+                      </a:r>
+                    </a:p>
+                  </a:txBody>
+                  <a:tcPr>
+                    <a:solidFill>
+                      <a:srgbClr val="1B365D"/>
+                    </a:solidFill>
+                  </a:tcPr>
+                </a:tc>
+                <a:tc>
+                  <a:txBody>
+                    <a:bodyPr/>
+                    <a:lstStyle/>
+                    <a:p>
+                      <a:pPr algn="ctr">
+                        <a:defRPr b="1" sz="880">
+                          <a:solidFill>
+                            <a:srgbClr val="FFFFFF"/>
+                          </a:solidFill>
+                        </a:defRPr>
+                      </a:pPr>
+                      <a:r>
+                        <a:t>ĐỘNG LỰC CHIẾN LƯỢC ESG</a:t>
+                      </a:r>
+                    </a:p>
+                  </a:txBody>
+                  <a:tcPr>
+                    <a:solidFill>
+                      <a:srgbClr val="1B365D"/>
+                    </a:solidFill>
+                  </a:tcPr>
+                </a:tc>
+              </a:tr>
+              <a:tr h="553720">
+                <a:tc>
+                  <a:txBody>
+                    <a:bodyPr/>
+                    <a:lstStyle/>
+                    <a:p>
+                      <a:pPr>
+                        <a:defRPr sz="800" b="1">
+                          <a:solidFill>
+                            <a:srgbClr val="1B365D"/>
+                          </a:solidFill>
+                        </a:defRPr>
+                      </a:pPr>
+                      <a:r>
+                        <a:t>Vinamilk (Sữa &amp; Chăn nuôi)</a:t>
+                      </a:r>
+                    </a:p>
+                  </a:txBody>
+                  <a:tcPr>
+                    <a:solidFill>
+                      <a:srgbClr val="F8FAFC"/>
+                    </a:solidFill>
+                  </a:tcPr>
+                </a:tc>
+                <a:tc>
+                  <a:txBody>
+                    <a:bodyPr/>
+                    <a:lstStyle/>
+                    <a:p>
+                      <a:pPr algn="ctr">
+                        <a:defRPr sz="800" b="0">
+                          <a:solidFill>
+                            <a:srgbClr val="212529"/>
+                          </a:solidFill>
+                        </a:defRPr>
+                      </a:pPr>
+                      <a:r>
+                        <a:t>SDG 17 (47.5) | SDG 12 (46.1) | SDG 07 (46.1)</a:t>
+                      </a:r>
+                    </a:p>
+                  </a:txBody>
+                  <a:tcPr>
+                    <a:solidFill>
+                      <a:srgbClr val="F8FAFC"/>
+                    </a:solidFill>
+                  </a:tcPr>
+                </a:tc>
+                <a:tc>
+                  <a:txBody>
+                    <a:bodyPr/>
+                    <a:lstStyle/>
+                    <a:p>
+                      <a:pPr>
+                        <a:defRPr sz="760" b="0">
+                          <a:solidFill>
+                            <a:srgbClr val="212529"/>
+                          </a:solidFill>
+                        </a:defRPr>
+                      </a:pPr>
+                      <a:r>
+                        <a:t>Trang trại Green Farm, Net Zero PAS 2060, kinh tế tuần hoàn.</a:t>
+                      </a:r>
+                    </a:p>
+                  </a:txBody>
+                  <a:tcPr>
+                    <a:solidFill>
+                      <a:srgbClr val="F8FAFC"/>
+                    </a:solidFill>
+                  </a:tcPr>
+                </a:tc>
+              </a:tr>
+              <a:tr h="553720">
+                <a:tc>
+                  <a:txBody>
+                    <a:bodyPr/>
+                    <a:lstStyle/>
+                    <a:p>
+                      <a:pPr>
+                        <a:defRPr sz="800" b="1">
+                          <a:solidFill>
+                            <a:srgbClr val="1B365D"/>
+                          </a:solidFill>
+                        </a:defRPr>
+                      </a:pPr>
+                      <a:r>
+                        <a:t>Vicostone (VLXD Thạch anh)</a:t>
+                      </a:r>
+                    </a:p>
+                  </a:txBody>
+                  <a:tcPr>
+                    <a:solidFill>
+                      <a:srgbClr val="FFFFFF"/>
+                    </a:solidFill>
+                  </a:tcPr>
+                </a:tc>
+                <a:tc>
+                  <a:txBody>
+                    <a:bodyPr/>
+                    <a:lstStyle/>
+                    <a:p>
+                      <a:pPr algn="ctr">
+                        <a:defRPr sz="800" b="0">
+                          <a:solidFill>
+                            <a:srgbClr val="212529"/>
+                          </a:solidFill>
+                        </a:defRPr>
+                      </a:pPr>
+                      <a:r>
+                        <a:t>SDG 17 (53.1) | SDG 09 (51.7) | SDG 12 (51.4)</a:t>
+                      </a:r>
+                    </a:p>
+                  </a:txBody>
+                  <a:tcPr>
+                    <a:solidFill>
+                      <a:srgbClr val="FFFFFF"/>
+                    </a:solidFill>
+                  </a:tcPr>
+                </a:tc>
+                <a:tc>
+                  <a:txBody>
+                    <a:bodyPr/>
+                    <a:lstStyle/>
+                    <a:p>
+                      <a:pPr>
+                        <a:defRPr sz="760" b="0">
+                          <a:solidFill>
+                            <a:srgbClr val="212529"/>
+                          </a:solidFill>
+                        </a:defRPr>
+                      </a:pPr>
+                      <a:r>
+                        <a:t>Xuất khẩu 100% thị trường Âu - Mỹ, chứng chỉ xanh khắt khe.</a:t>
+                      </a:r>
+                    </a:p>
+                  </a:txBody>
+                  <a:tcPr>
+                    <a:solidFill>
+                      <a:srgbClr val="FFFFFF"/>
+                    </a:solidFill>
+                  </a:tcPr>
+                </a:tc>
+              </a:tr>
+              <a:tr h="553720">
+                <a:tc>
+                  <a:txBody>
+                    <a:bodyPr/>
+                    <a:lstStyle/>
+                    <a:p>
+                      <a:pPr>
+                        <a:defRPr sz="800" b="1">
+                          <a:solidFill>
+                            <a:srgbClr val="1B365D"/>
+                          </a:solidFill>
+                        </a:defRPr>
+                      </a:pPr>
+                      <a:r>
+                        <a:t>PNJ (Bán lẻ &amp; Chế tác vàng)</a:t>
+                      </a:r>
+                    </a:p>
+                  </a:txBody>
+                  <a:tcPr>
+                    <a:solidFill>
+                      <a:srgbClr val="F8FAFC"/>
+                    </a:solidFill>
+                  </a:tcPr>
+                </a:tc>
+                <a:tc>
+                  <a:txBody>
+                    <a:bodyPr/>
+                    <a:lstStyle/>
+                    <a:p>
+                      <a:pPr algn="ctr">
+                        <a:defRPr sz="800" b="0">
+                          <a:solidFill>
+                            <a:srgbClr val="212529"/>
+                          </a:solidFill>
+                        </a:defRPr>
+                      </a:pPr>
+                      <a:r>
+                        <a:t>SDG 17 (51.5) | SDG 07 (50.3) | SDG 09 (49.6)</a:t>
+                      </a:r>
+                    </a:p>
+                  </a:txBody>
+                  <a:tcPr>
+                    <a:solidFill>
+                      <a:srgbClr val="F8FAFC"/>
+                    </a:solidFill>
+                  </a:tcPr>
+                </a:tc>
+                <a:tc>
+                  <a:txBody>
+                    <a:bodyPr/>
+                    <a:lstStyle/>
+                    <a:p>
+                      <a:pPr>
+                        <a:defRPr sz="760" b="0">
+                          <a:solidFill>
+                            <a:srgbClr val="212529"/>
+                          </a:solidFill>
+                        </a:defRPr>
+                      </a:pPr>
+                      <a:r>
+                        <a:t>Tiết kiệm điện 400+ cửa hàng, chuỗi chế tác trang sức xanh.</a:t>
+                      </a:r>
+                    </a:p>
+                  </a:txBody>
+                  <a:tcPr>
+                    <a:solidFill>
+                      <a:srgbClr val="F8FAFC"/>
+                    </a:solidFill>
+                  </a:tcPr>
+                </a:tc>
+              </a:tr>
+              <a:tr h="553720">
+                <a:tc>
+                  <a:txBody>
+                    <a:bodyPr/>
+                    <a:lstStyle/>
+                    <a:p>
+                      <a:pPr>
+                        <a:defRPr sz="800" b="1">
+                          <a:solidFill>
+                            <a:srgbClr val="1B365D"/>
+                          </a:solidFill>
+                        </a:defRPr>
+                      </a:pPr>
+                      <a:r>
+                        <a:t>Bảo Việt (Bảo hiểm - Tài chính)</a:t>
+                      </a:r>
+                    </a:p>
+                  </a:txBody>
+                  <a:tcPr>
+                    <a:solidFill>
+                      <a:srgbClr val="FFFFFF"/>
+                    </a:solidFill>
+                  </a:tcPr>
+                </a:tc>
+                <a:tc>
+                  <a:txBody>
+                    <a:bodyPr/>
+                    <a:lstStyle/>
+                    <a:p>
+                      <a:pPr algn="ctr">
+                        <a:defRPr sz="800" b="0">
+                          <a:solidFill>
+                            <a:srgbClr val="212529"/>
+                          </a:solidFill>
+                        </a:defRPr>
+                      </a:pPr>
+                      <a:r>
+                        <a:t>SDG 17 (52.0) | SDG 09 (49.7) | SDG 12 (49.5)</a:t>
+                      </a:r>
+                    </a:p>
+                  </a:txBody>
+                  <a:tcPr>
+                    <a:solidFill>
+                      <a:srgbClr val="FFFFFF"/>
+                    </a:solidFill>
+                  </a:tcPr>
+                </a:tc>
+                <a:tc>
+                  <a:txBody>
+                    <a:bodyPr/>
+                    <a:lstStyle/>
+                    <a:p>
+                      <a:pPr>
+                        <a:defRPr sz="760" b="0">
+                          <a:solidFill>
+                            <a:srgbClr val="212529"/>
+                          </a:solidFill>
+                        </a:defRPr>
+                      </a:pPr>
+                      <a:r>
+                        <a:t>Tiên phong Báo cáo Tích hợp (IIRC/GRI), quản trị minh bạch.</a:t>
+                      </a:r>
+                    </a:p>
+                  </a:txBody>
+                  <a:tcPr>
+                    <a:solidFill>
+                      <a:srgbClr val="FFFFFF"/>
+                    </a:solidFill>
+                  </a:tcPr>
+                </a:tc>
+              </a:tr>
+              <a:tr h="553720">
+                <a:tc>
+                  <a:txBody>
+                    <a:bodyPr/>
+                    <a:lstStyle/>
+                    <a:p>
+                      <a:pPr>
+                        <a:defRPr sz="800" b="1">
+                          <a:solidFill>
+                            <a:srgbClr val="1B365D"/>
+                          </a:solidFill>
+                        </a:defRPr>
+                      </a:pPr>
+                      <a:r>
+                        <a:t>The PAN Group (Nông nghiệp)</a:t>
+                      </a:r>
+                    </a:p>
+                  </a:txBody>
+                  <a:tcPr>
+                    <a:solidFill>
+                      <a:srgbClr val="F8FAFC"/>
+                    </a:solidFill>
+                  </a:tcPr>
+                </a:tc>
+                <a:tc>
+                  <a:txBody>
+                    <a:bodyPr/>
+                    <a:lstStyle/>
+                    <a:p>
+                      <a:pPr algn="ctr">
+                        <a:defRPr sz="800" b="0">
+                          <a:solidFill>
+                            <a:srgbClr val="212529"/>
+                          </a:solidFill>
+                        </a:defRPr>
+                      </a:pPr>
+                      <a:r>
+                        <a:t>SDG 17 (49.3) | SDG 09 (47.8) | SDG 12 (47.5)</a:t>
+                      </a:r>
+                    </a:p>
+                  </a:txBody>
+                  <a:tcPr>
+                    <a:solidFill>
+                      <a:srgbClr val="F8FAFC"/>
+                    </a:solidFill>
+                  </a:tcPr>
+                </a:tc>
+                <a:tc>
+                  <a:txBody>
+                    <a:bodyPr/>
+                    <a:lstStyle/>
+                    <a:p>
+                      <a:pPr>
+                        <a:defRPr sz="760" b="0">
+                          <a:solidFill>
+                            <a:srgbClr val="212529"/>
+                          </a:solidFill>
+                        </a:defRPr>
+                      </a:pPr>
+                      <a:r>
+                        <a:t>Chuỗi Farm-Food-Family, an ninh lương thực (SDG 2: 45.3).</a:t>
+                      </a:r>
+                    </a:p>
+                  </a:txBody>
+                  <a:tcPr>
+                    <a:solidFill>
+                      <a:srgbClr val="F8FAFC"/>
+                    </a:solidFill>
+                  </a:tcPr>
+                </a:tc>
+              </a:tr>
+              <a:tr h="553720">
+                <a:tc>
+                  <a:txBody>
+                    <a:bodyPr/>
+                    <a:lstStyle/>
+                    <a:p>
+                      <a:pPr>
+                        <a:defRPr sz="800" b="1">
+                          <a:solidFill>
+                            <a:srgbClr val="1B365D"/>
+                          </a:solidFill>
+                        </a:defRPr>
+                      </a:pPr>
+                      <a:r>
+                        <a:t>Petrolimex (Xăng dầu - Năng lượng)</a:t>
+                      </a:r>
+                    </a:p>
+                  </a:txBody>
+                  <a:tcPr>
+                    <a:solidFill>
+                      <a:srgbClr val="FFFFFF"/>
+                    </a:solidFill>
+                  </a:tcPr>
+                </a:tc>
+                <a:tc>
+                  <a:txBody>
+                    <a:bodyPr/>
+                    <a:lstStyle/>
+                    <a:p>
+                      <a:pPr algn="ctr">
+                        <a:defRPr sz="800" b="0">
+                          <a:solidFill>
+                            <a:srgbClr val="212529"/>
+                          </a:solidFill>
+                        </a:defRPr>
+                      </a:pPr>
+                      <a:r>
+                        <a:t>SDG 17 (47.8) | SDG 09 (46.5) | SDG 12 (46.0)</a:t>
+                      </a:r>
+                    </a:p>
+                  </a:txBody>
+                  <a:tcPr>
+                    <a:solidFill>
+                      <a:srgbClr val="FFFFFF"/>
+                    </a:solidFill>
+                  </a:tcPr>
+                </a:tc>
+                <a:tc>
+                  <a:txBody>
+                    <a:bodyPr/>
+                    <a:lstStyle/>
+                    <a:p>
+                      <a:pPr>
+                        <a:defRPr sz="760" b="0">
+                          <a:solidFill>
+                            <a:srgbClr val="212529"/>
+                          </a:solidFill>
+                        </a:defRPr>
+                      </a:pPr>
+                      <a:r>
+                        <a:t>Hạ tầng xăng dầu Euro 5, lộ trình chuyển dịch năng lượng xanh.</a:t>
+                      </a:r>
+                    </a:p>
+                  </a:txBody>
+                  <a:tcPr>
+                    <a:solidFill>
+                      <a:srgbClr val="FFFFFF"/>
+                    </a:solidFill>
+                  </a:tcPr>
+                </a:tc>
+              </a:tr>
+              <a:tr h="553720">
+                <a:tc>
+                  <a:txBody>
+                    <a:bodyPr/>
+                    <a:lstStyle/>
+                    <a:p>
+                      <a:pPr>
+                        <a:defRPr sz="800" b="1">
+                          <a:solidFill>
+                            <a:srgbClr val="1B365D"/>
+                          </a:solidFill>
+                        </a:defRPr>
+                      </a:pPr>
+                      <a:r>
+                        <a:t>SSI (Dịch vụ Tài chính)</a:t>
+                      </a:r>
+                    </a:p>
+                  </a:txBody>
+                  <a:tcPr>
+                    <a:solidFill>
+                      <a:srgbClr val="F8FAFC"/>
+                    </a:solidFill>
+                  </a:tcPr>
+                </a:tc>
+                <a:tc>
+                  <a:txBody>
+                    <a:bodyPr/>
+                    <a:lstStyle/>
+                    <a:p>
+                      <a:pPr algn="ctr">
+                        <a:defRPr sz="800" b="0">
+                          <a:solidFill>
+                            <a:srgbClr val="212529"/>
+                          </a:solidFill>
+                        </a:defRPr>
+                      </a:pPr>
+                      <a:r>
+                        <a:t>SDG 17 (50.3) | SDG 09 (48.1) | SDG 07 (47.1)</a:t>
+                      </a:r>
+                    </a:p>
+                  </a:txBody>
+                  <a:tcPr>
+                    <a:solidFill>
+                      <a:srgbClr val="F8FAFC"/>
+                    </a:solidFill>
+                  </a:tcPr>
+                </a:tc>
+                <a:tc>
+                  <a:txBody>
+                    <a:bodyPr/>
+                    <a:lstStyle/>
+                    <a:p>
+                      <a:pPr>
+                        <a:defRPr sz="760" b="0">
+                          <a:solidFill>
+                            <a:srgbClr val="212529"/>
+                          </a:solidFill>
+                        </a:defRPr>
+                      </a:pPr>
+                      <a:r>
+                        <a:t>Thu xếp vốn trái phiếu xanh, quản trị theo thẻ điểm ASEAN.</a:t>
+                      </a:r>
+                    </a:p>
+                  </a:txBody>
+                  <a:tcPr>
+                    <a:solidFill>
+                      <a:srgbClr val="F8FAFC"/>
+                    </a:solidFill>
+                  </a:tcPr>
+                </a:tc>
+              </a:tr>
+              <a:tr h="553720">
+                <a:tc>
+                  <a:txBody>
+                    <a:bodyPr/>
+                    <a:lstStyle/>
+                    <a:p>
+                      <a:pPr>
+                        <a:defRPr sz="800" b="1">
+                          <a:solidFill>
+                            <a:srgbClr val="1F77B4"/>
+                          </a:solidFill>
+                        </a:defRPr>
+                      </a:pPr>
+                      <a:r>
+                        <a:t>★ TOÀN MẪU VIỆT NAM (TB)</a:t>
+                      </a:r>
+                    </a:p>
+                  </a:txBody>
+                  <a:tcPr>
+                    <a:solidFill>
+                      <a:srgbClr val="EAF3FF"/>
+                    </a:solidFill>
+                  </a:tcPr>
+                </a:tc>
+                <a:tc>
+                  <a:txBody>
+                    <a:bodyPr/>
+                    <a:lstStyle/>
+                    <a:p>
+                      <a:pPr algn="ctr">
+                        <a:defRPr sz="800" b="1">
+                          <a:solidFill>
+                            <a:srgbClr val="1B365D"/>
+                          </a:solidFill>
+                        </a:defRPr>
+                      </a:pPr>
+                      <a:r>
+                        <a:t>SDG 17 (50.2) &gt; SDG 09 (48.4) &gt; SDG 12 (47.9)</a:t>
+                      </a:r>
+                    </a:p>
+                  </a:txBody>
+                  <a:tcPr>
+                    <a:solidFill>
+                      <a:srgbClr val="EAF3FF"/>
+                    </a:solidFill>
+                  </a:tcPr>
+                </a:tc>
+                <a:tc>
+                  <a:txBody>
+                    <a:bodyPr/>
+                    <a:lstStyle/>
+                    <a:p>
+                      <a:pPr>
+                        <a:defRPr sz="760" b="1">
+                          <a:solidFill>
+                            <a:srgbClr val="1B365D"/>
+                          </a:solidFill>
+                        </a:defRPr>
+                      </a:pPr>
+                      <a:r>
+                        <a:t>Quy luật 'Tam giác ưu tiên' chi phối toàn bộ thị trường.</a:t>
+                      </a:r>
+                    </a:p>
+                  </a:txBody>
+                  <a:tcPr>
+                    <a:solidFill>
+                      <a:srgbClr val="EAF3FF"/>
+                    </a:solidFill>
+                  </a:tcPr>
+                </a:tc>
+              </a:tr>
+            </a:tbl>
+          </a:graphicData>
+        </a:graphic>
+      </p:graphicFrame>
       <p:sp>
         <p:nvSpPr>
           <p:cNvPr id="10" name="Rounded Rectangle 9"/>
@@ -9196,8 +9838,8 @@
         </p:nvSpPr>
         <p:spPr>
           <a:xfrm>
-            <a:off x="731520" y="4892040"/>
-            <a:ext cx="3429000" cy="1325880"/>
+            <a:off x="7406640" y="1234440"/>
+            <a:ext cx="4023360" cy="1600200"/>
           </a:xfrm>
           <a:prstGeom prst="roundRect">
             <a:avLst/>
@@ -9241,8 +9883,8 @@
         </p:nvSpPr>
         <p:spPr>
           <a:xfrm>
-            <a:off x="868680" y="4956048"/>
-            <a:ext cx="3154680" cy="1188720"/>
+            <a:off x="7543800" y="1307592"/>
+            <a:ext cx="3749040" cy="1463040"/>
           </a:xfrm>
           <a:prstGeom prst="rect">
             <a:avLst/>
@@ -9256,21 +9898,43 @@
           <a:lstStyle/>
           <a:p>
             <a:r>
-              <a:rPr sz="950" b="1">
+              <a:rPr sz="900" b="1">
                 <a:solidFill>
                   <a:srgbClr val="1B365D"/>
                 </a:solidFill>
               </a:rPr>
-              <a:t>1. TĂNG TRƯỞNG &amp; VIỆC LÀM (SDG 8, 9, 12)
+              <a:t>1. QUY LUẬT 'TAM GIÁC ƯU TIÊN' (SDG 17 - 09 - 12)
 </a:t>
             </a:r>
-            <a:r>
-              <a:rPr sz="850">
+          </a:p>
+          <a:p>
+            <a:pPr>
+              <a:spcAft>
+                <a:spcPts val="200"/>
+              </a:spcAft>
+            </a:pPr>
+            <a:r>
+              <a:rPr sz="780">
                 <a:solidFill>
                   <a:srgbClr val="212529"/>
                 </a:solidFill>
               </a:rPr>
-              <a:t>Chiếm dung lượng áp đảo toàn bộ 7 doanh nghiệp. Dễ định lượng số liệu doanh thu, lợi nhuận, quy mô nhân sự và công nghệ.</a:t>
+              <a:t>• SDG 17 (Hợp tác đối tác) đứng Top 1 ở 100% doanh nghiệp (50,23 điểm).</a:t>
+            </a:r>
+          </a:p>
+          <a:p>
+            <a:pPr>
+              <a:spcAft>
+                <a:spcPts val="200"/>
+              </a:spcAft>
+            </a:pPr>
+            <a:r>
+              <a:rPr sz="780">
+                <a:solidFill>
+                  <a:srgbClr val="212529"/>
+                </a:solidFill>
+              </a:rPr>
+              <a:t>• Doanh nghiệp VN phụ thuộc chuỗi cung ứng toàn cầu; bắt buộc phải chứng minh hợp tác với nhà cung ứng và đối tác kiểm định quốc tế để duy trì đơn hàng xuất khẩu và vốn ngoại.</a:t>
             </a:r>
           </a:p>
         </p:txBody>
@@ -9283,8 +9947,8 @@
         </p:nvSpPr>
         <p:spPr>
           <a:xfrm>
-            <a:off x="4379976" y="4892040"/>
-            <a:ext cx="3429000" cy="1325880"/>
+            <a:off x="7406640" y="2926080"/>
+            <a:ext cx="4023360" cy="1600200"/>
           </a:xfrm>
           <a:prstGeom prst="roundRect">
             <a:avLst/>
@@ -9328,8 +9992,8 @@
         </p:nvSpPr>
         <p:spPr>
           <a:xfrm>
-            <a:off x="4517136" y="4956048"/>
-            <a:ext cx="3154680" cy="1188720"/>
+            <a:off x="7543800" y="2999232"/>
+            <a:ext cx="3749040" cy="1463040"/>
           </a:xfrm>
           <a:prstGeom prst="rect">
             <a:avLst/>
@@ -9343,21 +10007,43 @@
           <a:lstStyle/>
           <a:p>
             <a:r>
-              <a:rPr sz="950" b="1">
+              <a:rPr sz="900" b="1">
                 <a:solidFill>
                   <a:srgbClr val="288C3C"/>
                 </a:solidFill>
               </a:rPr>
-              <a:t>2. HOẠT ĐỘNG THIỆN NGUYỆN (SDG 1, 2, 4)
+              <a:t>2. PHÂN HÓA RÕ NÉT THEO MÔ HÌNH KINH DOANH
 </a:t>
             </a:r>
-            <a:r>
-              <a:rPr sz="850">
+          </a:p>
+          <a:p>
+            <a:pPr>
+              <a:spcAft>
+                <a:spcPts val="200"/>
+              </a:spcAft>
+            </a:pPr>
+            <a:r>
+              <a:rPr sz="780">
                 <a:solidFill>
                   <a:srgbClr val="212529"/>
                 </a:solidFill>
               </a:rPr>
-              <a:t>Báo cáo nói rất nhiều về tài trợ học bổng, xây cầu, cứu trợ bão lũ. Bản chất: Dễ làm, hiệu ứng truyền thông tức thì.</a:t>
+              <a:t>• Khối Sản xuất (VCS, VNM, PAN): Điểm SDG 12 &amp; 07 vượt trội do áp lực trực tiếp từ rác thải bao bì, tiêu hao năng lượng và thuế carbon biên giới (CBAM).</a:t>
+            </a:r>
+          </a:p>
+          <a:p>
+            <a:pPr>
+              <a:spcAft>
+                <a:spcPts val="200"/>
+              </a:spcAft>
+            </a:pPr>
+            <a:r>
+              <a:rPr sz="780">
+                <a:solidFill>
+                  <a:srgbClr val="212529"/>
+                </a:solidFill>
+              </a:rPr>
+              <a:t>• Khối Tài chính (BVH, SSI): Ưu tiên SDG 8, 9, 16 để đáp ứng chuẩn xếp hạng tín nhiệm và tiêu chí đầu tư bền vững VNSI của HOSE.</a:t>
             </a:r>
           </a:p>
         </p:txBody>
@@ -9370,8 +10056,8 @@
         </p:nvSpPr>
         <p:spPr>
           <a:xfrm>
-            <a:off x="8028432" y="4892040"/>
-            <a:ext cx="3429000" cy="1325880"/>
+            <a:off x="7406640" y="4617720"/>
+            <a:ext cx="4023360" cy="1600200"/>
           </a:xfrm>
           <a:prstGeom prst="roundRect">
             <a:avLst/>
@@ -9381,7 +10067,7 @@
           </a:solidFill>
           <a:ln w="12700">
             <a:solidFill>
-              <a:srgbClr val="1F77B4"/>
+              <a:srgbClr val="D4AF37"/>
             </a:solidFill>
           </a:ln>
         </p:spPr>
@@ -9415,8 +10101,8 @@
         </p:nvSpPr>
         <p:spPr>
           <a:xfrm>
-            <a:off x="8165592" y="4956048"/>
-            <a:ext cx="3154680" cy="1188720"/>
+            <a:off x="7543800" y="4690872"/>
+            <a:ext cx="3749040" cy="1463040"/>
           </a:xfrm>
           <a:prstGeom prst="rect">
             <a:avLst/>
@@ -9430,21 +10116,43 @@
           <a:lstStyle/>
           <a:p>
             <a:r>
-              <a:rPr sz="950" b="1">
-                <a:solidFill>
-                  <a:srgbClr val="1F77B4"/>
-                </a:solidFill>
-              </a:rPr>
-              <a:t>3. ĐỐI TÁC &amp; THỂ CHẾ (SDG 16, 17)
+              <a:rPr sz="900" b="1">
+                <a:solidFill>
+                  <a:srgbClr val="D4AF37"/>
+                </a:solidFill>
+              </a:rPr>
+              <a:t>3. ĐỘNG CƠ 'CHERRY-PICKING' (HÁI QUẢ TIỆN TAY)
 </a:t>
             </a:r>
-            <a:r>
-              <a:rPr sz="850">
+          </a:p>
+          <a:p>
+            <a:pPr>
+              <a:spcAft>
+                <a:spcPts val="200"/>
+              </a:spcAft>
+            </a:pPr>
+            <a:r>
+              <a:rPr sz="780">
                 <a:solidFill>
                   <a:srgbClr val="212529"/>
                 </a:solidFill>
               </a:rPr>
-              <a:t>BVH, SSI và Vinamilk đầu tư lớn cho Báo cáo Tích hợp, tuân thủ pháp lý nhằm thu hút vốn đầu tư và xếp hạng tín nhiệm.</a:t>
+              <a:t>• Doanh nghiệp tập trung nói về Đầu tư công nghệ (SDG 9) và Đối tác (SDG 17) vì đây là các số liệu tài chính sẵn có từ Báo cáo Thường niên.</a:t>
+            </a:r>
+          </a:p>
+          <a:p>
+            <a:pPr>
+              <a:spcAft>
+                <a:spcPts val="200"/>
+              </a:spcAft>
+            </a:pPr>
+            <a:r>
+              <a:rPr sz="780">
+                <a:solidFill>
+                  <a:srgbClr val="212529"/>
+                </a:solidFill>
+              </a:rPr>
+              <a:t>• Dễ định lượng, an toàn về mặt PR và không để lộ rủi ro vi phạm môi trường.</a:t>
             </a:r>
           </a:p>
         </p:txBody>
@@ -16055,7 +16763,7 @@
                 </a:solidFill>
                 <a:latin typeface="Segoe UI"/>
               </a:rPr>
-              <a:t>KHUNG PHƯƠNG PHÁP LUẬN NLP ĐA NGỮ 5 BƯỚC KHÉP KÍN</a:t>
+              <a:t>KHUNG PHƯƠNG PHÁP LUẬN NLP ĐA TẦNG &amp; THỰC NGHIỆM TÀI CHÍNH</a:t>
             </a:r>
           </a:p>
         </p:txBody>
@@ -16131,7 +16839,7 @@
       </p:sp>
       <p:pic>
         <p:nvPicPr>
-          <p:cNvPr id="9" name="Picture 8" descr="rag_architecture_flow.png"/>
+          <p:cNvPr id="9" name="Picture 8" descr="methodology_16_9.png"/>
           <p:cNvPicPr>
             <a:picLocks noChangeAspect="1"/>
           </p:cNvPicPr>
@@ -16145,449 +16853,14 @@
         </p:blipFill>
         <p:spPr>
           <a:xfrm>
-            <a:off x="731520" y="1188720"/>
-            <a:ext cx="10728655" cy="3611880"/>
+            <a:off x="1463040" y="1143000"/>
+            <a:ext cx="9265615" cy="5212080"/>
           </a:xfrm>
           <a:prstGeom prst="rect">
             <a:avLst/>
           </a:prstGeom>
         </p:spPr>
       </p:pic>
-      <p:sp>
-        <p:nvSpPr>
-          <p:cNvPr id="10" name="Rounded Rectangle 9"/>
-          <p:cNvSpPr/>
-          <p:nvPr/>
-        </p:nvSpPr>
-        <p:spPr>
-          <a:xfrm>
-            <a:off x="731520" y="5029200"/>
-            <a:ext cx="2029968" cy="1234440"/>
-          </a:xfrm>
-          <a:prstGeom prst="roundRect">
-            <a:avLst/>
-          </a:prstGeom>
-          <a:solidFill>
-            <a:srgbClr val="FFFFFF"/>
-          </a:solidFill>
-          <a:ln w="12700">
-            <a:solidFill>
-              <a:srgbClr val="1B365D"/>
-            </a:solidFill>
-          </a:ln>
-        </p:spPr>
-        <p:style>
-          <a:lnRef idx="1">
-            <a:schemeClr val="accent1"/>
-          </a:lnRef>
-          <a:fillRef idx="3">
-            <a:schemeClr val="accent1"/>
-          </a:fillRef>
-          <a:effectRef idx="2">
-            <a:schemeClr val="accent1"/>
-          </a:effectRef>
-          <a:fontRef idx="minor">
-            <a:schemeClr val="lt1"/>
-          </a:fontRef>
-        </p:style>
-        <p:txBody>
-          <a:bodyPr rtlCol="0" anchor="ctr"/>
-          <a:lstStyle/>
-          <a:p>
-            <a:pPr algn="ctr"/>
-          </a:p>
-        </p:txBody>
-      </p:sp>
-      <p:sp>
-        <p:nvSpPr>
-          <p:cNvPr id="11" name="TextBox 10"/>
-          <p:cNvSpPr txBox="1"/>
-          <p:nvPr/>
-        </p:nvSpPr>
-        <p:spPr>
-          <a:xfrm>
-            <a:off x="822960" y="5084064"/>
-            <a:ext cx="1847088" cy="1097280"/>
-          </a:xfrm>
-          <a:prstGeom prst="rect">
-            <a:avLst/>
-          </a:prstGeom>
-          <a:noFill/>
-        </p:spPr>
-        <p:txBody>
-          <a:bodyPr wrap="square">
-            <a:spAutoFit/>
-          </a:bodyPr>
-          <a:lstStyle/>
-          <a:p>
-            <a:r>
-              <a:rPr sz="950" b="1">
-                <a:solidFill>
-                  <a:srgbClr val="1B365D"/>
-                </a:solidFill>
-              </a:rPr>
-              <a:t>B1. Thu thập PDF
-</a:t>
-            </a:r>
-            <a:r>
-              <a:rPr sz="830">
-                <a:solidFill>
-                  <a:srgbClr val="212529"/>
-                </a:solidFill>
-              </a:rPr>
-              <a:t>42 báo cáo từ 7 tập đoàn (2020–2025).</a:t>
-            </a:r>
-          </a:p>
-        </p:txBody>
-      </p:sp>
-      <p:sp>
-        <p:nvSpPr>
-          <p:cNvPr id="12" name="Rounded Rectangle 11"/>
-          <p:cNvSpPr/>
-          <p:nvPr/>
-        </p:nvSpPr>
-        <p:spPr>
-          <a:xfrm>
-            <a:off x="2907792" y="5029200"/>
-            <a:ext cx="2029968" cy="1234440"/>
-          </a:xfrm>
-          <a:prstGeom prst="roundRect">
-            <a:avLst/>
-          </a:prstGeom>
-          <a:solidFill>
-            <a:srgbClr val="FFFFFF"/>
-          </a:solidFill>
-          <a:ln w="12700">
-            <a:solidFill>
-              <a:srgbClr val="1F77B4"/>
-            </a:solidFill>
-          </a:ln>
-        </p:spPr>
-        <p:style>
-          <a:lnRef idx="1">
-            <a:schemeClr val="accent1"/>
-          </a:lnRef>
-          <a:fillRef idx="3">
-            <a:schemeClr val="accent1"/>
-          </a:fillRef>
-          <a:effectRef idx="2">
-            <a:schemeClr val="accent1"/>
-          </a:effectRef>
-          <a:fontRef idx="minor">
-            <a:schemeClr val="lt1"/>
-          </a:fontRef>
-        </p:style>
-        <p:txBody>
-          <a:bodyPr rtlCol="0" anchor="ctr"/>
-          <a:lstStyle/>
-          <a:p>
-            <a:pPr algn="ctr"/>
-          </a:p>
-        </p:txBody>
-      </p:sp>
-      <p:sp>
-        <p:nvSpPr>
-          <p:cNvPr id="13" name="TextBox 12"/>
-          <p:cNvSpPr txBox="1"/>
-          <p:nvPr/>
-        </p:nvSpPr>
-        <p:spPr>
-          <a:xfrm>
-            <a:off x="2999232" y="5084064"/>
-            <a:ext cx="1847088" cy="1097280"/>
-          </a:xfrm>
-          <a:prstGeom prst="rect">
-            <a:avLst/>
-          </a:prstGeom>
-          <a:noFill/>
-        </p:spPr>
-        <p:txBody>
-          <a:bodyPr wrap="square">
-            <a:spAutoFit/>
-          </a:bodyPr>
-          <a:lstStyle/>
-          <a:p>
-            <a:r>
-              <a:rPr sz="950" b="1">
-                <a:solidFill>
-                  <a:srgbClr val="1F77B4"/>
-                </a:solidFill>
-              </a:rPr>
-              <a:t>B2. Tiền xử lý &amp; OCR
-</a:t>
-            </a:r>
-            <a:r>
-              <a:rPr sz="830">
-                <a:solidFill>
-                  <a:srgbClr val="212529"/>
-                </a:solidFill>
-              </a:rPr>
-              <a:t>PyMuPDF + Tesseract phục hồi 100% scan.</a:t>
-            </a:r>
-          </a:p>
-        </p:txBody>
-      </p:sp>
-      <p:sp>
-        <p:nvSpPr>
-          <p:cNvPr id="14" name="Rounded Rectangle 13"/>
-          <p:cNvSpPr/>
-          <p:nvPr/>
-        </p:nvSpPr>
-        <p:spPr>
-          <a:xfrm>
-            <a:off x="5084064" y="5029200"/>
-            <a:ext cx="2029968" cy="1234440"/>
-          </a:xfrm>
-          <a:prstGeom prst="roundRect">
-            <a:avLst/>
-          </a:prstGeom>
-          <a:solidFill>
-            <a:srgbClr val="FFFFFF"/>
-          </a:solidFill>
-          <a:ln w="12700">
-            <a:solidFill>
-              <a:srgbClr val="D4AF37"/>
-            </a:solidFill>
-          </a:ln>
-        </p:spPr>
-        <p:style>
-          <a:lnRef idx="1">
-            <a:schemeClr val="accent1"/>
-          </a:lnRef>
-          <a:fillRef idx="3">
-            <a:schemeClr val="accent1"/>
-          </a:fillRef>
-          <a:effectRef idx="2">
-            <a:schemeClr val="accent1"/>
-          </a:effectRef>
-          <a:fontRef idx="minor">
-            <a:schemeClr val="lt1"/>
-          </a:fontRef>
-        </p:style>
-        <p:txBody>
-          <a:bodyPr rtlCol="0" anchor="ctr"/>
-          <a:lstStyle/>
-          <a:p>
-            <a:pPr algn="ctr"/>
-          </a:p>
-        </p:txBody>
-      </p:sp>
-      <p:sp>
-        <p:nvSpPr>
-          <p:cNvPr id="15" name="TextBox 14"/>
-          <p:cNvSpPr txBox="1"/>
-          <p:nvPr/>
-        </p:nvSpPr>
-        <p:spPr>
-          <a:xfrm>
-            <a:off x="5175504" y="5084064"/>
-            <a:ext cx="1847088" cy="1097280"/>
-          </a:xfrm>
-          <a:prstGeom prst="rect">
-            <a:avLst/>
-          </a:prstGeom>
-          <a:noFill/>
-        </p:spPr>
-        <p:txBody>
-          <a:bodyPr wrap="square">
-            <a:spAutoFit/>
-          </a:bodyPr>
-          <a:lstStyle/>
-          <a:p>
-            <a:r>
-              <a:rPr sz="950" b="1">
-                <a:solidFill>
-                  <a:srgbClr val="D4AF37"/>
-                </a:solidFill>
-              </a:rPr>
-              <a:t>B3. Nhúng SBERT
-</a:t>
-            </a:r>
-            <a:r>
-              <a:rPr sz="830">
-                <a:solidFill>
-                  <a:srgbClr val="212529"/>
-                </a:solidFill>
-              </a:rPr>
-              <a:t>vietnamese-sbert 768-d + 1.032 câu chuẩn.</a:t>
-            </a:r>
-          </a:p>
-        </p:txBody>
-      </p:sp>
-      <p:sp>
-        <p:nvSpPr>
-          <p:cNvPr id="16" name="Rounded Rectangle 15"/>
-          <p:cNvSpPr/>
-          <p:nvPr/>
-        </p:nvSpPr>
-        <p:spPr>
-          <a:xfrm>
-            <a:off x="7260336" y="5029200"/>
-            <a:ext cx="2029968" cy="1234440"/>
-          </a:xfrm>
-          <a:prstGeom prst="roundRect">
-            <a:avLst/>
-          </a:prstGeom>
-          <a:solidFill>
-            <a:srgbClr val="FFFFFF"/>
-          </a:solidFill>
-          <a:ln w="12700">
-            <a:solidFill>
-              <a:srgbClr val="7030A0"/>
-            </a:solidFill>
-          </a:ln>
-        </p:spPr>
-        <p:style>
-          <a:lnRef idx="1">
-            <a:schemeClr val="accent1"/>
-          </a:lnRef>
-          <a:fillRef idx="3">
-            <a:schemeClr val="accent1"/>
-          </a:fillRef>
-          <a:effectRef idx="2">
-            <a:schemeClr val="accent1"/>
-          </a:effectRef>
-          <a:fontRef idx="minor">
-            <a:schemeClr val="lt1"/>
-          </a:fontRef>
-        </p:style>
-        <p:txBody>
-          <a:bodyPr rtlCol="0" anchor="ctr"/>
-          <a:lstStyle/>
-          <a:p>
-            <a:pPr algn="ctr"/>
-          </a:p>
-        </p:txBody>
-      </p:sp>
-      <p:sp>
-        <p:nvSpPr>
-          <p:cNvPr id="17" name="TextBox 16"/>
-          <p:cNvSpPr txBox="1"/>
-          <p:nvPr/>
-        </p:nvSpPr>
-        <p:spPr>
-          <a:xfrm>
-            <a:off x="7351776" y="5084064"/>
-            <a:ext cx="1847088" cy="1097280"/>
-          </a:xfrm>
-          <a:prstGeom prst="rect">
-            <a:avLst/>
-          </a:prstGeom>
-          <a:noFill/>
-        </p:spPr>
-        <p:txBody>
-          <a:bodyPr wrap="square">
-            <a:spAutoFit/>
-          </a:bodyPr>
-          <a:lstStyle/>
-          <a:p>
-            <a:r>
-              <a:rPr sz="950" b="1">
-                <a:solidFill>
-                  <a:srgbClr val="7030A0"/>
-                </a:solidFill>
-              </a:rPr>
-              <a:t>B4. Min-Max 0-100
-</a:t>
-            </a:r>
-            <a:r>
-              <a:rPr sz="830">
-                <a:solidFill>
-                  <a:srgbClr val="212529"/>
-                </a:solidFill>
-              </a:rPr>
-              <a:t>Chuẩn hóa toàn cục + 6 nhóm Max-Neef.</a:t>
-            </a:r>
-          </a:p>
-        </p:txBody>
-      </p:sp>
-      <p:sp>
-        <p:nvSpPr>
-          <p:cNvPr id="18" name="Rounded Rectangle 17"/>
-          <p:cNvSpPr/>
-          <p:nvPr/>
-        </p:nvSpPr>
-        <p:spPr>
-          <a:xfrm>
-            <a:off x="9436608" y="5029200"/>
-            <a:ext cx="2029968" cy="1234440"/>
-          </a:xfrm>
-          <a:prstGeom prst="roundRect">
-            <a:avLst/>
-          </a:prstGeom>
-          <a:solidFill>
-            <a:srgbClr val="FFFFFF"/>
-          </a:solidFill>
-          <a:ln w="12700">
-            <a:solidFill>
-              <a:srgbClr val="288C3C"/>
-            </a:solidFill>
-          </a:ln>
-        </p:spPr>
-        <p:style>
-          <a:lnRef idx="1">
-            <a:schemeClr val="accent1"/>
-          </a:lnRef>
-          <a:fillRef idx="3">
-            <a:schemeClr val="accent1"/>
-          </a:fillRef>
-          <a:effectRef idx="2">
-            <a:schemeClr val="accent1"/>
-          </a:effectRef>
-          <a:fontRef idx="minor">
-            <a:schemeClr val="lt1"/>
-          </a:fontRef>
-        </p:style>
-        <p:txBody>
-          <a:bodyPr rtlCol="0" anchor="ctr"/>
-          <a:lstStyle/>
-          <a:p>
-            <a:pPr algn="ctr"/>
-          </a:p>
-        </p:txBody>
-      </p:sp>
-      <p:sp>
-        <p:nvSpPr>
-          <p:cNvPr id="19" name="TextBox 18"/>
-          <p:cNvSpPr txBox="1"/>
-          <p:nvPr/>
-        </p:nvSpPr>
-        <p:spPr>
-          <a:xfrm>
-            <a:off x="9528048" y="5084064"/>
-            <a:ext cx="1847088" cy="1097280"/>
-          </a:xfrm>
-          <a:prstGeom prst="rect">
-            <a:avLst/>
-          </a:prstGeom>
-          <a:noFill/>
-        </p:spPr>
-        <p:txBody>
-          <a:bodyPr wrap="square">
-            <a:spAutoFit/>
-          </a:bodyPr>
-          <a:lstStyle/>
-          <a:p>
-            <a:r>
-              <a:rPr sz="950" b="1">
-                <a:solidFill>
-                  <a:srgbClr val="288C3C"/>
-                </a:solidFill>
-              </a:rPr>
-              <a:t>B5. PhoBERT 3 lớp
-</a:t>
-            </a:r>
-            <a:r>
-              <a:rPr sz="830">
-                <a:solidFill>
-                  <a:srgbClr val="212529"/>
-                </a:solidFill>
-              </a:rPr>
-              <a:t>Phân tích cảm xúc &amp; Tỷ số Pos/Neg Ratio.</a:t>
-            </a:r>
-          </a:p>
-        </p:txBody>
-      </p:sp>
     </p:spTree>
   </p:cSld>
   <p:clrMapOvr>

</xml_diff>

<commit_message>
feat(presentation): convert Result 3 to grouped bar graph (slide_company_6cat_bar.png)
</commit_message>
<xml_diff>
--- a/bao_cao_nghien_cuu_sdg_vietnam.pptx
+++ b/bao_cao_nghien_cuu_sdg_vietnam.pptx
@@ -3150,7 +3150,7 @@
               </a:defRPr>
             </a:pPr>
             <a:r>
-              <a:t>Tổng hợp đối chiếu cả 7 doanh nghiệp trên cùng 1 bảng 6 nhóm chủ đề SDG, làm bật quy luật thị trường và phân hóa đặc thù ngành.</a:t>
+              <a:t>Chỉ vào biểu đồ cột Bar Chart đối chuẩn 7 doanh nghiệp qua 6 nhóm chủ đề SDG, làm bật quy luật thị trường và phân hóa đặc thù ngành.</a:t>
             </a:r>
           </a:p>
           <a:p/>
@@ -3177,7 +3177,7 @@
               </a:defRPr>
             </a:pPr>
             <a:r>
-              <a:t>Kính thưa Hội đồng, bảng tổng hợp trên slide là bức tranh toàn cảnh so sánh đồng thời 7 doanh nghiệp qua 6 nhóm chủ đề SDG theo phân loại quốc tế của Kang &amp; Kim (2022). Kết quả định lượng chỉ ra 3 quy luật thực nghiệm: Thứ nhất, quy luật 'Economic cao nhất - Equity thấp nhất' mang tính phổ quát ở tất cả các doanh nghiệp; thứ hai là sự phân hóa rõ nét giữa nhóm xuất khẩu tư nhân (chú trọng Tài nguyên &amp; Môi trường để vượt rào cản CBAM) và nhóm tài chính/nhà nước (chú trọng Xã hội &amp; Thể chế); thứ ba là từng doanh nghiệp đều có điểm bứt phá tương ứng với mô hình kinh doanh, như VCS dẫn đầu nhờ đá thạch anh, PNJ dẫn đầu Bình đẳng giới và Bảo Việt dẫn đầu Xã hội.</a:t>
+              <a:t>Kính thưa Hội đồng, biểu đồ cột trên slide trực quan hóa mức độ gắn kết của 7 doanh nghiệp với 6 nhóm chủ đề SDG. Kết quả định lượng chỉ ra 3 phát hiện lớn: Thứ nhất, quy luật 'Economic cao nhất - Equity thấp nhất' thể hiện trực quan qua việc thanh màu xanh dương luôn cao nhất và thanh màu tím luôn thấp nhất ở toàn bộ các doanh nghiệp; thứ hai là sự phân hóa rõ nét giữa nhóm xuất khẩu tư nhân (chú trọng Tài nguyên &amp; Môi trường để vượt rào cản CBAM) và nhóm tài chính/nhà nước (chú trọng Xã hội &amp; Thể chế); thứ ba là từng doanh nghiệp đều có điểm bứt phá tương ứng với mô hình kinh doanh, như VCS dẫn đầu nhờ đá thạch anh, PNJ dẫn đầu Bình đẳng giới và Bảo Việt dẫn đầu Xã hội.</a:t>
             </a:r>
           </a:p>
           <a:p/>
@@ -3204,7 +3204,7 @@
               </a:defRPr>
             </a:pPr>
             <a:r>
-              <a:t>Toàn mẫu: Economic (47,69đ) &gt; Social (46,39đ) &gt; Resources (45,63đ) &gt; Environs (44,98đ) &gt; Life (44,26đ) &gt; Equity (42,08đ); Phân hóa sản xuất vs tài chính.</a:t>
+              <a:t>Toàn mẫu: Economic (47,69đ) &gt; Social (46,39đ) &gt; Resources (45,63đ) &gt; Environs (44,98đ) &gt; Life (44,26đ) &gt; Equity (42,08đ); Thanh màu trực quan phân hóa theo ngành.</a:t>
             </a:r>
           </a:p>
           <a:p/>
@@ -3231,7 +3231,7 @@
               </a:defRPr>
             </a:pPr>
             <a:r>
-              <a:t>Tại sao lại gom 17 SDG thành 6 nhóm: Vì 17 SDG có sự giao thoa, gom thành 6 nhóm theo lý thuyết Max-Neef giúp phát hiện xu hướng chiến lược vĩ mô rõ ràng hơn.</a:t>
+              <a:t>Tại sao lại dùng biểu đồ cột thay cho bảng số liệu: Biểu đồ cột trực quan hóa tức thì sự chênh lệch giữa các nhóm chủ đề, giúp hội đồng thấy ngay cột Economic luôn vọt lên cao nhất và cột Equity luôn tụt sâu nhất ở 100% doanh nghiệp.</a:t>
             </a:r>
           </a:p>
           <a:p/>
@@ -19489,7 +19489,7 @@
                 </a:solidFill>
                 <a:latin typeface="Segoe UI"/>
               </a:rPr>
-              <a:t>KẾT QUẢ 3: BẢNG SO SÁNH ĐẶC THÙ 7 DOANH NGHIỆP THEO 6 NHÓM SDG</a:t>
+              <a:t>KẾT QUẢ 3: ĐẶC THÙ 7 DOANH NGHIỆP THEO 6 NHÓM CHỦ ĐỀ SDG</a:t>
             </a:r>
           </a:p>
         </p:txBody>
@@ -19563,1736 +19563,30 @@
           </a:p>
         </p:txBody>
       </p:sp>
-      <p:graphicFrame>
-        <p:nvGraphicFramePr>
-          <p:cNvPr id="9" name="Table 8"/>
-          <p:cNvGraphicFramePr>
-            <a:graphicFrameLocks noGrp="1"/>
-          </p:cNvGraphicFramePr>
-          <p:nvPr/>
-        </p:nvGraphicFramePr>
-        <p:xfrm>
-          <a:off x="731520" y="1188720"/>
-          <a:ext cx="10728655" cy="3474720"/>
-        </p:xfrm>
-        <a:graphic>
-          <a:graphicData uri="http://schemas.openxmlformats.org/drawingml/2006/table">
-            <a:tbl>
-              <a:tblPr firstRow="1" bandRow="1">
-                <a:tableStyleId>{5C22544A-7EE6-4342-B048-85BDC9FD1C3A}</a:tableStyleId>
-              </a:tblPr>
-              <a:tblGrid>
-                <a:gridCol w="2041855"/>
-                <a:gridCol w="1051560"/>
-                <a:gridCol w="1143000"/>
-                <a:gridCol w="1051560"/>
-                <a:gridCol w="1051560"/>
-                <a:gridCol w="1143000"/>
-                <a:gridCol w="1051560"/>
-                <a:gridCol w="2194560"/>
-              </a:tblGrid>
-              <a:tr h="386080">
-                <a:tc>
-                  <a:txBody>
-                    <a:bodyPr/>
-                    <a:lstStyle/>
-                    <a:p>
-                      <a:pPr algn="ctr">
-                        <a:defRPr b="1" sz="819">
-                          <a:solidFill>
-                            <a:srgbClr val="FFFFFF"/>
-                          </a:solidFill>
-                        </a:defRPr>
-                      </a:pPr>
-                      <a:r>
-                        <a:t>DOANH NGHIỆP (NGÀNH)</a:t>
-                      </a:r>
-                    </a:p>
-                  </a:txBody>
-                  <a:tcPr>
-                    <a:solidFill>
-                      <a:srgbClr val="1B365D"/>
-                    </a:solidFill>
-                  </a:tcPr>
-                </a:tc>
-                <a:tc>
-                  <a:txBody>
-                    <a:bodyPr/>
-                    <a:lstStyle/>
-                    <a:p>
-                      <a:pPr algn="ctr">
-                        <a:defRPr b="1" sz="819">
-                          <a:solidFill>
-                            <a:srgbClr val="FFFFFF"/>
-                          </a:solidFill>
-                        </a:defRPr>
-                      </a:pPr>
-                      <a:r>
-                        <a:t>LIFE</a:t>
-                      </a:r>
-                      <a:br/>
-                      <a:r>
-                        <a:t>(1, 2, 3)</a:t>
-                      </a:r>
-                    </a:p>
-                  </a:txBody>
-                  <a:tcPr>
-                    <a:solidFill>
-                      <a:srgbClr val="1B365D"/>
-                    </a:solidFill>
-                  </a:tcPr>
-                </a:tc>
-                <a:tc>
-                  <a:txBody>
-                    <a:bodyPr/>
-                    <a:lstStyle/>
-                    <a:p>
-                      <a:pPr algn="ctr">
-                        <a:defRPr b="1" sz="819">
-                          <a:solidFill>
-                            <a:srgbClr val="FFFFFF"/>
-                          </a:solidFill>
-                        </a:defRPr>
-                      </a:pPr>
-                      <a:r>
-                        <a:t>ECONOMIC</a:t>
-                      </a:r>
-                      <a:br/>
-                      <a:r>
-                        <a:t>(8, 9)</a:t>
-                      </a:r>
-                    </a:p>
-                  </a:txBody>
-                  <a:tcPr>
-                    <a:solidFill>
-                      <a:srgbClr val="1B365D"/>
-                    </a:solidFill>
-                  </a:tcPr>
-                </a:tc>
-                <a:tc>
-                  <a:txBody>
-                    <a:bodyPr/>
-                    <a:lstStyle/>
-                    <a:p>
-                      <a:pPr algn="ctr">
-                        <a:defRPr b="1" sz="819">
-                          <a:solidFill>
-                            <a:srgbClr val="FFFFFF"/>
-                          </a:solidFill>
-                        </a:defRPr>
-                      </a:pPr>
-                      <a:r>
-                        <a:t>EQUITY</a:t>
-                      </a:r>
-                      <a:br/>
-                      <a:r>
-                        <a:t>(4, 5, 10)</a:t>
-                      </a:r>
-                    </a:p>
-                  </a:txBody>
-                  <a:tcPr>
-                    <a:solidFill>
-                      <a:srgbClr val="1B365D"/>
-                    </a:solidFill>
-                  </a:tcPr>
-                </a:tc>
-                <a:tc>
-                  <a:txBody>
-                    <a:bodyPr/>
-                    <a:lstStyle/>
-                    <a:p>
-                      <a:pPr algn="ctr">
-                        <a:defRPr b="1" sz="819">
-                          <a:solidFill>
-                            <a:srgbClr val="FFFFFF"/>
-                          </a:solidFill>
-                        </a:defRPr>
-                      </a:pPr>
-                      <a:r>
-                        <a:t>SOCIAL</a:t>
-                      </a:r>
-                      <a:br/>
-                      <a:r>
-                        <a:t>(11, 16, 17)</a:t>
-                      </a:r>
-                    </a:p>
-                  </a:txBody>
-                  <a:tcPr>
-                    <a:solidFill>
-                      <a:srgbClr val="1B365D"/>
-                    </a:solidFill>
-                  </a:tcPr>
-                </a:tc>
-                <a:tc>
-                  <a:txBody>
-                    <a:bodyPr/>
-                    <a:lstStyle/>
-                    <a:p>
-                      <a:pPr algn="ctr">
-                        <a:defRPr b="1" sz="819">
-                          <a:solidFill>
-                            <a:srgbClr val="FFFFFF"/>
-                          </a:solidFill>
-                        </a:defRPr>
-                      </a:pPr>
-                      <a:r>
-                        <a:t>RESOURCES</a:t>
-                      </a:r>
-                      <a:br/>
-                      <a:r>
-                        <a:t>(6, 7, 12, 14)</a:t>
-                      </a:r>
-                    </a:p>
-                  </a:txBody>
-                  <a:tcPr>
-                    <a:solidFill>
-                      <a:srgbClr val="1B365D"/>
-                    </a:solidFill>
-                  </a:tcPr>
-                </a:tc>
-                <a:tc>
-                  <a:txBody>
-                    <a:bodyPr/>
-                    <a:lstStyle/>
-                    <a:p>
-                      <a:pPr algn="ctr">
-                        <a:defRPr b="1" sz="819">
-                          <a:solidFill>
-                            <a:srgbClr val="FFFFFF"/>
-                          </a:solidFill>
-                        </a:defRPr>
-                      </a:pPr>
-                      <a:r>
-                        <a:t>ENVIRONS</a:t>
-                      </a:r>
-                      <a:br/>
-                      <a:r>
-                        <a:t>(13, 15)</a:t>
-                      </a:r>
-                    </a:p>
-                  </a:txBody>
-                  <a:tcPr>
-                    <a:solidFill>
-                      <a:srgbClr val="1B365D"/>
-                    </a:solidFill>
-                  </a:tcPr>
-                </a:tc>
-                <a:tc>
-                  <a:txBody>
-                    <a:bodyPr/>
-                    <a:lstStyle/>
-                    <a:p>
-                      <a:pPr algn="ctr">
-                        <a:defRPr b="1" sz="819">
-                          <a:solidFill>
-                            <a:srgbClr val="FFFFFF"/>
-                          </a:solidFill>
-                        </a:defRPr>
-                      </a:pPr>
-                      <a:r>
-                        <a:t>ĐẶC TRƯNG CHIẾN LƯỢC CỐT LÕI</a:t>
-                      </a:r>
-                    </a:p>
-                  </a:txBody>
-                  <a:tcPr>
-                    <a:solidFill>
-                      <a:srgbClr val="1B365D"/>
-                    </a:solidFill>
-                  </a:tcPr>
-                </a:tc>
-              </a:tr>
-              <a:tr h="386080">
-                <a:tc>
-                  <a:txBody>
-                    <a:bodyPr/>
-                    <a:lstStyle/>
-                    <a:p>
-                      <a:pPr>
-                        <a:defRPr sz="780" b="1">
-                          <a:solidFill>
-                            <a:srgbClr val="1B365D"/>
-                          </a:solidFill>
-                        </a:defRPr>
-                      </a:pPr>
-                      <a:r>
-                        <a:t>Vinamilk (VNM - Sữa &amp; Chăn nuôi)</a:t>
-                      </a:r>
-                    </a:p>
-                  </a:txBody>
-                  <a:tcPr>
-                    <a:solidFill>
-                      <a:srgbClr val="F8FAFC"/>
-                    </a:solidFill>
-                  </a:tcPr>
-                </a:tc>
-                <a:tc>
-                  <a:txBody>
-                    <a:bodyPr/>
-                    <a:lstStyle/>
-                    <a:p>
-                      <a:pPr algn="ctr">
-                        <a:defRPr sz="780" b="0">
-                          <a:solidFill>
-                            <a:srgbClr val="212529"/>
-                          </a:solidFill>
-                        </a:defRPr>
-                      </a:pPr>
-                      <a:r>
-                        <a:t>42.26</a:t>
-                      </a:r>
-                    </a:p>
-                  </a:txBody>
-                  <a:tcPr>
-                    <a:solidFill>
-                      <a:srgbClr val="F8FAFC"/>
-                    </a:solidFill>
-                  </a:tcPr>
-                </a:tc>
-                <a:tc>
-                  <a:txBody>
-                    <a:bodyPr/>
-                    <a:lstStyle/>
-                    <a:p>
-                      <a:pPr algn="ctr">
-                        <a:defRPr sz="780" b="1">
-                          <a:solidFill>
-                            <a:srgbClr val="1B365D"/>
-                          </a:solidFill>
-                        </a:defRPr>
-                      </a:pPr>
-                      <a:r>
-                        <a:t>45.09</a:t>
-                      </a:r>
-                    </a:p>
-                  </a:txBody>
-                  <a:tcPr>
-                    <a:solidFill>
-                      <a:srgbClr val="F8FAFC"/>
-                    </a:solidFill>
-                  </a:tcPr>
-                </a:tc>
-                <a:tc>
-                  <a:txBody>
-                    <a:bodyPr/>
-                    <a:lstStyle/>
-                    <a:p>
-                      <a:pPr algn="ctr">
-                        <a:defRPr sz="780" b="0">
-                          <a:solidFill>
-                            <a:srgbClr val="D4AF37"/>
-                          </a:solidFill>
-                        </a:defRPr>
-                      </a:pPr>
-                      <a:r>
-                        <a:t>40.28</a:t>
-                      </a:r>
-                    </a:p>
-                  </a:txBody>
-                  <a:tcPr>
-                    <a:solidFill>
-                      <a:srgbClr val="F8FAFC"/>
-                    </a:solidFill>
-                  </a:tcPr>
-                </a:tc>
-                <a:tc>
-                  <a:txBody>
-                    <a:bodyPr/>
-                    <a:lstStyle/>
-                    <a:p>
-                      <a:pPr algn="ctr">
-                        <a:defRPr sz="780" b="0">
-                          <a:solidFill>
-                            <a:srgbClr val="212529"/>
-                          </a:solidFill>
-                        </a:defRPr>
-                      </a:pPr>
-                      <a:r>
-                        <a:t>43.94</a:t>
-                      </a:r>
-                    </a:p>
-                  </a:txBody>
-                  <a:tcPr>
-                    <a:solidFill>
-                      <a:srgbClr val="F8FAFC"/>
-                    </a:solidFill>
-                  </a:tcPr>
-                </a:tc>
-                <a:tc>
-                  <a:txBody>
-                    <a:bodyPr/>
-                    <a:lstStyle/>
-                    <a:p>
-                      <a:pPr algn="ctr">
-                        <a:defRPr sz="780" b="0">
-                          <a:solidFill>
-                            <a:srgbClr val="212529"/>
-                          </a:solidFill>
-                        </a:defRPr>
-                      </a:pPr>
-                      <a:r>
-                        <a:t>44.08</a:t>
-                      </a:r>
-                    </a:p>
-                  </a:txBody>
-                  <a:tcPr>
-                    <a:solidFill>
-                      <a:srgbClr val="F8FAFC"/>
-                    </a:solidFill>
-                  </a:tcPr>
-                </a:tc>
-                <a:tc>
-                  <a:txBody>
-                    <a:bodyPr/>
-                    <a:lstStyle/>
-                    <a:p>
-                      <a:pPr algn="ctr">
-                        <a:defRPr sz="780" b="0">
-                          <a:solidFill>
-                            <a:srgbClr val="212529"/>
-                          </a:solidFill>
-                        </a:defRPr>
-                      </a:pPr>
-                      <a:r>
-                        <a:t>43.38</a:t>
-                      </a:r>
-                    </a:p>
-                  </a:txBody>
-                  <a:tcPr>
-                    <a:solidFill>
-                      <a:srgbClr val="F8FAFC"/>
-                    </a:solidFill>
-                  </a:tcPr>
-                </a:tc>
-                <a:tc>
-                  <a:txBody>
-                    <a:bodyPr/>
-                    <a:lstStyle/>
-                    <a:p>
-                      <a:pPr>
-                        <a:defRPr sz="740" b="0">
-                          <a:solidFill>
-                            <a:srgbClr val="212529"/>
-                          </a:solidFill>
-                        </a:defRPr>
-                      </a:pPr>
-                      <a:r>
-                        <a:t>Net Zero 2050, 3 đơn vị PAS 2060, Green Farm.</a:t>
-                      </a:r>
-                    </a:p>
-                  </a:txBody>
-                  <a:tcPr>
-                    <a:solidFill>
-                      <a:srgbClr val="F8FAFC"/>
-                    </a:solidFill>
-                  </a:tcPr>
-                </a:tc>
-              </a:tr>
-              <a:tr h="386080">
-                <a:tc>
-                  <a:txBody>
-                    <a:bodyPr/>
-                    <a:lstStyle/>
-                    <a:p>
-                      <a:pPr>
-                        <a:defRPr sz="780" b="1">
-                          <a:solidFill>
-                            <a:srgbClr val="1B365D"/>
-                          </a:solidFill>
-                        </a:defRPr>
-                      </a:pPr>
-                      <a:r>
-                        <a:t>Vicostone (VCS - Đá thạch anh)</a:t>
-                      </a:r>
-                    </a:p>
-                  </a:txBody>
-                  <a:tcPr>
-                    <a:solidFill>
-                      <a:srgbClr val="FFFFFF"/>
-                    </a:solidFill>
-                  </a:tcPr>
-                </a:tc>
-                <a:tc>
-                  <a:txBody>
-                    <a:bodyPr/>
-                    <a:lstStyle/>
-                    <a:p>
-                      <a:pPr algn="ctr">
-                        <a:defRPr sz="780" b="0">
-                          <a:solidFill>
-                            <a:srgbClr val="212529"/>
-                          </a:solidFill>
-                        </a:defRPr>
-                      </a:pPr>
-                      <a:r>
-                        <a:t>46.19</a:t>
-                      </a:r>
-                    </a:p>
-                  </a:txBody>
-                  <a:tcPr>
-                    <a:solidFill>
-                      <a:srgbClr val="FFFFFF"/>
-                    </a:solidFill>
-                  </a:tcPr>
-                </a:tc>
-                <a:tc>
-                  <a:txBody>
-                    <a:bodyPr/>
-                    <a:lstStyle/>
-                    <a:p>
-                      <a:pPr algn="ctr">
-                        <a:defRPr sz="780" b="1">
-                          <a:solidFill>
-                            <a:srgbClr val="1B365D"/>
-                          </a:solidFill>
-                        </a:defRPr>
-                      </a:pPr>
-                      <a:r>
-                        <a:t>50.71</a:t>
-                      </a:r>
-                    </a:p>
-                  </a:txBody>
-                  <a:tcPr>
-                    <a:solidFill>
-                      <a:srgbClr val="FFFFFF"/>
-                    </a:solidFill>
-                  </a:tcPr>
-                </a:tc>
-                <a:tc>
-                  <a:txBody>
-                    <a:bodyPr/>
-                    <a:lstStyle/>
-                    <a:p>
-                      <a:pPr algn="ctr">
-                        <a:defRPr sz="780" b="0">
-                          <a:solidFill>
-                            <a:srgbClr val="D4AF37"/>
-                          </a:solidFill>
-                        </a:defRPr>
-                      </a:pPr>
-                      <a:r>
-                        <a:t>44.20</a:t>
-                      </a:r>
-                    </a:p>
-                  </a:txBody>
-                  <a:tcPr>
-                    <a:solidFill>
-                      <a:srgbClr val="FFFFFF"/>
-                    </a:solidFill>
-                  </a:tcPr>
-                </a:tc>
-                <a:tc>
-                  <a:txBody>
-                    <a:bodyPr/>
-                    <a:lstStyle/>
-                    <a:p>
-                      <a:pPr algn="ctr">
-                        <a:defRPr sz="780" b="0">
-                          <a:solidFill>
-                            <a:srgbClr val="212529"/>
-                          </a:solidFill>
-                        </a:defRPr>
-                      </a:pPr>
-                      <a:r>
-                        <a:t>49.08</a:t>
-                      </a:r>
-                    </a:p>
-                  </a:txBody>
-                  <a:tcPr>
-                    <a:solidFill>
-                      <a:srgbClr val="FFFFFF"/>
-                    </a:solidFill>
-                  </a:tcPr>
-                </a:tc>
-                <a:tc>
-                  <a:txBody>
-                    <a:bodyPr/>
-                    <a:lstStyle/>
-                    <a:p>
-                      <a:pPr algn="ctr">
-                        <a:defRPr sz="780" b="0">
-                          <a:solidFill>
-                            <a:srgbClr val="212529"/>
-                          </a:solidFill>
-                        </a:defRPr>
-                      </a:pPr>
-                      <a:r>
-                        <a:t>48.63</a:t>
-                      </a:r>
-                    </a:p>
-                  </a:txBody>
-                  <a:tcPr>
-                    <a:solidFill>
-                      <a:srgbClr val="FFFFFF"/>
-                    </a:solidFill>
-                  </a:tcPr>
-                </a:tc>
-                <a:tc>
-                  <a:txBody>
-                    <a:bodyPr/>
-                    <a:lstStyle/>
-                    <a:p>
-                      <a:pPr algn="ctr">
-                        <a:defRPr sz="780" b="0">
-                          <a:solidFill>
-                            <a:srgbClr val="212529"/>
-                          </a:solidFill>
-                        </a:defRPr>
-                      </a:pPr>
-                      <a:r>
-                        <a:t>47.31</a:t>
-                      </a:r>
-                    </a:p>
-                  </a:txBody>
-                  <a:tcPr>
-                    <a:solidFill>
-                      <a:srgbClr val="FFFFFF"/>
-                    </a:solidFill>
-                  </a:tcPr>
-                </a:tc>
-                <a:tc>
-                  <a:txBody>
-                    <a:bodyPr/>
-                    <a:lstStyle/>
-                    <a:p>
-                      <a:pPr>
-                        <a:defRPr sz="740" b="0">
-                          <a:solidFill>
-                            <a:srgbClr val="212529"/>
-                          </a:solidFill>
-                        </a:defRPr>
-                      </a:pPr>
-                      <a:r>
-                        <a:t>Đỉnh toàn mẫu Economic &amp; Resources nhờ xuất khẩu Âu-Mỹ.</a:t>
-                      </a:r>
-                    </a:p>
-                  </a:txBody>
-                  <a:tcPr>
-                    <a:solidFill>
-                      <a:srgbClr val="FFFFFF"/>
-                    </a:solidFill>
-                  </a:tcPr>
-                </a:tc>
-              </a:tr>
-              <a:tr h="386080">
-                <a:tc>
-                  <a:txBody>
-                    <a:bodyPr/>
-                    <a:lstStyle/>
-                    <a:p>
-                      <a:pPr>
-                        <a:defRPr sz="780" b="1">
-                          <a:solidFill>
-                            <a:srgbClr val="1B365D"/>
-                          </a:solidFill>
-                        </a:defRPr>
-                      </a:pPr>
-                      <a:r>
-                        <a:t>PNJ (PNJ - Bán lẻ &amp; Chế tác vàng)</a:t>
-                      </a:r>
-                    </a:p>
-                  </a:txBody>
-                  <a:tcPr>
-                    <a:solidFill>
-                      <a:srgbClr val="F8FAFC"/>
-                    </a:solidFill>
-                  </a:tcPr>
-                </a:tc>
-                <a:tc>
-                  <a:txBody>
-                    <a:bodyPr/>
-                    <a:lstStyle/>
-                    <a:p>
-                      <a:pPr algn="ctr">
-                        <a:defRPr sz="780" b="0">
-                          <a:solidFill>
-                            <a:srgbClr val="212529"/>
-                          </a:solidFill>
-                        </a:defRPr>
-                      </a:pPr>
-                      <a:r>
-                        <a:t>44.58</a:t>
-                      </a:r>
-                    </a:p>
-                  </a:txBody>
-                  <a:tcPr>
-                    <a:solidFill>
-                      <a:srgbClr val="F8FAFC"/>
-                    </a:solidFill>
-                  </a:tcPr>
-                </a:tc>
-                <a:tc>
-                  <a:txBody>
-                    <a:bodyPr/>
-                    <a:lstStyle/>
-                    <a:p>
-                      <a:pPr algn="ctr">
-                        <a:defRPr sz="780" b="1">
-                          <a:solidFill>
-                            <a:srgbClr val="1B365D"/>
-                          </a:solidFill>
-                        </a:defRPr>
-                      </a:pPr>
-                      <a:r>
-                        <a:t>48.67</a:t>
-                      </a:r>
-                    </a:p>
-                  </a:txBody>
-                  <a:tcPr>
-                    <a:solidFill>
-                      <a:srgbClr val="F8FAFC"/>
-                    </a:solidFill>
-                  </a:tcPr>
-                </a:tc>
-                <a:tc>
-                  <a:txBody>
-                    <a:bodyPr/>
-                    <a:lstStyle/>
-                    <a:p>
-                      <a:pPr algn="ctr">
-                        <a:defRPr sz="780" b="0">
-                          <a:solidFill>
-                            <a:srgbClr val="D4AF37"/>
-                          </a:solidFill>
-                        </a:defRPr>
-                      </a:pPr>
-                      <a:r>
-                        <a:t>43.18</a:t>
-                      </a:r>
-                    </a:p>
-                  </a:txBody>
-                  <a:tcPr>
-                    <a:solidFill>
-                      <a:srgbClr val="F8FAFC"/>
-                    </a:solidFill>
-                  </a:tcPr>
-                </a:tc>
-                <a:tc>
-                  <a:txBody>
-                    <a:bodyPr/>
-                    <a:lstStyle/>
-                    <a:p>
-                      <a:pPr algn="ctr">
-                        <a:defRPr sz="780" b="0">
-                          <a:solidFill>
-                            <a:srgbClr val="212529"/>
-                          </a:solidFill>
-                        </a:defRPr>
-                      </a:pPr>
-                      <a:r>
-                        <a:t>47.32</a:t>
-                      </a:r>
-                    </a:p>
-                  </a:txBody>
-                  <a:tcPr>
-                    <a:solidFill>
-                      <a:srgbClr val="F8FAFC"/>
-                    </a:solidFill>
-                  </a:tcPr>
-                </a:tc>
-                <a:tc>
-                  <a:txBody>
-                    <a:bodyPr/>
-                    <a:lstStyle/>
-                    <a:p>
-                      <a:pPr algn="ctr">
-                        <a:defRPr sz="780" b="0">
-                          <a:solidFill>
-                            <a:srgbClr val="212529"/>
-                          </a:solidFill>
-                        </a:defRPr>
-                      </a:pPr>
-                      <a:r>
-                        <a:t>46.93</a:t>
-                      </a:r>
-                    </a:p>
-                  </a:txBody>
-                  <a:tcPr>
-                    <a:solidFill>
-                      <a:srgbClr val="F8FAFC"/>
-                    </a:solidFill>
-                  </a:tcPr>
-                </a:tc>
-                <a:tc>
-                  <a:txBody>
-                    <a:bodyPr/>
-                    <a:lstStyle/>
-                    <a:p>
-                      <a:pPr algn="ctr">
-                        <a:defRPr sz="780" b="0">
-                          <a:solidFill>
-                            <a:srgbClr val="212529"/>
-                          </a:solidFill>
-                        </a:defRPr>
-                      </a:pPr>
-                      <a:r>
-                        <a:t>45.97</a:t>
-                      </a:r>
-                    </a:p>
-                  </a:txBody>
-                  <a:tcPr>
-                    <a:solidFill>
-                      <a:srgbClr val="F8FAFC"/>
-                    </a:solidFill>
-                  </a:tcPr>
-                </a:tc>
-                <a:tc>
-                  <a:txBody>
-                    <a:bodyPr/>
-                    <a:lstStyle/>
-                    <a:p>
-                      <a:pPr>
-                        <a:defRPr sz="740" b="0">
-                          <a:solidFill>
-                            <a:srgbClr val="212529"/>
-                          </a:solidFill>
-                        </a:defRPr>
-                      </a:pPr>
-                      <a:r>
-                        <a:t>Dẫn đầu Equity (43,18đ) nhờ &gt;60% nhân sự nữ &amp; DE&amp;I.</a:t>
-                      </a:r>
-                    </a:p>
-                  </a:txBody>
-                  <a:tcPr>
-                    <a:solidFill>
-                      <a:srgbClr val="F8FAFC"/>
-                    </a:solidFill>
-                  </a:tcPr>
-                </a:tc>
-              </a:tr>
-              <a:tr h="386080">
-                <a:tc>
-                  <a:txBody>
-                    <a:bodyPr/>
-                    <a:lstStyle/>
-                    <a:p>
-                      <a:pPr>
-                        <a:defRPr sz="780" b="1">
-                          <a:solidFill>
-                            <a:srgbClr val="1B365D"/>
-                          </a:solidFill>
-                        </a:defRPr>
-                      </a:pPr>
-                      <a:r>
-                        <a:t>Bảo Việt (BVH - Bảo hiểm &amp; Tài chính)</a:t>
-                      </a:r>
-                    </a:p>
-                  </a:txBody>
-                  <a:tcPr>
-                    <a:solidFill>
-                      <a:srgbClr val="FFFFFF"/>
-                    </a:solidFill>
-                  </a:tcPr>
-                </a:tc>
-                <a:tc>
-                  <a:txBody>
-                    <a:bodyPr/>
-                    <a:lstStyle/>
-                    <a:p>
-                      <a:pPr algn="ctr">
-                        <a:defRPr sz="780" b="0">
-                          <a:solidFill>
-                            <a:srgbClr val="212529"/>
-                          </a:solidFill>
-                        </a:defRPr>
-                      </a:pPr>
-                      <a:r>
-                        <a:t>46.34</a:t>
-                      </a:r>
-                    </a:p>
-                  </a:txBody>
-                  <a:tcPr>
-                    <a:solidFill>
-                      <a:srgbClr val="FFFFFF"/>
-                    </a:solidFill>
-                  </a:tcPr>
-                </a:tc>
-                <a:tc>
-                  <a:txBody>
-                    <a:bodyPr/>
-                    <a:lstStyle/>
-                    <a:p>
-                      <a:pPr algn="ctr">
-                        <a:defRPr sz="780" b="1">
-                          <a:solidFill>
-                            <a:srgbClr val="1B365D"/>
-                          </a:solidFill>
-                        </a:defRPr>
-                      </a:pPr>
-                      <a:r>
-                        <a:t>49.36</a:t>
-                      </a:r>
-                    </a:p>
-                  </a:txBody>
-                  <a:tcPr>
-                    <a:solidFill>
-                      <a:srgbClr val="FFFFFF"/>
-                    </a:solidFill>
-                  </a:tcPr>
-                </a:tc>
-                <a:tc>
-                  <a:txBody>
-                    <a:bodyPr/>
-                    <a:lstStyle/>
-                    <a:p>
-                      <a:pPr algn="ctr">
-                        <a:defRPr sz="780" b="0">
-                          <a:solidFill>
-                            <a:srgbClr val="D4AF37"/>
-                          </a:solidFill>
-                        </a:defRPr>
-                      </a:pPr>
-                      <a:r>
-                        <a:t>43.05</a:t>
-                      </a:r>
-                    </a:p>
-                  </a:txBody>
-                  <a:tcPr>
-                    <a:solidFill>
-                      <a:srgbClr val="FFFFFF"/>
-                    </a:solidFill>
-                  </a:tcPr>
-                </a:tc>
-                <a:tc>
-                  <a:txBody>
-                    <a:bodyPr/>
-                    <a:lstStyle/>
-                    <a:p>
-                      <a:pPr algn="ctr">
-                        <a:defRPr sz="780" b="0">
-                          <a:solidFill>
-                            <a:srgbClr val="212529"/>
-                          </a:solidFill>
-                        </a:defRPr>
-                      </a:pPr>
-                      <a:r>
-                        <a:t>48.13</a:t>
-                      </a:r>
-                    </a:p>
-                  </a:txBody>
-                  <a:tcPr>
-                    <a:solidFill>
-                      <a:srgbClr val="FFFFFF"/>
-                    </a:solidFill>
-                  </a:tcPr>
-                </a:tc>
-                <a:tc>
-                  <a:txBody>
-                    <a:bodyPr/>
-                    <a:lstStyle/>
-                    <a:p>
-                      <a:pPr algn="ctr">
-                        <a:defRPr sz="780" b="0">
-                          <a:solidFill>
-                            <a:srgbClr val="212529"/>
-                          </a:solidFill>
-                        </a:defRPr>
-                      </a:pPr>
-                      <a:r>
-                        <a:t>46.40</a:t>
-                      </a:r>
-                    </a:p>
-                  </a:txBody>
-                  <a:tcPr>
-                    <a:solidFill>
-                      <a:srgbClr val="FFFFFF"/>
-                    </a:solidFill>
-                  </a:tcPr>
-                </a:tc>
-                <a:tc>
-                  <a:txBody>
-                    <a:bodyPr/>
-                    <a:lstStyle/>
-                    <a:p>
-                      <a:pPr algn="ctr">
-                        <a:defRPr sz="780" b="0">
-                          <a:solidFill>
-                            <a:srgbClr val="212529"/>
-                          </a:solidFill>
-                        </a:defRPr>
-                      </a:pPr>
-                      <a:r>
-                        <a:t>46.08</a:t>
-                      </a:r>
-                    </a:p>
-                  </a:txBody>
-                  <a:tcPr>
-                    <a:solidFill>
-                      <a:srgbClr val="FFFFFF"/>
-                    </a:solidFill>
-                  </a:tcPr>
-                </a:tc>
-                <a:tc>
-                  <a:txBody>
-                    <a:bodyPr/>
-                    <a:lstStyle/>
-                    <a:p>
-                      <a:pPr>
-                        <a:defRPr sz="740" b="0">
-                          <a:solidFill>
-                            <a:srgbClr val="212529"/>
-                          </a:solidFill>
-                        </a:defRPr>
-                      </a:pPr>
-                      <a:r>
-                        <a:t>Tiên phong Báo cáo Tích hợp IIRC, bảo hiểm vi mô.</a:t>
-                      </a:r>
-                    </a:p>
-                  </a:txBody>
-                  <a:tcPr>
-                    <a:solidFill>
-                      <a:srgbClr val="FFFFFF"/>
-                    </a:solidFill>
-                  </a:tcPr>
-                </a:tc>
-              </a:tr>
-              <a:tr h="386080">
-                <a:tc>
-                  <a:txBody>
-                    <a:bodyPr/>
-                    <a:lstStyle/>
-                    <a:p>
-                      <a:pPr>
-                        <a:defRPr sz="780" b="1">
-                          <a:solidFill>
-                            <a:srgbClr val="1B365D"/>
-                          </a:solidFill>
-                        </a:defRPr>
-                      </a:pPr>
-                      <a:r>
-                        <a:t>The PAN Group (PAN - Nông nghiệp)</a:t>
-                      </a:r>
-                    </a:p>
-                  </a:txBody>
-                  <a:tcPr>
-                    <a:solidFill>
-                      <a:srgbClr val="F8FAFC"/>
-                    </a:solidFill>
-                  </a:tcPr>
-                </a:tc>
-                <a:tc>
-                  <a:txBody>
-                    <a:bodyPr/>
-                    <a:lstStyle/>
-                    <a:p>
-                      <a:pPr algn="ctr">
-                        <a:defRPr sz="780" b="0">
-                          <a:solidFill>
-                            <a:srgbClr val="212529"/>
-                          </a:solidFill>
-                        </a:defRPr>
-                      </a:pPr>
-                      <a:r>
-                        <a:t>44.81</a:t>
-                      </a:r>
-                    </a:p>
-                  </a:txBody>
-                  <a:tcPr>
-                    <a:solidFill>
-                      <a:srgbClr val="F8FAFC"/>
-                    </a:solidFill>
-                  </a:tcPr>
-                </a:tc>
-                <a:tc>
-                  <a:txBody>
-                    <a:bodyPr/>
-                    <a:lstStyle/>
-                    <a:p>
-                      <a:pPr algn="ctr">
-                        <a:defRPr sz="780" b="1">
-                          <a:solidFill>
-                            <a:srgbClr val="1B365D"/>
-                          </a:solidFill>
-                        </a:defRPr>
-                      </a:pPr>
-                      <a:r>
-                        <a:t>47.29</a:t>
-                      </a:r>
-                    </a:p>
-                  </a:txBody>
-                  <a:tcPr>
-                    <a:solidFill>
-                      <a:srgbClr val="F8FAFC"/>
-                    </a:solidFill>
-                  </a:tcPr>
-                </a:tc>
-                <a:tc>
-                  <a:txBody>
-                    <a:bodyPr/>
-                    <a:lstStyle/>
-                    <a:p>
-                      <a:pPr algn="ctr">
-                        <a:defRPr sz="780" b="0">
-                          <a:solidFill>
-                            <a:srgbClr val="D4AF37"/>
-                          </a:solidFill>
-                        </a:defRPr>
-                      </a:pPr>
-                      <a:r>
-                        <a:t>41.91</a:t>
-                      </a:r>
-                    </a:p>
-                  </a:txBody>
-                  <a:tcPr>
-                    <a:solidFill>
-                      <a:srgbClr val="F8FAFC"/>
-                    </a:solidFill>
-                  </a:tcPr>
-                </a:tc>
-                <a:tc>
-                  <a:txBody>
-                    <a:bodyPr/>
-                    <a:lstStyle/>
-                    <a:p>
-                      <a:pPr algn="ctr">
-                        <a:defRPr sz="780" b="0">
-                          <a:solidFill>
-                            <a:srgbClr val="212529"/>
-                          </a:solidFill>
-                        </a:defRPr>
-                      </a:pPr>
-                      <a:r>
-                        <a:t>45.51</a:t>
-                      </a:r>
-                    </a:p>
-                  </a:txBody>
-                  <a:tcPr>
-                    <a:solidFill>
-                      <a:srgbClr val="F8FAFC"/>
-                    </a:solidFill>
-                  </a:tcPr>
-                </a:tc>
-                <a:tc>
-                  <a:txBody>
-                    <a:bodyPr/>
-                    <a:lstStyle/>
-                    <a:p>
-                      <a:pPr algn="ctr">
-                        <a:defRPr sz="780" b="0">
-                          <a:solidFill>
-                            <a:srgbClr val="212529"/>
-                          </a:solidFill>
-                        </a:defRPr>
-                      </a:pPr>
-                      <a:r>
-                        <a:t>45.07</a:t>
-                      </a:r>
-                    </a:p>
-                  </a:txBody>
-                  <a:tcPr>
-                    <a:solidFill>
-                      <a:srgbClr val="F8FAFC"/>
-                    </a:solidFill>
-                  </a:tcPr>
-                </a:tc>
-                <a:tc>
-                  <a:txBody>
-                    <a:bodyPr/>
-                    <a:lstStyle/>
-                    <a:p>
-                      <a:pPr algn="ctr">
-                        <a:defRPr sz="780" b="0">
-                          <a:solidFill>
-                            <a:srgbClr val="212529"/>
-                          </a:solidFill>
-                        </a:defRPr>
-                      </a:pPr>
-                      <a:r>
-                        <a:t>44.67</a:t>
-                      </a:r>
-                    </a:p>
-                  </a:txBody>
-                  <a:tcPr>
-                    <a:solidFill>
-                      <a:srgbClr val="F8FAFC"/>
-                    </a:solidFill>
-                  </a:tcPr>
-                </a:tc>
-                <a:tc>
-                  <a:txBody>
-                    <a:bodyPr/>
-                    <a:lstStyle/>
-                    <a:p>
-                      <a:pPr>
-                        <a:defRPr sz="740" b="0">
-                          <a:solidFill>
-                            <a:srgbClr val="212529"/>
-                          </a:solidFill>
-                        </a:defRPr>
-                      </a:pPr>
-                      <a:r>
-                        <a:t>Chuỗi Farm-Food-Family, lúa gạo giảm phát thải (SDG 2).</a:t>
-                      </a:r>
-                    </a:p>
-                  </a:txBody>
-                  <a:tcPr>
-                    <a:solidFill>
-                      <a:srgbClr val="F8FAFC"/>
-                    </a:solidFill>
-                  </a:tcPr>
-                </a:tc>
-              </a:tr>
-              <a:tr h="386080">
-                <a:tc>
-                  <a:txBody>
-                    <a:bodyPr/>
-                    <a:lstStyle/>
-                    <a:p>
-                      <a:pPr>
-                        <a:defRPr sz="780" b="1">
-                          <a:solidFill>
-                            <a:srgbClr val="1B365D"/>
-                          </a:solidFill>
-                        </a:defRPr>
-                      </a:pPr>
-                      <a:r>
-                        <a:t>Petrolimex (PLX - Xăng dầu &amp; Năng lượng)</a:t>
-                      </a:r>
-                    </a:p>
-                  </a:txBody>
-                  <a:tcPr>
-                    <a:solidFill>
-                      <a:srgbClr val="FFFFFF"/>
-                    </a:solidFill>
-                  </a:tcPr>
-                </a:tc>
-                <a:tc>
-                  <a:txBody>
-                    <a:bodyPr/>
-                    <a:lstStyle/>
-                    <a:p>
-                      <a:pPr algn="ctr">
-                        <a:defRPr sz="780" b="0">
-                          <a:solidFill>
-                            <a:srgbClr val="212529"/>
-                          </a:solidFill>
-                        </a:defRPr>
-                      </a:pPr>
-                      <a:r>
-                        <a:t>42.14</a:t>
-                      </a:r>
-                    </a:p>
-                  </a:txBody>
-                  <a:tcPr>
-                    <a:solidFill>
-                      <a:srgbClr val="FFFFFF"/>
-                    </a:solidFill>
-                  </a:tcPr>
-                </a:tc>
-                <a:tc>
-                  <a:txBody>
-                    <a:bodyPr/>
-                    <a:lstStyle/>
-                    <a:p>
-                      <a:pPr algn="ctr">
-                        <a:defRPr sz="780" b="1">
-                          <a:solidFill>
-                            <a:srgbClr val="1B365D"/>
-                          </a:solidFill>
-                        </a:defRPr>
-                      </a:pPr>
-                      <a:r>
-                        <a:t>45.55</a:t>
-                      </a:r>
-                    </a:p>
-                  </a:txBody>
-                  <a:tcPr>
-                    <a:solidFill>
-                      <a:srgbClr val="FFFFFF"/>
-                    </a:solidFill>
-                  </a:tcPr>
-                </a:tc>
-                <a:tc>
-                  <a:txBody>
-                    <a:bodyPr/>
-                    <a:lstStyle/>
-                    <a:p>
-                      <a:pPr algn="ctr">
-                        <a:defRPr sz="780" b="0">
-                          <a:solidFill>
-                            <a:srgbClr val="D4AF37"/>
-                          </a:solidFill>
-                        </a:defRPr>
-                      </a:pPr>
-                      <a:r>
-                        <a:t>39.98</a:t>
-                      </a:r>
-                    </a:p>
-                  </a:txBody>
-                  <a:tcPr>
-                    <a:solidFill>
-                      <a:srgbClr val="FFFFFF"/>
-                    </a:solidFill>
-                  </a:tcPr>
-                </a:tc>
-                <a:tc>
-                  <a:txBody>
-                    <a:bodyPr/>
-                    <a:lstStyle/>
-                    <a:p>
-                      <a:pPr algn="ctr">
-                        <a:defRPr sz="780" b="0">
-                          <a:solidFill>
-                            <a:srgbClr val="212529"/>
-                          </a:solidFill>
-                        </a:defRPr>
-                      </a:pPr>
-                      <a:r>
-                        <a:t>44.42</a:t>
-                      </a:r>
-                    </a:p>
-                  </a:txBody>
-                  <a:tcPr>
-                    <a:solidFill>
-                      <a:srgbClr val="FFFFFF"/>
-                    </a:solidFill>
-                  </a:tcPr>
-                </a:tc>
-                <a:tc>
-                  <a:txBody>
-                    <a:bodyPr/>
-                    <a:lstStyle/>
-                    <a:p>
-                      <a:pPr algn="ctr">
-                        <a:defRPr sz="780" b="0">
-                          <a:solidFill>
-                            <a:srgbClr val="212529"/>
-                          </a:solidFill>
-                        </a:defRPr>
-                      </a:pPr>
-                      <a:r>
-                        <a:t>44.22</a:t>
-                      </a:r>
-                    </a:p>
-                  </a:txBody>
-                  <a:tcPr>
-                    <a:solidFill>
-                      <a:srgbClr val="FFFFFF"/>
-                    </a:solidFill>
-                  </a:tcPr>
-                </a:tc>
-                <a:tc>
-                  <a:txBody>
-                    <a:bodyPr/>
-                    <a:lstStyle/>
-                    <a:p>
-                      <a:pPr algn="ctr">
-                        <a:defRPr sz="780" b="0">
-                          <a:solidFill>
-                            <a:srgbClr val="212529"/>
-                          </a:solidFill>
-                        </a:defRPr>
-                      </a:pPr>
-                      <a:r>
-                        <a:t>43.72</a:t>
-                      </a:r>
-                    </a:p>
-                  </a:txBody>
-                  <a:tcPr>
-                    <a:solidFill>
-                      <a:srgbClr val="FFFFFF"/>
-                    </a:solidFill>
-                  </a:tcPr>
-                </a:tc>
-                <a:tc>
-                  <a:txBody>
-                    <a:bodyPr/>
-                    <a:lstStyle/>
-                    <a:p>
-                      <a:pPr>
-                        <a:defRPr sz="740" b="0">
-                          <a:solidFill>
-                            <a:srgbClr val="212529"/>
-                          </a:solidFill>
-                        </a:defRPr>
-                      </a:pPr>
-                      <a:r>
-                        <a:t>Hạ tầng xăng dầu Euro 5, kiểm kê phát thải ISO 14064.</a:t>
-                      </a:r>
-                    </a:p>
-                  </a:txBody>
-                  <a:tcPr>
-                    <a:solidFill>
-                      <a:srgbClr val="FFFFFF"/>
-                    </a:solidFill>
-                  </a:tcPr>
-                </a:tc>
-              </a:tr>
-              <a:tr h="386080">
-                <a:tc>
-                  <a:txBody>
-                    <a:bodyPr/>
-                    <a:lstStyle/>
-                    <a:p>
-                      <a:pPr>
-                        <a:defRPr sz="780" b="1">
-                          <a:solidFill>
-                            <a:srgbClr val="1B365D"/>
-                          </a:solidFill>
-                        </a:defRPr>
-                      </a:pPr>
-                      <a:r>
-                        <a:t>Chứng khoán SSI (SSI - Dịch vụ Tài chính)</a:t>
-                      </a:r>
-                    </a:p>
-                  </a:txBody>
-                  <a:tcPr>
-                    <a:solidFill>
-                      <a:srgbClr val="F8FAFC"/>
-                    </a:solidFill>
-                  </a:tcPr>
-                </a:tc>
-                <a:tc>
-                  <a:txBody>
-                    <a:bodyPr/>
-                    <a:lstStyle/>
-                    <a:p>
-                      <a:pPr algn="ctr">
-                        <a:defRPr sz="780" b="0">
-                          <a:solidFill>
-                            <a:srgbClr val="212529"/>
-                          </a:solidFill>
-                        </a:defRPr>
-                      </a:pPr>
-                      <a:r>
-                        <a:t>43.52</a:t>
-                      </a:r>
-                    </a:p>
-                  </a:txBody>
-                  <a:tcPr>
-                    <a:solidFill>
-                      <a:srgbClr val="F8FAFC"/>
-                    </a:solidFill>
-                  </a:tcPr>
-                </a:tc>
-                <a:tc>
-                  <a:txBody>
-                    <a:bodyPr/>
-                    <a:lstStyle/>
-                    <a:p>
-                      <a:pPr algn="ctr">
-                        <a:defRPr sz="780" b="1">
-                          <a:solidFill>
-                            <a:srgbClr val="1B365D"/>
-                          </a:solidFill>
-                        </a:defRPr>
-                      </a:pPr>
-                      <a:r>
-                        <a:t>47.20</a:t>
-                      </a:r>
-                    </a:p>
-                  </a:txBody>
-                  <a:tcPr>
-                    <a:solidFill>
-                      <a:srgbClr val="F8FAFC"/>
-                    </a:solidFill>
-                  </a:tcPr>
-                </a:tc>
-                <a:tc>
-                  <a:txBody>
-                    <a:bodyPr/>
-                    <a:lstStyle/>
-                    <a:p>
-                      <a:pPr algn="ctr">
-                        <a:defRPr sz="780" b="0">
-                          <a:solidFill>
-                            <a:srgbClr val="D4AF37"/>
-                          </a:solidFill>
-                        </a:defRPr>
-                      </a:pPr>
-                      <a:r>
-                        <a:t>41.99</a:t>
-                      </a:r>
-                    </a:p>
-                  </a:txBody>
-                  <a:tcPr>
-                    <a:solidFill>
-                      <a:srgbClr val="F8FAFC"/>
-                    </a:solidFill>
-                  </a:tcPr>
-                </a:tc>
-                <a:tc>
-                  <a:txBody>
-                    <a:bodyPr/>
-                    <a:lstStyle/>
-                    <a:p>
-                      <a:pPr algn="ctr">
-                        <a:defRPr sz="780" b="0">
-                          <a:solidFill>
-                            <a:srgbClr val="212529"/>
-                          </a:solidFill>
-                        </a:defRPr>
-                      </a:pPr>
-                      <a:r>
-                        <a:t>46.33</a:t>
-                      </a:r>
-                    </a:p>
-                  </a:txBody>
-                  <a:tcPr>
-                    <a:solidFill>
-                      <a:srgbClr val="F8FAFC"/>
-                    </a:solidFill>
-                  </a:tcPr>
-                </a:tc>
-                <a:tc>
-                  <a:txBody>
-                    <a:bodyPr/>
-                    <a:lstStyle/>
-                    <a:p>
-                      <a:pPr algn="ctr">
-                        <a:defRPr sz="780" b="0">
-                          <a:solidFill>
-                            <a:srgbClr val="212529"/>
-                          </a:solidFill>
-                        </a:defRPr>
-                      </a:pPr>
-                      <a:r>
-                        <a:t>44.10</a:t>
-                      </a:r>
-                    </a:p>
-                  </a:txBody>
-                  <a:tcPr>
-                    <a:solidFill>
-                      <a:srgbClr val="F8FAFC"/>
-                    </a:solidFill>
-                  </a:tcPr>
-                </a:tc>
-                <a:tc>
-                  <a:txBody>
-                    <a:bodyPr/>
-                    <a:lstStyle/>
-                    <a:p>
-                      <a:pPr algn="ctr">
-                        <a:defRPr sz="780" b="0">
-                          <a:solidFill>
-                            <a:srgbClr val="212529"/>
-                          </a:solidFill>
-                        </a:defRPr>
-                      </a:pPr>
-                      <a:r>
-                        <a:t>43.71</a:t>
-                      </a:r>
-                    </a:p>
-                  </a:txBody>
-                  <a:tcPr>
-                    <a:solidFill>
-                      <a:srgbClr val="F8FAFC"/>
-                    </a:solidFill>
-                  </a:tcPr>
-                </a:tc>
-                <a:tc>
-                  <a:txBody>
-                    <a:bodyPr/>
-                    <a:lstStyle/>
-                    <a:p>
-                      <a:pPr>
-                        <a:defRPr sz="740" b="0">
-                          <a:solidFill>
-                            <a:srgbClr val="212529"/>
-                          </a:solidFill>
-                        </a:defRPr>
-                      </a:pPr>
-                      <a:r>
-                        <a:t>Thu xếp vốn trái phiếu xanh, quản trị thẻ điểm ASEAN.</a:t>
-                      </a:r>
-                    </a:p>
-                  </a:txBody>
-                  <a:tcPr>
-                    <a:solidFill>
-                      <a:srgbClr val="F8FAFC"/>
-                    </a:solidFill>
-                  </a:tcPr>
-                </a:tc>
-              </a:tr>
-              <a:tr h="386080">
-                <a:tc>
-                  <a:txBody>
-                    <a:bodyPr/>
-                    <a:lstStyle/>
-                    <a:p>
-                      <a:pPr>
-                        <a:defRPr sz="780" b="1">
-                          <a:solidFill>
-                            <a:srgbClr val="1F77B4"/>
-                          </a:solidFill>
-                        </a:defRPr>
-                      </a:pPr>
-                      <a:r>
-                        <a:t>★ TOÀN MẪU VIỆT NAM (TRUNG BÌNH)</a:t>
-                      </a:r>
-                    </a:p>
-                  </a:txBody>
-                  <a:tcPr>
-                    <a:solidFill>
-                      <a:srgbClr val="EAF3FF"/>
-                    </a:solidFill>
-                  </a:tcPr>
-                </a:tc>
-                <a:tc>
-                  <a:txBody>
-                    <a:bodyPr/>
-                    <a:lstStyle/>
-                    <a:p>
-                      <a:pPr algn="ctr">
-                        <a:defRPr sz="780" b="1">
-                          <a:solidFill>
-                            <a:srgbClr val="1B365D"/>
-                          </a:solidFill>
-                        </a:defRPr>
-                      </a:pPr>
-                      <a:r>
-                        <a:t>44.26</a:t>
-                      </a:r>
-                    </a:p>
-                  </a:txBody>
-                  <a:tcPr>
-                    <a:solidFill>
-                      <a:srgbClr val="EAF3FF"/>
-                    </a:solidFill>
-                  </a:tcPr>
-                </a:tc>
-                <a:tc>
-                  <a:txBody>
-                    <a:bodyPr/>
-                    <a:lstStyle/>
-                    <a:p>
-                      <a:pPr algn="ctr">
-                        <a:defRPr sz="780" b="1">
-                          <a:solidFill>
-                            <a:srgbClr val="1B365D"/>
-                          </a:solidFill>
-                        </a:defRPr>
-                      </a:pPr>
-                      <a:r>
-                        <a:t>47.69</a:t>
-                      </a:r>
-                    </a:p>
-                  </a:txBody>
-                  <a:tcPr>
-                    <a:solidFill>
-                      <a:srgbClr val="EAF3FF"/>
-                    </a:solidFill>
-                  </a:tcPr>
-                </a:tc>
-                <a:tc>
-                  <a:txBody>
-                    <a:bodyPr/>
-                    <a:lstStyle/>
-                    <a:p>
-                      <a:pPr algn="ctr">
-                        <a:defRPr sz="780" b="1">
-                          <a:solidFill>
-                            <a:srgbClr val="1B365D"/>
-                          </a:solidFill>
-                        </a:defRPr>
-                      </a:pPr>
-                      <a:r>
-                        <a:t>42.08</a:t>
-                      </a:r>
-                    </a:p>
-                  </a:txBody>
-                  <a:tcPr>
-                    <a:solidFill>
-                      <a:srgbClr val="EAF3FF"/>
-                    </a:solidFill>
-                  </a:tcPr>
-                </a:tc>
-                <a:tc>
-                  <a:txBody>
-                    <a:bodyPr/>
-                    <a:lstStyle/>
-                    <a:p>
-                      <a:pPr algn="ctr">
-                        <a:defRPr sz="780" b="1">
-                          <a:solidFill>
-                            <a:srgbClr val="1B365D"/>
-                          </a:solidFill>
-                        </a:defRPr>
-                      </a:pPr>
-                      <a:r>
-                        <a:t>46.39</a:t>
-                      </a:r>
-                    </a:p>
-                  </a:txBody>
-                  <a:tcPr>
-                    <a:solidFill>
-                      <a:srgbClr val="EAF3FF"/>
-                    </a:solidFill>
-                  </a:tcPr>
-                </a:tc>
-                <a:tc>
-                  <a:txBody>
-                    <a:bodyPr/>
-                    <a:lstStyle/>
-                    <a:p>
-                      <a:pPr algn="ctr">
-                        <a:defRPr sz="780" b="1">
-                          <a:solidFill>
-                            <a:srgbClr val="1B365D"/>
-                          </a:solidFill>
-                        </a:defRPr>
-                      </a:pPr>
-                      <a:r>
-                        <a:t>45.63</a:t>
-                      </a:r>
-                    </a:p>
-                  </a:txBody>
-                  <a:tcPr>
-                    <a:solidFill>
-                      <a:srgbClr val="EAF3FF"/>
-                    </a:solidFill>
-                  </a:tcPr>
-                </a:tc>
-                <a:tc>
-                  <a:txBody>
-                    <a:bodyPr/>
-                    <a:lstStyle/>
-                    <a:p>
-                      <a:pPr algn="ctr">
-                        <a:defRPr sz="780" b="1">
-                          <a:solidFill>
-                            <a:srgbClr val="1B365D"/>
-                          </a:solidFill>
-                        </a:defRPr>
-                      </a:pPr>
-                      <a:r>
-                        <a:t>44.98</a:t>
-                      </a:r>
-                    </a:p>
-                  </a:txBody>
-                  <a:tcPr>
-                    <a:solidFill>
-                      <a:srgbClr val="EAF3FF"/>
-                    </a:solidFill>
-                  </a:tcPr>
-                </a:tc>
-                <a:tc>
-                  <a:txBody>
-                    <a:bodyPr/>
-                    <a:lstStyle/>
-                    <a:p>
-                      <a:pPr>
-                        <a:defRPr sz="740" b="1">
-                          <a:solidFill>
-                            <a:srgbClr val="1B365D"/>
-                          </a:solidFill>
-                        </a:defRPr>
-                      </a:pPr>
-                      <a:r>
-                        <a:t>Quy luật toàn diện: Economic cao nhất, Equity thấp nhất.</a:t>
-                      </a:r>
-                    </a:p>
-                  </a:txBody>
-                  <a:tcPr>
-                    <a:solidFill>
-                      <a:srgbClr val="EAF3FF"/>
-                    </a:solidFill>
-                  </a:tcPr>
-                </a:tc>
-              </a:tr>
-            </a:tbl>
-          </a:graphicData>
-        </a:graphic>
-      </p:graphicFrame>
+      <p:pic>
+        <p:nvPicPr>
+          <p:cNvPr id="9" name="Picture 8" descr="slide_company_6cat_bar.png"/>
+          <p:cNvPicPr>
+            <a:picLocks noChangeAspect="1"/>
+          </p:cNvPicPr>
+          <p:nvPr/>
+        </p:nvPicPr>
+        <p:blipFill>
+          <a:blip r:embed="rId2"/>
+          <a:stretch>
+            <a:fillRect/>
+          </a:stretch>
+        </p:blipFill>
+        <p:spPr>
+          <a:xfrm>
+            <a:off x="731520" y="1115568"/>
+            <a:ext cx="10728655" cy="3749039"/>
+          </a:xfrm>
+          <a:prstGeom prst="rect">
+            <a:avLst/>
+          </a:prstGeom>
+        </p:spPr>
+      </p:pic>
       <p:sp>
         <p:nvSpPr>
           <p:cNvPr id="10" name="Rounded Rectangle 9"/>
@@ -21301,8 +19595,8 @@
         </p:nvSpPr>
         <p:spPr>
           <a:xfrm>
-            <a:off x="731520" y="4846320"/>
-            <a:ext cx="3429000" cy="1508760"/>
+            <a:off x="731520" y="4956048"/>
+            <a:ext cx="3429000" cy="1417320"/>
           </a:xfrm>
           <a:prstGeom prst="roundRect">
             <a:avLst/>
@@ -21346,8 +19640,8 @@
         </p:nvSpPr>
         <p:spPr>
           <a:xfrm>
-            <a:off x="841248" y="4901184"/>
-            <a:ext cx="3209544" cy="1371600"/>
+            <a:off x="841248" y="5010912"/>
+            <a:ext cx="3209544" cy="1280160"/>
           </a:xfrm>
           <a:prstGeom prst="rect">
             <a:avLst/>
@@ -21382,7 +19676,7 @@
                   <a:srgbClr val="212529"/>
                 </a:solidFill>
               </a:rPr>
-              <a:t>• Nhóm Economic (47,69đ) luôn cao nhất ở 100% doanh nghiệp (đỉnh tại VCS 50,71đ và BVH 49,36đ) vì việc làm và tăng trưởng là lẽ sống còn.</a:t>
+              <a:t>• Cột Economic (Xanh dương, 47,69đ) luôn cao nhất ở 100% doanh nghiệp (đỉnh tại VCS 50,71đ và BVH 49,36đ) vì tăng trưởng kinh tế là mục tiêu sống còn.</a:t>
             </a:r>
           </a:p>
           <a:p>
@@ -21397,7 +19691,7 @@
                   <a:srgbClr val="212529"/>
                 </a:solidFill>
               </a:rPr>
-              <a:t>• Nhóm Equity (42,08đ) luôn thấp nhất toàn mẫu do doanh nghiệp né tránh công bố chênh lệch thu nhập và bình đẳng giới.</a:t>
+              <a:t>• Cột Equity (Tím, 42,08đ) luôn thấp nhất toàn mẫu do doanh nghiệp né tránh công bố chênh lệch thu nhập và bình đẳng giới cấp cao.</a:t>
             </a:r>
           </a:p>
         </p:txBody>
@@ -21410,8 +19704,8 @@
         </p:nvSpPr>
         <p:spPr>
           <a:xfrm>
-            <a:off x="4379976" y="4846320"/>
-            <a:ext cx="3429000" cy="1508760"/>
+            <a:off x="4379976" y="4956048"/>
+            <a:ext cx="3429000" cy="1417320"/>
           </a:xfrm>
           <a:prstGeom prst="roundRect">
             <a:avLst/>
@@ -21455,8 +19749,8 @@
         </p:nvSpPr>
         <p:spPr>
           <a:xfrm>
-            <a:off x="4489704" y="4901184"/>
-            <a:ext cx="3209544" cy="1371600"/>
+            <a:off x="4489704" y="5010912"/>
+            <a:ext cx="3209544" cy="1280160"/>
           </a:xfrm>
           <a:prstGeom prst="rect">
             <a:avLst/>
@@ -21519,8 +19813,8 @@
         </p:nvSpPr>
         <p:spPr>
           <a:xfrm>
-            <a:off x="8028432" y="4846320"/>
-            <a:ext cx="3429000" cy="1508760"/>
+            <a:off x="8028432" y="4956048"/>
+            <a:ext cx="3429000" cy="1417320"/>
           </a:xfrm>
           <a:prstGeom prst="roundRect">
             <a:avLst/>
@@ -21564,8 +19858,8 @@
         </p:nvSpPr>
         <p:spPr>
           <a:xfrm>
-            <a:off x="8138160" y="4901184"/>
-            <a:ext cx="3209544" cy="1371600"/>
+            <a:off x="8138160" y="5010912"/>
+            <a:ext cx="3209544" cy="1280160"/>
           </a:xfrm>
           <a:prstGeom prst="rect">
             <a:avLst/>

</xml_diff>